<commit_message>
Fix duplicate panel and box overflow in Project Record deck
Slide 7: loop was iterating over all 9 compliance items then the 9th
was drawn a second time by the centred block, creating two overlapping
notification bell panels. Fixed loop to compliance_2[:8], reduced ph3
to 1.12 so the centred 9th item clears the footer, and corrected cx9
to be truly centred on the slide.

Slide 11: both Row 1 boxes were 2.35" tall but contained 0.8" header
plus 6 rows × 0.36" = 2.96" of content — overflowing by ~0.6". Increased
box height to 3.1", pushed Row 2 down to y=4.42, tightened row_h to
0.33 and shortened the vite 'Why' value so it fits on one line.

Co-Authored-By: Claude Sonnet 4.6 <noreply@anthropic.com>
Claude-Session: https://claude.ai/code/session_012EFETGbhdxdnPCjpmQ9UDz
</commit_message>
<xml_diff>
--- a/Santander_Project_Record.pptx
+++ b/Santander_Project_Record.pptx
@@ -9941,7 +9941,7 @@
         <p:spPr>
           <a:xfrm>
             <a:off x="384048" y="1024128"/>
-            <a:ext cx="7132320" cy="2148840"/>
+            <a:ext cx="7132320" cy="2834640"/>
           </a:xfrm>
           <a:prstGeom prst="rect">
             <a:avLst/>
@@ -10098,8 +10098,8 @@
         </p:nvSpPr>
         <p:spPr>
           <a:xfrm>
-            <a:off x="566928" y="1755648"/>
-            <a:ext cx="6858000" cy="329184"/>
+            <a:off x="566928" y="1783080"/>
+            <a:ext cx="6858000" cy="301752"/>
           </a:xfrm>
           <a:prstGeom prst="rect">
             <a:avLst/>
@@ -10143,8 +10143,8 @@
         </p:nvSpPr>
         <p:spPr>
           <a:xfrm>
-            <a:off x="676656" y="1810512"/>
-            <a:ext cx="1417320" cy="256031"/>
+            <a:off x="676656" y="1837943"/>
+            <a:ext cx="1417320" cy="228600"/>
           </a:xfrm>
           <a:prstGeom prst="rect">
             <a:avLst/>
@@ -10178,8 +10178,8 @@
         </p:nvSpPr>
         <p:spPr>
           <a:xfrm>
-            <a:off x="2212848" y="1810512"/>
-            <a:ext cx="5166359" cy="256031"/>
+            <a:off x="2212848" y="1837943"/>
+            <a:ext cx="5166359" cy="228600"/>
           </a:xfrm>
           <a:prstGeom prst="rect">
             <a:avLst/>
@@ -10214,7 +10214,7 @@
         <p:spPr>
           <a:xfrm>
             <a:off x="566928" y="2084831"/>
-            <a:ext cx="6858000" cy="329184"/>
+            <a:ext cx="6858000" cy="301752"/>
           </a:xfrm>
           <a:prstGeom prst="rect">
             <a:avLst/>
@@ -10259,7 +10259,7 @@
         <p:spPr>
           <a:xfrm>
             <a:off x="676656" y="2139696"/>
-            <a:ext cx="1417320" cy="256031"/>
+            <a:ext cx="1417320" cy="228600"/>
           </a:xfrm>
           <a:prstGeom prst="rect">
             <a:avLst/>
@@ -10294,7 +10294,7 @@
         <p:spPr>
           <a:xfrm>
             <a:off x="2212848" y="2139696"/>
-            <a:ext cx="5166359" cy="256031"/>
+            <a:ext cx="5166359" cy="228600"/>
           </a:xfrm>
           <a:prstGeom prst="rect">
             <a:avLst/>
@@ -10328,8 +10328,8 @@
         </p:nvSpPr>
         <p:spPr>
           <a:xfrm>
-            <a:off x="566928" y="2414015"/>
-            <a:ext cx="6858000" cy="329184"/>
+            <a:off x="566928" y="2386584"/>
+            <a:ext cx="6858000" cy="301752"/>
           </a:xfrm>
           <a:prstGeom prst="rect">
             <a:avLst/>
@@ -10373,8 +10373,8 @@
         </p:nvSpPr>
         <p:spPr>
           <a:xfrm>
-            <a:off x="676656" y="2468879"/>
-            <a:ext cx="1417320" cy="256031"/>
+            <a:off x="676656" y="2441448"/>
+            <a:ext cx="1417320" cy="228600"/>
           </a:xfrm>
           <a:prstGeom prst="rect">
             <a:avLst/>
@@ -10408,8 +10408,8 @@
         </p:nvSpPr>
         <p:spPr>
           <a:xfrm>
-            <a:off x="2212848" y="2468879"/>
-            <a:ext cx="5166359" cy="256031"/>
+            <a:off x="2212848" y="2441448"/>
+            <a:ext cx="5166359" cy="228600"/>
           </a:xfrm>
           <a:prstGeom prst="rect">
             <a:avLst/>
@@ -10430,7 +10430,7 @@
                 </a:solidFill>
                 <a:latin typeface="Calibri"/>
               </a:rPr>
-              <a:t>Vite 5 + vite-plugin-singlefile → all JS/CSS/fonts inlined</a:t>
+              <a:t>Vite 5 + vite-plugin-singlefile — all JS/CSS/fonts inlined</a:t>
             </a:r>
           </a:p>
         </p:txBody>
@@ -10443,8 +10443,8 @@
         </p:nvSpPr>
         <p:spPr>
           <a:xfrm>
-            <a:off x="566928" y="2743200"/>
-            <a:ext cx="6858000" cy="329184"/>
+            <a:off x="566928" y="2688336"/>
+            <a:ext cx="6858000" cy="301752"/>
           </a:xfrm>
           <a:prstGeom prst="rect">
             <a:avLst/>
@@ -10488,8 +10488,8 @@
         </p:nvSpPr>
         <p:spPr>
           <a:xfrm>
-            <a:off x="676656" y="2798064"/>
-            <a:ext cx="1417320" cy="256031"/>
+            <a:off x="676656" y="2743200"/>
+            <a:ext cx="1417320" cy="228600"/>
           </a:xfrm>
           <a:prstGeom prst="rect">
             <a:avLst/>
@@ -10523,8 +10523,8 @@
         </p:nvSpPr>
         <p:spPr>
           <a:xfrm>
-            <a:off x="2212848" y="2798064"/>
-            <a:ext cx="5166359" cy="256031"/>
+            <a:off x="2212848" y="2743200"/>
+            <a:ext cx="5166359" cy="228600"/>
           </a:xfrm>
           <a:prstGeom prst="rect">
             <a:avLst/>
@@ -10558,8 +10558,8 @@
         </p:nvSpPr>
         <p:spPr>
           <a:xfrm>
-            <a:off x="566928" y="3072384"/>
-            <a:ext cx="6858000" cy="329184"/>
+            <a:off x="566928" y="2990088"/>
+            <a:ext cx="6858000" cy="301752"/>
           </a:xfrm>
           <a:prstGeom prst="rect">
             <a:avLst/>
@@ -10603,8 +10603,8 @@
         </p:nvSpPr>
         <p:spPr>
           <a:xfrm>
-            <a:off x="676656" y="3127248"/>
-            <a:ext cx="1417320" cy="256031"/>
+            <a:off x="676656" y="3044952"/>
+            <a:ext cx="1417320" cy="228600"/>
           </a:xfrm>
           <a:prstGeom prst="rect">
             <a:avLst/>
@@ -10638,8 +10638,8 @@
         </p:nvSpPr>
         <p:spPr>
           <a:xfrm>
-            <a:off x="2212848" y="3127248"/>
-            <a:ext cx="5166359" cy="256031"/>
+            <a:off x="2212848" y="3044952"/>
+            <a:ext cx="5166359" cy="228600"/>
           </a:xfrm>
           <a:prstGeom prst="rect">
             <a:avLst/>
@@ -10660,7 +10660,7 @@
                 </a:solidFill>
                 <a:latin typeface="Calibri"/>
               </a:rPr>
-              <a:t>DOMContentLoaded listener — vite-plugin-singlefile inlines JS into &lt;head&gt; as plain &lt;script&gt; (no defer)</a:t>
+              <a:t>DOMContentLoaded listener — singlefile inlines JS into &lt;head&gt; as plain &lt;script&gt; (no defer)</a:t>
             </a:r>
           </a:p>
         </p:txBody>
@@ -10673,8 +10673,8 @@
         </p:nvSpPr>
         <p:spPr>
           <a:xfrm>
-            <a:off x="566928" y="3401568"/>
-            <a:ext cx="6858000" cy="329184"/>
+            <a:off x="566928" y="3291840"/>
+            <a:ext cx="6858000" cy="301752"/>
           </a:xfrm>
           <a:prstGeom prst="rect">
             <a:avLst/>
@@ -10718,8 +10718,8 @@
         </p:nvSpPr>
         <p:spPr>
           <a:xfrm>
-            <a:off x="676656" y="3456432"/>
-            <a:ext cx="1417320" cy="256031"/>
+            <a:off x="676656" y="3346704"/>
+            <a:ext cx="1417320" cy="228600"/>
           </a:xfrm>
           <a:prstGeom prst="rect">
             <a:avLst/>
@@ -10753,8 +10753,8 @@
         </p:nvSpPr>
         <p:spPr>
           <a:xfrm>
-            <a:off x="2212848" y="3456432"/>
-            <a:ext cx="5166359" cy="256031"/>
+            <a:off x="2212848" y="3346704"/>
+            <a:ext cx="5166359" cy="228600"/>
           </a:xfrm>
           <a:prstGeom prst="rect">
             <a:avLst/>
@@ -10789,7 +10789,7 @@
         <p:spPr>
           <a:xfrm>
             <a:off x="7699248" y="1024128"/>
-            <a:ext cx="4114800" cy="2148840"/>
+            <a:ext cx="4114800" cy="2834640"/>
           </a:xfrm>
           <a:prstGeom prst="rect">
             <a:avLst/>
@@ -10911,8 +10911,8 @@
         </p:nvSpPr>
         <p:spPr>
           <a:xfrm>
-            <a:off x="7882127" y="1408176"/>
-            <a:ext cx="3867912" cy="329184"/>
+            <a:off x="7882127" y="1435608"/>
+            <a:ext cx="3867912" cy="301752"/>
           </a:xfrm>
           <a:prstGeom prst="rect">
             <a:avLst/>
@@ -10956,8 +10956,8 @@
         </p:nvSpPr>
         <p:spPr>
           <a:xfrm>
-            <a:off x="7991855" y="1463040"/>
-            <a:ext cx="1097280" cy="256031"/>
+            <a:off x="7991855" y="1490472"/>
+            <a:ext cx="1143000" cy="228600"/>
           </a:xfrm>
           <a:prstGeom prst="rect">
             <a:avLst/>
@@ -10991,8 +10991,8 @@
         </p:nvSpPr>
         <p:spPr>
           <a:xfrm>
-            <a:off x="9208007" y="1463040"/>
-            <a:ext cx="2496312" cy="256031"/>
+            <a:off x="9253728" y="1490472"/>
+            <a:ext cx="2450592" cy="228600"/>
           </a:xfrm>
           <a:prstGeom prst="rect">
             <a:avLst/>
@@ -11027,7 +11027,7 @@
         <p:spPr>
           <a:xfrm>
             <a:off x="7882127" y="1737360"/>
-            <a:ext cx="3867912" cy="329184"/>
+            <a:ext cx="3867912" cy="301752"/>
           </a:xfrm>
           <a:prstGeom prst="rect">
             <a:avLst/>
@@ -11072,7 +11072,7 @@
         <p:spPr>
           <a:xfrm>
             <a:off x="7991855" y="1792224"/>
-            <a:ext cx="1097280" cy="256031"/>
+            <a:ext cx="1143000" cy="228600"/>
           </a:xfrm>
           <a:prstGeom prst="rect">
             <a:avLst/>
@@ -11106,8 +11106,8 @@
         </p:nvSpPr>
         <p:spPr>
           <a:xfrm>
-            <a:off x="9208007" y="1792224"/>
-            <a:ext cx="2496312" cy="256031"/>
+            <a:off x="9253728" y="1792224"/>
+            <a:ext cx="2450592" cy="228600"/>
           </a:xfrm>
           <a:prstGeom prst="rect">
             <a:avLst/>
@@ -11141,8 +11141,8 @@
         </p:nvSpPr>
         <p:spPr>
           <a:xfrm>
-            <a:off x="7882127" y="2066543"/>
-            <a:ext cx="3867912" cy="329184"/>
+            <a:off x="7882127" y="2039112"/>
+            <a:ext cx="3867912" cy="301752"/>
           </a:xfrm>
           <a:prstGeom prst="rect">
             <a:avLst/>
@@ -11186,8 +11186,8 @@
         </p:nvSpPr>
         <p:spPr>
           <a:xfrm>
-            <a:off x="7991855" y="2121408"/>
-            <a:ext cx="1097280" cy="256031"/>
+            <a:off x="7991855" y="2093976"/>
+            <a:ext cx="1143000" cy="228600"/>
           </a:xfrm>
           <a:prstGeom prst="rect">
             <a:avLst/>
@@ -11221,8 +11221,8 @@
         </p:nvSpPr>
         <p:spPr>
           <a:xfrm>
-            <a:off x="9208007" y="2121408"/>
-            <a:ext cx="2496312" cy="256031"/>
+            <a:off x="9253728" y="2093976"/>
+            <a:ext cx="2450592" cy="228600"/>
           </a:xfrm>
           <a:prstGeom prst="rect">
             <a:avLst/>
@@ -11256,8 +11256,8 @@
         </p:nvSpPr>
         <p:spPr>
           <a:xfrm>
-            <a:off x="7882127" y="2395728"/>
-            <a:ext cx="3867912" cy="329184"/>
+            <a:off x="7882127" y="2340864"/>
+            <a:ext cx="3867912" cy="301752"/>
           </a:xfrm>
           <a:prstGeom prst="rect">
             <a:avLst/>
@@ -11301,8 +11301,8 @@
         </p:nvSpPr>
         <p:spPr>
           <a:xfrm>
-            <a:off x="7991855" y="2450592"/>
-            <a:ext cx="1097280" cy="256031"/>
+            <a:off x="7991855" y="2395728"/>
+            <a:ext cx="1143000" cy="228600"/>
           </a:xfrm>
           <a:prstGeom prst="rect">
             <a:avLst/>
@@ -11336,8 +11336,8 @@
         </p:nvSpPr>
         <p:spPr>
           <a:xfrm>
-            <a:off x="9208007" y="2450592"/>
-            <a:ext cx="2496312" cy="256031"/>
+            <a:off x="9253728" y="2395728"/>
+            <a:ext cx="2450592" cy="228600"/>
           </a:xfrm>
           <a:prstGeom prst="rect">
             <a:avLst/>
@@ -11371,8 +11371,8 @@
         </p:nvSpPr>
         <p:spPr>
           <a:xfrm>
-            <a:off x="7882127" y="2724912"/>
-            <a:ext cx="3867912" cy="329184"/>
+            <a:off x="7882127" y="2642616"/>
+            <a:ext cx="3867912" cy="301752"/>
           </a:xfrm>
           <a:prstGeom prst="rect">
             <a:avLst/>
@@ -11416,8 +11416,8 @@
         </p:nvSpPr>
         <p:spPr>
           <a:xfrm>
-            <a:off x="7991855" y="2779776"/>
-            <a:ext cx="1097280" cy="256031"/>
+            <a:off x="7991855" y="2697480"/>
+            <a:ext cx="1143000" cy="228600"/>
           </a:xfrm>
           <a:prstGeom prst="rect">
             <a:avLst/>
@@ -11451,8 +11451,8 @@
         </p:nvSpPr>
         <p:spPr>
           <a:xfrm>
-            <a:off x="9208007" y="2779776"/>
-            <a:ext cx="2496312" cy="256031"/>
+            <a:off x="9253728" y="2697480"/>
+            <a:ext cx="2450592" cy="228600"/>
           </a:xfrm>
           <a:prstGeom prst="rect">
             <a:avLst/>
@@ -11486,8 +11486,8 @@
         </p:nvSpPr>
         <p:spPr>
           <a:xfrm>
-            <a:off x="7882127" y="3054096"/>
-            <a:ext cx="3867912" cy="329184"/>
+            <a:off x="7882127" y="2944368"/>
+            <a:ext cx="3867912" cy="301752"/>
           </a:xfrm>
           <a:prstGeom prst="rect">
             <a:avLst/>
@@ -11531,8 +11531,8 @@
         </p:nvSpPr>
         <p:spPr>
           <a:xfrm>
-            <a:off x="7991855" y="3108960"/>
-            <a:ext cx="1097280" cy="256031"/>
+            <a:off x="7991855" y="2999232"/>
+            <a:ext cx="1143000" cy="228600"/>
           </a:xfrm>
           <a:prstGeom prst="rect">
             <a:avLst/>
@@ -11566,8 +11566,8 @@
         </p:nvSpPr>
         <p:spPr>
           <a:xfrm>
-            <a:off x="9208007" y="3108960"/>
-            <a:ext cx="2496312" cy="256031"/>
+            <a:off x="9253728" y="2999232"/>
+            <a:ext cx="2450592" cy="228600"/>
           </a:xfrm>
           <a:prstGeom prst="rect">
             <a:avLst/>
@@ -11588,7 +11588,7 @@
                 </a:solidFill>
                 <a:latin typeface="Calibri"/>
               </a:rPr>
-              <a:t>Was stripping module type → exec order bug</a:t>
+              <a:t>Strips module type → script exec order bug</a:t>
             </a:r>
           </a:p>
         </p:txBody>
@@ -11601,8 +11601,8 @@
         </p:nvSpPr>
         <p:spPr>
           <a:xfrm>
-            <a:off x="384048" y="3337560"/>
-            <a:ext cx="5303520" cy="2377440"/>
+            <a:off x="384048" y="4041648"/>
+            <a:ext cx="5303520" cy="2359152"/>
           </a:xfrm>
           <a:prstGeom prst="rect">
             <a:avLst/>
@@ -11646,7 +11646,7 @@
         </p:nvSpPr>
         <p:spPr>
           <a:xfrm>
-            <a:off x="384048" y="3337560"/>
+            <a:off x="384048" y="4041648"/>
             <a:ext cx="5303520" cy="54864"/>
           </a:xfrm>
           <a:prstGeom prst="rect">
@@ -11689,7 +11689,7 @@
         </p:nvSpPr>
         <p:spPr>
           <a:xfrm>
-            <a:off x="566928" y="3429000"/>
+            <a:off x="566928" y="4133087"/>
             <a:ext cx="4937760" cy="274320"/>
           </a:xfrm>
           <a:prstGeom prst="rect">
@@ -11724,8 +11724,8 @@
         </p:nvSpPr>
         <p:spPr>
           <a:xfrm>
-            <a:off x="566928" y="3703320"/>
-            <a:ext cx="4937760" cy="283464"/>
+            <a:off x="566928" y="4425696"/>
+            <a:ext cx="4937760" cy="274320"/>
           </a:xfrm>
           <a:prstGeom prst="rect">
             <a:avLst/>
@@ -11769,8 +11769,8 @@
         </p:nvSpPr>
         <p:spPr>
           <a:xfrm>
-            <a:off x="658368" y="3749039"/>
-            <a:ext cx="1920240" cy="219456"/>
+            <a:off x="658368" y="4462272"/>
+            <a:ext cx="1920240" cy="210312"/>
           </a:xfrm>
           <a:prstGeom prst="rect">
             <a:avLst/>
@@ -11804,8 +11804,8 @@
         </p:nvSpPr>
         <p:spPr>
           <a:xfrm>
-            <a:off x="2606040" y="3749039"/>
-            <a:ext cx="2834640" cy="219456"/>
+            <a:off x="2606040" y="4462272"/>
+            <a:ext cx="2834640" cy="210312"/>
           </a:xfrm>
           <a:prstGeom prst="rect">
             <a:avLst/>
@@ -11839,8 +11839,8 @@
         </p:nvSpPr>
         <p:spPr>
           <a:xfrm>
-            <a:off x="566928" y="3986783"/>
-            <a:ext cx="4937760" cy="283464"/>
+            <a:off x="566928" y="4700016"/>
+            <a:ext cx="4937760" cy="274320"/>
           </a:xfrm>
           <a:prstGeom prst="rect">
             <a:avLst/>
@@ -11884,8 +11884,8 @@
         </p:nvSpPr>
         <p:spPr>
           <a:xfrm>
-            <a:off x="658368" y="4032503"/>
-            <a:ext cx="1920240" cy="219456"/>
+            <a:off x="658368" y="4736592"/>
+            <a:ext cx="1920240" cy="210312"/>
           </a:xfrm>
           <a:prstGeom prst="rect">
             <a:avLst/>
@@ -11919,8 +11919,8 @@
         </p:nvSpPr>
         <p:spPr>
           <a:xfrm>
-            <a:off x="2606040" y="4032503"/>
-            <a:ext cx="2834640" cy="219456"/>
+            <a:off x="2606040" y="4736592"/>
+            <a:ext cx="2834640" cy="210312"/>
           </a:xfrm>
           <a:prstGeom prst="rect">
             <a:avLst/>
@@ -11954,8 +11954,8 @@
         </p:nvSpPr>
         <p:spPr>
           <a:xfrm>
-            <a:off x="566928" y="4270248"/>
-            <a:ext cx="4937760" cy="283464"/>
+            <a:off x="566928" y="4974336"/>
+            <a:ext cx="4937760" cy="274320"/>
           </a:xfrm>
           <a:prstGeom prst="rect">
             <a:avLst/>
@@ -11999,8 +11999,8 @@
         </p:nvSpPr>
         <p:spPr>
           <a:xfrm>
-            <a:off x="658368" y="4315968"/>
-            <a:ext cx="1920240" cy="219456"/>
+            <a:off x="658368" y="5010912"/>
+            <a:ext cx="1920240" cy="210312"/>
           </a:xfrm>
           <a:prstGeom prst="rect">
             <a:avLst/>
@@ -12034,8 +12034,8 @@
         </p:nvSpPr>
         <p:spPr>
           <a:xfrm>
-            <a:off x="2606040" y="4315968"/>
-            <a:ext cx="2834640" cy="219456"/>
+            <a:off x="2606040" y="5010912"/>
+            <a:ext cx="2834640" cy="210312"/>
           </a:xfrm>
           <a:prstGeom prst="rect">
             <a:avLst/>
@@ -12069,8 +12069,8 @@
         </p:nvSpPr>
         <p:spPr>
           <a:xfrm>
-            <a:off x="566928" y="4553712"/>
-            <a:ext cx="4937760" cy="283464"/>
+            <a:off x="566928" y="5248656"/>
+            <a:ext cx="4937760" cy="274320"/>
           </a:xfrm>
           <a:prstGeom prst="rect">
             <a:avLst/>
@@ -12114,8 +12114,8 @@
         </p:nvSpPr>
         <p:spPr>
           <a:xfrm>
-            <a:off x="658368" y="4599431"/>
-            <a:ext cx="1920240" cy="219456"/>
+            <a:off x="658368" y="5285232"/>
+            <a:ext cx="1920240" cy="210312"/>
           </a:xfrm>
           <a:prstGeom prst="rect">
             <a:avLst/>
@@ -12149,8 +12149,8 @@
         </p:nvSpPr>
         <p:spPr>
           <a:xfrm>
-            <a:off x="2606040" y="4599431"/>
-            <a:ext cx="2834640" cy="219456"/>
+            <a:off x="2606040" y="5285232"/>
+            <a:ext cx="2834640" cy="210312"/>
           </a:xfrm>
           <a:prstGeom prst="rect">
             <a:avLst/>
@@ -12184,8 +12184,8 @@
         </p:nvSpPr>
         <p:spPr>
           <a:xfrm>
-            <a:off x="566928" y="4837176"/>
-            <a:ext cx="4937760" cy="283464"/>
+            <a:off x="566928" y="5522976"/>
+            <a:ext cx="4937760" cy="274320"/>
           </a:xfrm>
           <a:prstGeom prst="rect">
             <a:avLst/>
@@ -12229,8 +12229,8 @@
         </p:nvSpPr>
         <p:spPr>
           <a:xfrm>
-            <a:off x="658368" y="4882896"/>
-            <a:ext cx="1920240" cy="219456"/>
+            <a:off x="658368" y="5559552"/>
+            <a:ext cx="1920240" cy="210312"/>
           </a:xfrm>
           <a:prstGeom prst="rect">
             <a:avLst/>
@@ -12264,8 +12264,8 @@
         </p:nvSpPr>
         <p:spPr>
           <a:xfrm>
-            <a:off x="2606040" y="4882896"/>
-            <a:ext cx="2834640" cy="219456"/>
+            <a:off x="2606040" y="5559552"/>
+            <a:ext cx="2834640" cy="210312"/>
           </a:xfrm>
           <a:prstGeom prst="rect">
             <a:avLst/>
@@ -12299,8 +12299,8 @@
         </p:nvSpPr>
         <p:spPr>
           <a:xfrm>
-            <a:off x="566928" y="5120640"/>
-            <a:ext cx="4937760" cy="283464"/>
+            <a:off x="566928" y="5797296"/>
+            <a:ext cx="4937760" cy="274320"/>
           </a:xfrm>
           <a:prstGeom prst="rect">
             <a:avLst/>
@@ -12344,8 +12344,8 @@
         </p:nvSpPr>
         <p:spPr>
           <a:xfrm>
-            <a:off x="658368" y="5166359"/>
-            <a:ext cx="1920240" cy="219456"/>
+            <a:off x="658368" y="5833872"/>
+            <a:ext cx="1920240" cy="210312"/>
           </a:xfrm>
           <a:prstGeom prst="rect">
             <a:avLst/>
@@ -12379,8 +12379,8 @@
         </p:nvSpPr>
         <p:spPr>
           <a:xfrm>
-            <a:off x="2606040" y="5166359"/>
-            <a:ext cx="2834640" cy="219456"/>
+            <a:off x="2606040" y="5833872"/>
+            <a:ext cx="2834640" cy="210312"/>
           </a:xfrm>
           <a:prstGeom prst="rect">
             <a:avLst/>
@@ -12414,8 +12414,8 @@
         </p:nvSpPr>
         <p:spPr>
           <a:xfrm>
-            <a:off x="566928" y="5404104"/>
-            <a:ext cx="4937760" cy="283464"/>
+            <a:off x="566928" y="6071616"/>
+            <a:ext cx="4937760" cy="274320"/>
           </a:xfrm>
           <a:prstGeom prst="rect">
             <a:avLst/>
@@ -12459,8 +12459,8 @@
         </p:nvSpPr>
         <p:spPr>
           <a:xfrm>
-            <a:off x="658368" y="5449824"/>
-            <a:ext cx="1920240" cy="219456"/>
+            <a:off x="658368" y="6108192"/>
+            <a:ext cx="1920240" cy="210312"/>
           </a:xfrm>
           <a:prstGeom prst="rect">
             <a:avLst/>
@@ -12494,8 +12494,8 @@
         </p:nvSpPr>
         <p:spPr>
           <a:xfrm>
-            <a:off x="2606040" y="5449824"/>
-            <a:ext cx="2834640" cy="219456"/>
+            <a:off x="2606040" y="6108192"/>
+            <a:ext cx="2834640" cy="210312"/>
           </a:xfrm>
           <a:prstGeom prst="rect">
             <a:avLst/>
@@ -12516,7 +12516,7 @@
                 </a:solidFill>
                 <a:latin typeface="Calibri"/>
               </a:rPr>
-              <a:t>Regenerate this project record deck (11 slides)</a:t>
+              <a:t>Regenerate this project record (13 slides)</a:t>
             </a:r>
           </a:p>
         </p:txBody>
@@ -12529,8 +12529,8 @@
         </p:nvSpPr>
         <p:spPr>
           <a:xfrm>
-            <a:off x="5870448" y="3337560"/>
-            <a:ext cx="5943600" cy="2377440"/>
+            <a:off x="5870448" y="4041648"/>
+            <a:ext cx="5943600" cy="2359152"/>
           </a:xfrm>
           <a:prstGeom prst="rect">
             <a:avLst/>
@@ -12574,7 +12574,7 @@
         </p:nvSpPr>
         <p:spPr>
           <a:xfrm>
-            <a:off x="5870448" y="3337560"/>
+            <a:off x="5870448" y="4041648"/>
             <a:ext cx="5943600" cy="54864"/>
           </a:xfrm>
           <a:prstGeom prst="rect">
@@ -12617,7 +12617,7 @@
         </p:nvSpPr>
         <p:spPr>
           <a:xfrm>
-            <a:off x="6053328" y="3429000"/>
+            <a:off x="6053328" y="4133087"/>
             <a:ext cx="5577840" cy="274320"/>
           </a:xfrm>
           <a:prstGeom prst="rect">
@@ -12652,8 +12652,8 @@
         </p:nvSpPr>
         <p:spPr>
           <a:xfrm>
-            <a:off x="6053328" y="3749039"/>
-            <a:ext cx="5577840" cy="1828800"/>
+            <a:off x="6053328" y="4462272"/>
+            <a:ext cx="5577840" cy="1783080"/>
           </a:xfrm>
           <a:prstGeom prst="rect">
             <a:avLst/>
@@ -12694,7 +12694,7 @@
                 </a:solidFill>
                 <a:latin typeface="Calibri"/>
               </a:rPr>
-              <a:t>· 5 Standing Security Orders (never outline-none without focus-visible, no dangerouslySetInnerHTML on dynamic content, no secrets in source, no git push --force, run /ship-ready before every push)</a:t>
+              <a:t>· 5 Standing Security Orders: no bare outline-none, no dangerouslySetInnerHTML on dynamic content, no secrets in source, no git push --force, run /ship-ready before every push</a:t>
             </a:r>
           </a:p>
           <a:p>
@@ -12710,7 +12710,7 @@
                 </a:solidFill>
                 <a:latin typeface="Calibri"/>
               </a:rPr>
-              <a:t>· Bosun's Law — spacing scale (4·8·12·16·24·32·48·64·96·128px), stone-* only (never gray-* or zinc-*), one primary CTA per view, num-tab on all monetary amounts</a:t>
+              <a:t>· Bosun's Law — spacing scale (4·8·12·16·24·32·48·64·96·128px), stone-* only, one primary CTA per view, num-tab on all monetary amounts</a:t>
             </a:r>
           </a:p>
           <a:p>
@@ -31647,7 +31647,7 @@
         <p:spPr>
           <a:xfrm>
             <a:off x="384048" y="1024128"/>
-            <a:ext cx="5394960" cy="1060704"/>
+            <a:ext cx="5394960" cy="1024128"/>
           </a:xfrm>
           <a:prstGeom prst="rect">
             <a:avLst/>
@@ -31805,7 +31805,7 @@
         <p:spPr>
           <a:xfrm>
             <a:off x="521207" y="1408176"/>
-            <a:ext cx="5166360" cy="621792"/>
+            <a:ext cx="5166360" cy="594360"/>
           </a:xfrm>
           <a:prstGeom prst="rect">
             <a:avLst/>
@@ -31844,7 +31844,7 @@
         <p:spPr>
           <a:xfrm>
             <a:off x="6007608" y="1024128"/>
-            <a:ext cx="5394960" cy="1060704"/>
+            <a:ext cx="5394960" cy="1024128"/>
           </a:xfrm>
           <a:prstGeom prst="rect">
             <a:avLst/>
@@ -32002,7 +32002,7 @@
         <p:spPr>
           <a:xfrm>
             <a:off x="6144768" y="1408176"/>
-            <a:ext cx="5166360" cy="621792"/>
+            <a:ext cx="5166360" cy="594360"/>
           </a:xfrm>
           <a:prstGeom prst="rect">
             <a:avLst/>
@@ -32040,8 +32040,8 @@
         </p:nvSpPr>
         <p:spPr>
           <a:xfrm>
-            <a:off x="384048" y="2176272"/>
-            <a:ext cx="5394960" cy="1060704"/>
+            <a:off x="384048" y="2139696"/>
+            <a:ext cx="5394960" cy="1024128"/>
           </a:xfrm>
           <a:prstGeom prst="rect">
             <a:avLst/>
@@ -32085,7 +32085,7 @@
         </p:nvSpPr>
         <p:spPr>
           <a:xfrm>
-            <a:off x="384048" y="2176272"/>
+            <a:off x="384048" y="2139696"/>
             <a:ext cx="5394960" cy="50292"/>
           </a:xfrm>
           <a:prstGeom prst="rect">
@@ -32128,7 +32128,7 @@
         </p:nvSpPr>
         <p:spPr>
           <a:xfrm>
-            <a:off x="521207" y="2267712"/>
+            <a:off x="521207" y="2231136"/>
             <a:ext cx="2967228" cy="274320"/>
           </a:xfrm>
           <a:prstGeom prst="rect">
@@ -32163,7 +32163,7 @@
         </p:nvSpPr>
         <p:spPr>
           <a:xfrm>
-            <a:off x="3513124" y="2286000"/>
+            <a:off x="3513124" y="2249424"/>
             <a:ext cx="2157984" cy="228600"/>
           </a:xfrm>
           <a:prstGeom prst="rect">
@@ -32198,8 +32198,8 @@
         </p:nvSpPr>
         <p:spPr>
           <a:xfrm>
-            <a:off x="521207" y="2560320"/>
-            <a:ext cx="5166360" cy="621792"/>
+            <a:off x="521207" y="2523744"/>
+            <a:ext cx="5166360" cy="594360"/>
           </a:xfrm>
           <a:prstGeom prst="rect">
             <a:avLst/>
@@ -32237,8 +32237,8 @@
         </p:nvSpPr>
         <p:spPr>
           <a:xfrm>
-            <a:off x="6007608" y="2176272"/>
-            <a:ext cx="5394960" cy="1060704"/>
+            <a:off x="6007608" y="2139696"/>
+            <a:ext cx="5394960" cy="1024128"/>
           </a:xfrm>
           <a:prstGeom prst="rect">
             <a:avLst/>
@@ -32282,7 +32282,7 @@
         </p:nvSpPr>
         <p:spPr>
           <a:xfrm>
-            <a:off x="6007608" y="2176272"/>
+            <a:off x="6007608" y="2139696"/>
             <a:ext cx="5394960" cy="50292"/>
           </a:xfrm>
           <a:prstGeom prst="rect">
@@ -32325,7 +32325,7 @@
         </p:nvSpPr>
         <p:spPr>
           <a:xfrm>
-            <a:off x="6144768" y="2267712"/>
+            <a:off x="6144768" y="2231136"/>
             <a:ext cx="2967228" cy="274320"/>
           </a:xfrm>
           <a:prstGeom prst="rect">
@@ -32360,7 +32360,7 @@
         </p:nvSpPr>
         <p:spPr>
           <a:xfrm>
-            <a:off x="9136684" y="2286000"/>
+            <a:off x="9136684" y="2249424"/>
             <a:ext cx="2157984" cy="228600"/>
           </a:xfrm>
           <a:prstGeom prst="rect">
@@ -32395,8 +32395,8 @@
         </p:nvSpPr>
         <p:spPr>
           <a:xfrm>
-            <a:off x="6144768" y="2560320"/>
-            <a:ext cx="5166360" cy="621792"/>
+            <a:off x="6144768" y="2523744"/>
+            <a:ext cx="5166360" cy="594360"/>
           </a:xfrm>
           <a:prstGeom prst="rect">
             <a:avLst/>
@@ -32434,8 +32434,8 @@
         </p:nvSpPr>
         <p:spPr>
           <a:xfrm>
-            <a:off x="384048" y="3328416"/>
-            <a:ext cx="5394960" cy="1060704"/>
+            <a:off x="384048" y="3255264"/>
+            <a:ext cx="5394960" cy="1024128"/>
           </a:xfrm>
           <a:prstGeom prst="rect">
             <a:avLst/>
@@ -32479,7 +32479,7 @@
         </p:nvSpPr>
         <p:spPr>
           <a:xfrm>
-            <a:off x="384048" y="3328416"/>
+            <a:off x="384048" y="3255264"/>
             <a:ext cx="5394960" cy="50292"/>
           </a:xfrm>
           <a:prstGeom prst="rect">
@@ -32522,7 +32522,7 @@
         </p:nvSpPr>
         <p:spPr>
           <a:xfrm>
-            <a:off x="521207" y="3419856"/>
+            <a:off x="521207" y="3346704"/>
             <a:ext cx="2967228" cy="274320"/>
           </a:xfrm>
           <a:prstGeom prst="rect">
@@ -32557,7 +32557,7 @@
         </p:nvSpPr>
         <p:spPr>
           <a:xfrm>
-            <a:off x="3513124" y="3438144"/>
+            <a:off x="3513124" y="3364992"/>
             <a:ext cx="2157984" cy="228600"/>
           </a:xfrm>
           <a:prstGeom prst="rect">
@@ -32592,8 +32592,8 @@
         </p:nvSpPr>
         <p:spPr>
           <a:xfrm>
-            <a:off x="521207" y="3712464"/>
-            <a:ext cx="5166360" cy="621792"/>
+            <a:off x="521207" y="3639312"/>
+            <a:ext cx="5166360" cy="594360"/>
           </a:xfrm>
           <a:prstGeom prst="rect">
             <a:avLst/>
@@ -32631,8 +32631,8 @@
         </p:nvSpPr>
         <p:spPr>
           <a:xfrm>
-            <a:off x="6007608" y="3328416"/>
-            <a:ext cx="5394960" cy="1060704"/>
+            <a:off x="6007608" y="3255264"/>
+            <a:ext cx="5394960" cy="1024128"/>
           </a:xfrm>
           <a:prstGeom prst="rect">
             <a:avLst/>
@@ -32676,7 +32676,7 @@
         </p:nvSpPr>
         <p:spPr>
           <a:xfrm>
-            <a:off x="6007608" y="3328416"/>
+            <a:off x="6007608" y="3255264"/>
             <a:ext cx="5394960" cy="50292"/>
           </a:xfrm>
           <a:prstGeom prst="rect">
@@ -32719,7 +32719,7 @@
         </p:nvSpPr>
         <p:spPr>
           <a:xfrm>
-            <a:off x="6144768" y="3419856"/>
+            <a:off x="6144768" y="3346704"/>
             <a:ext cx="2967228" cy="274320"/>
           </a:xfrm>
           <a:prstGeom prst="rect">
@@ -32754,7 +32754,7 @@
         </p:nvSpPr>
         <p:spPr>
           <a:xfrm>
-            <a:off x="9136684" y="3438144"/>
+            <a:off x="9136684" y="3364992"/>
             <a:ext cx="2157984" cy="228600"/>
           </a:xfrm>
           <a:prstGeom prst="rect">
@@ -32789,8 +32789,8 @@
         </p:nvSpPr>
         <p:spPr>
           <a:xfrm>
-            <a:off x="6144768" y="3712464"/>
-            <a:ext cx="5166360" cy="621792"/>
+            <a:off x="6144768" y="3639312"/>
+            <a:ext cx="5166360" cy="594360"/>
           </a:xfrm>
           <a:prstGeom prst="rect">
             <a:avLst/>
@@ -32828,8 +32828,8 @@
         </p:nvSpPr>
         <p:spPr>
           <a:xfrm>
-            <a:off x="384048" y="4480560"/>
-            <a:ext cx="5394960" cy="1060704"/>
+            <a:off x="384048" y="4370832"/>
+            <a:ext cx="5394960" cy="1024128"/>
           </a:xfrm>
           <a:prstGeom prst="rect">
             <a:avLst/>
@@ -32873,7 +32873,7 @@
         </p:nvSpPr>
         <p:spPr>
           <a:xfrm>
-            <a:off x="384048" y="4480560"/>
+            <a:off x="384048" y="4370832"/>
             <a:ext cx="5394960" cy="50292"/>
           </a:xfrm>
           <a:prstGeom prst="rect">
@@ -32916,7 +32916,7 @@
         </p:nvSpPr>
         <p:spPr>
           <a:xfrm>
-            <a:off x="521207" y="4572000"/>
+            <a:off x="521207" y="4462272"/>
             <a:ext cx="2967228" cy="274320"/>
           </a:xfrm>
           <a:prstGeom prst="rect">
@@ -32951,7 +32951,7 @@
         </p:nvSpPr>
         <p:spPr>
           <a:xfrm>
-            <a:off x="3513124" y="4590288"/>
+            <a:off x="3513124" y="4480560"/>
             <a:ext cx="2157984" cy="228600"/>
           </a:xfrm>
           <a:prstGeom prst="rect">
@@ -32986,8 +32986,8 @@
         </p:nvSpPr>
         <p:spPr>
           <a:xfrm>
-            <a:off x="521207" y="4864608"/>
-            <a:ext cx="5166360" cy="621792"/>
+            <a:off x="521207" y="4754880"/>
+            <a:ext cx="5166360" cy="594360"/>
           </a:xfrm>
           <a:prstGeom prst="rect">
             <a:avLst/>
@@ -33025,8 +33025,8 @@
         </p:nvSpPr>
         <p:spPr>
           <a:xfrm>
-            <a:off x="6007608" y="4480560"/>
-            <a:ext cx="5394960" cy="1060704"/>
+            <a:off x="6007608" y="4370832"/>
+            <a:ext cx="5394960" cy="1024128"/>
           </a:xfrm>
           <a:prstGeom prst="rect">
             <a:avLst/>
@@ -33070,7 +33070,7 @@
         </p:nvSpPr>
         <p:spPr>
           <a:xfrm>
-            <a:off x="6007608" y="4480560"/>
+            <a:off x="6007608" y="4370832"/>
             <a:ext cx="5394960" cy="50292"/>
           </a:xfrm>
           <a:prstGeom prst="rect">
@@ -33113,7 +33113,7 @@
         </p:nvSpPr>
         <p:spPr>
           <a:xfrm>
-            <a:off x="6144768" y="4572000"/>
+            <a:off x="6144768" y="4462272"/>
             <a:ext cx="2967228" cy="274320"/>
           </a:xfrm>
           <a:prstGeom prst="rect">
@@ -33148,7 +33148,7 @@
         </p:nvSpPr>
         <p:spPr>
           <a:xfrm>
-            <a:off x="9136684" y="4590288"/>
+            <a:off x="9136684" y="4480560"/>
             <a:ext cx="2157984" cy="228600"/>
           </a:xfrm>
           <a:prstGeom prst="rect">
@@ -33183,8 +33183,8 @@
         </p:nvSpPr>
         <p:spPr>
           <a:xfrm>
-            <a:off x="6144768" y="4864608"/>
-            <a:ext cx="5166360" cy="621792"/>
+            <a:off x="6144768" y="4754880"/>
+            <a:ext cx="5166360" cy="594360"/>
           </a:xfrm>
           <a:prstGeom prst="rect">
             <a:avLst/>
@@ -33222,8 +33222,8 @@
         </p:nvSpPr>
         <p:spPr>
           <a:xfrm>
-            <a:off x="384048" y="5632704"/>
-            <a:ext cx="5394960" cy="1060704"/>
+            <a:off x="3396996" y="5486400"/>
+            <a:ext cx="5394960" cy="1024128"/>
           </a:xfrm>
           <a:prstGeom prst="rect">
             <a:avLst/>
@@ -33267,7 +33267,7 @@
         </p:nvSpPr>
         <p:spPr>
           <a:xfrm>
-            <a:off x="384048" y="5632704"/>
+            <a:off x="3396996" y="5486400"/>
             <a:ext cx="5394960" cy="50292"/>
           </a:xfrm>
           <a:prstGeom prst="rect">
@@ -33310,7 +33310,7 @@
         </p:nvSpPr>
         <p:spPr>
           <a:xfrm>
-            <a:off x="521207" y="5724144"/>
+            <a:off x="3534156" y="5577840"/>
             <a:ext cx="2967228" cy="274320"/>
           </a:xfrm>
           <a:prstGeom prst="rect">
@@ -33345,7 +33345,7 @@
         </p:nvSpPr>
         <p:spPr>
           <a:xfrm>
-            <a:off x="3513124" y="5742432"/>
+            <a:off x="6526072" y="5596128"/>
             <a:ext cx="2157984" cy="228600"/>
           </a:xfrm>
           <a:prstGeom prst="rect">
@@ -33380,8 +33380,8 @@
         </p:nvSpPr>
         <p:spPr>
           <a:xfrm>
-            <a:off x="521207" y="6016752"/>
-            <a:ext cx="5166360" cy="621792"/>
+            <a:off x="3534156" y="5870448"/>
+            <a:ext cx="5166360" cy="594360"/>
           </a:xfrm>
           <a:prstGeom prst="rect">
             <a:avLst/>
@@ -33414,203 +33414,6 @@
       <p:sp>
         <p:nvSpPr>
           <p:cNvPr id="52" name="Rectangle 51"/>
-          <p:cNvSpPr/>
-          <p:nvPr/>
-        </p:nvSpPr>
-        <p:spPr>
-          <a:xfrm>
-            <a:off x="3195828" y="5632704"/>
-            <a:ext cx="5394960" cy="1060704"/>
-          </a:xfrm>
-          <a:prstGeom prst="rect">
-            <a:avLst/>
-          </a:prstGeom>
-          <a:solidFill>
-            <a:srgbClr val="FFFFFF"/>
-          </a:solidFill>
-          <a:ln w="9525">
-            <a:solidFill>
-              <a:srgbClr val="E7E5E4"/>
-            </a:solidFill>
-          </a:ln>
-        </p:spPr>
-        <p:style>
-          <a:lnRef idx="1">
-            <a:schemeClr val="accent1"/>
-          </a:lnRef>
-          <a:fillRef idx="3">
-            <a:schemeClr val="accent1"/>
-          </a:fillRef>
-          <a:effectRef idx="2">
-            <a:schemeClr val="accent1"/>
-          </a:effectRef>
-          <a:fontRef idx="minor">
-            <a:schemeClr val="lt1"/>
-          </a:fontRef>
-        </p:style>
-        <p:txBody>
-          <a:bodyPr rtlCol="0" anchor="ctr"/>
-          <a:lstStyle/>
-          <a:p>
-            <a:pPr algn="ctr"/>
-          </a:p>
-        </p:txBody>
-      </p:sp>
-      <p:sp>
-        <p:nvSpPr>
-          <p:cNvPr id="53" name="Rectangle 52"/>
-          <p:cNvSpPr/>
-          <p:nvPr/>
-        </p:nvSpPr>
-        <p:spPr>
-          <a:xfrm>
-            <a:off x="3195828" y="5632704"/>
-            <a:ext cx="5394960" cy="50292"/>
-          </a:xfrm>
-          <a:prstGeom prst="rect">
-            <a:avLst/>
-          </a:prstGeom>
-          <a:solidFill>
-            <a:srgbClr val="C8102E"/>
-          </a:solidFill>
-          <a:ln>
-            <a:noFill/>
-          </a:ln>
-        </p:spPr>
-        <p:style>
-          <a:lnRef idx="1">
-            <a:schemeClr val="accent1"/>
-          </a:lnRef>
-          <a:fillRef idx="3">
-            <a:schemeClr val="accent1"/>
-          </a:fillRef>
-          <a:effectRef idx="2">
-            <a:schemeClr val="accent1"/>
-          </a:effectRef>
-          <a:fontRef idx="minor">
-            <a:schemeClr val="lt1"/>
-          </a:fontRef>
-        </p:style>
-        <p:txBody>
-          <a:bodyPr rtlCol="0" anchor="ctr"/>
-          <a:lstStyle/>
-          <a:p>
-            <a:pPr algn="ctr"/>
-          </a:p>
-        </p:txBody>
-      </p:sp>
-      <p:sp>
-        <p:nvSpPr>
-          <p:cNvPr id="54" name="TextBox 53"/>
-          <p:cNvSpPr txBox="1"/>
-          <p:nvPr/>
-        </p:nvSpPr>
-        <p:spPr>
-          <a:xfrm>
-            <a:off x="3332988" y="5724144"/>
-            <a:ext cx="2967228" cy="274320"/>
-          </a:xfrm>
-          <a:prstGeom prst="rect">
-            <a:avLst/>
-          </a:prstGeom>
-          <a:noFill/>
-        </p:spPr>
-        <p:txBody>
-          <a:bodyPr wrap="square">
-            <a:spAutoFit/>
-          </a:bodyPr>
-          <a:lstStyle/>
-          <a:p>
-            <a:pPr algn="l"/>
-            <a:r>
-              <a:rPr sz="950" b="1" i="0">
-                <a:solidFill>
-                  <a:srgbClr val="1C1917"/>
-                </a:solidFill>
-                <a:latin typeface="Calibri"/>
-              </a:rPr>
-              <a:t>Live notification bell</a:t>
-            </a:r>
-          </a:p>
-        </p:txBody>
-      </p:sp>
-      <p:sp>
-        <p:nvSpPr>
-          <p:cNvPr id="55" name="TextBox 54"/>
-          <p:cNvSpPr txBox="1"/>
-          <p:nvPr/>
-        </p:nvSpPr>
-        <p:spPr>
-          <a:xfrm>
-            <a:off x="6324904" y="5742432"/>
-            <a:ext cx="2157984" cy="228600"/>
-          </a:xfrm>
-          <a:prstGeom prst="rect">
-            <a:avLst/>
-          </a:prstGeom>
-          <a:noFill/>
-        </p:spPr>
-        <p:txBody>
-          <a:bodyPr wrap="square">
-            <a:spAutoFit/>
-          </a:bodyPr>
-          <a:lstStyle/>
-          <a:p>
-            <a:pPr algn="l"/>
-            <a:r>
-              <a:rPr sz="700" b="1" i="0">
-                <a:solidFill>
-                  <a:srgbClr val="C8102E"/>
-                </a:solidFill>
-                <a:latin typeface="Calibri"/>
-              </a:rPr>
-              <a:t>FCA SYSC 10A · PSD2 RTS Art.2</a:t>
-            </a:r>
-          </a:p>
-        </p:txBody>
-      </p:sp>
-      <p:sp>
-        <p:nvSpPr>
-          <p:cNvPr id="56" name="TextBox 55"/>
-          <p:cNvSpPr txBox="1"/>
-          <p:nvPr/>
-        </p:nvSpPr>
-        <p:spPr>
-          <a:xfrm>
-            <a:off x="3332988" y="6016752"/>
-            <a:ext cx="5166360" cy="621792"/>
-          </a:xfrm>
-          <a:prstGeom prst="rect">
-            <a:avLst/>
-          </a:prstGeom>
-          <a:noFill/>
-        </p:spPr>
-        <p:txBody>
-          <a:bodyPr wrap="square">
-            <a:spAutoFit/>
-          </a:bodyPr>
-          <a:lstStyle/>
-          <a:p>
-            <a:pPr>
-              <a:spcAft>
-                <a:spcPts val="300"/>
-              </a:spcAft>
-            </a:pPr>
-            <a:r>
-              <a:rPr sz="800">
-                <a:solidFill>
-                  <a:srgbClr val="78716C"/>
-                </a:solidFill>
-                <a:latin typeface="Calibri"/>
-              </a:rPr>
-              <a:t>Bell icon (desktop header + mobile header) opens NotificationsSheet. Shows: session anomaly alert with CTAs, unsigned pending approvals with Sign-tab navigation, cooling-off progress bars, stalled co-signer escalations. Badge dot while anomaly or approvals exist.</a:t>
-            </a:r>
-          </a:p>
-        </p:txBody>
-      </p:sp>
-      <p:sp>
-        <p:nvSpPr>
-          <p:cNvPr id="57" name="Rectangle 56"/>
           <p:cNvSpPr/>
           <p:nvPr/>
         </p:nvSpPr>
@@ -33653,7 +33456,7 @@
       </p:sp>
       <p:sp>
         <p:nvSpPr>
-          <p:cNvPr id="58" name="TextBox 57"/>
+          <p:cNvPr id="53" name="TextBox 52"/>
           <p:cNvSpPr txBox="1"/>
           <p:nvPr/>
         </p:nvSpPr>
@@ -33688,7 +33491,7 @@
       </p:sp>
       <p:sp>
         <p:nvSpPr>
-          <p:cNvPr id="59" name="TextBox 58"/>
+          <p:cNvPr id="54" name="TextBox 53"/>
           <p:cNvSpPr txBox="1"/>
           <p:nvPr/>
         </p:nvSpPr>

</xml_diff>

<commit_message>
Fix slide 3 Five Screens duplicate panel and overflow
Same bug as slide 7: loop iterated over all 5 screens then the 'centred'
block drew screen 4 (Audit Trail) a second time. The row-2 y position
was 6.71" with a 2.6" panel, overflowing the 7.5" slide entirely and
letting the footer bar cut through the content.

Switched from 2-column × 3-row to 3+2 layout: 3 panels in row 0,
2 centred in row 1. Each panel now 2.68" tall, row 1 bottom at 6.73"
— clear of the 7.22" footer.

Co-Authored-By: Claude Sonnet 4.6 <noreply@anthropic.com>
Claude-Session: https://claude.ai/code/session_012EFETGbhdxdnPCjpmQ9UDz
</commit_message>
<xml_diff>
--- a/Santander_Project_Record.pptx
+++ b/Santander_Project_Record.pptx
@@ -22269,8 +22269,8 @@
         </p:nvSpPr>
         <p:spPr>
           <a:xfrm>
-            <a:off x="411480" y="1051560"/>
-            <a:ext cx="5806440" cy="2377440"/>
+            <a:off x="384048" y="1051560"/>
+            <a:ext cx="3694176" cy="2450592"/>
           </a:xfrm>
           <a:prstGeom prst="rect">
             <a:avLst/>
@@ -22314,8 +22314,8 @@
         </p:nvSpPr>
         <p:spPr>
           <a:xfrm>
-            <a:off x="411480" y="1051560"/>
-            <a:ext cx="5806440" cy="54864"/>
+            <a:off x="384048" y="1051560"/>
+            <a:ext cx="3694176" cy="54864"/>
           </a:xfrm>
           <a:prstGeom prst="rect">
             <a:avLst/>
@@ -22357,8 +22357,8 @@
         </p:nvSpPr>
         <p:spPr>
           <a:xfrm>
-            <a:off x="576072" y="1143000"/>
-            <a:ext cx="5440679" cy="292608"/>
+            <a:off x="521207" y="1143000"/>
+            <a:ext cx="3419856" cy="274320"/>
           </a:xfrm>
           <a:prstGeom prst="rect">
             <a:avLst/>
@@ -22392,8 +22392,8 @@
         </p:nvSpPr>
         <p:spPr>
           <a:xfrm>
-            <a:off x="576072" y="1435607"/>
-            <a:ext cx="5440679" cy="201168"/>
+            <a:off x="521207" y="1417319"/>
+            <a:ext cx="3419856" cy="182880"/>
           </a:xfrm>
           <a:prstGeom prst="rect">
             <a:avLst/>
@@ -22427,8 +22427,8 @@
         </p:nvSpPr>
         <p:spPr>
           <a:xfrm>
-            <a:off x="576072" y="1645919"/>
-            <a:ext cx="5513831" cy="1719072"/>
+            <a:off x="521207" y="1618488"/>
+            <a:ext cx="3438144" cy="1810512"/>
           </a:xfrm>
           <a:prstGeom prst="rect">
             <a:avLst/>
@@ -22610,8 +22610,8 @@
         </p:nvSpPr>
         <p:spPr>
           <a:xfrm>
-            <a:off x="6419088" y="1051560"/>
-            <a:ext cx="5806440" cy="2377440"/>
+            <a:off x="4251960" y="1051560"/>
+            <a:ext cx="3694176" cy="2450592"/>
           </a:xfrm>
           <a:prstGeom prst="rect">
             <a:avLst/>
@@ -22655,8 +22655,8 @@
         </p:nvSpPr>
         <p:spPr>
           <a:xfrm>
-            <a:off x="6419088" y="1051560"/>
-            <a:ext cx="5806440" cy="54864"/>
+            <a:off x="4251960" y="1051560"/>
+            <a:ext cx="3694176" cy="54864"/>
           </a:xfrm>
           <a:prstGeom prst="rect">
             <a:avLst/>
@@ -22698,8 +22698,8 @@
         </p:nvSpPr>
         <p:spPr>
           <a:xfrm>
-            <a:off x="6583679" y="1143000"/>
-            <a:ext cx="5440679" cy="292608"/>
+            <a:off x="4389120" y="1143000"/>
+            <a:ext cx="3419856" cy="274320"/>
           </a:xfrm>
           <a:prstGeom prst="rect">
             <a:avLst/>
@@ -22733,8 +22733,8 @@
         </p:nvSpPr>
         <p:spPr>
           <a:xfrm>
-            <a:off x="6583679" y="1435607"/>
-            <a:ext cx="5440679" cy="201168"/>
+            <a:off x="4389120" y="1417319"/>
+            <a:ext cx="3419856" cy="182880"/>
           </a:xfrm>
           <a:prstGeom prst="rect">
             <a:avLst/>
@@ -22768,8 +22768,8 @@
         </p:nvSpPr>
         <p:spPr>
           <a:xfrm>
-            <a:off x="6583679" y="1645919"/>
-            <a:ext cx="5513831" cy="1719072"/>
+            <a:off x="4389120" y="1618488"/>
+            <a:ext cx="3438144" cy="1810512"/>
           </a:xfrm>
           <a:prstGeom prst="rect">
             <a:avLst/>
@@ -22871,8 +22871,8 @@
         </p:nvSpPr>
         <p:spPr>
           <a:xfrm>
-            <a:off x="411480" y="3593591"/>
-            <a:ext cx="5806440" cy="2377440"/>
+            <a:off x="8119872" y="1051560"/>
+            <a:ext cx="3694176" cy="2450592"/>
           </a:xfrm>
           <a:prstGeom prst="rect">
             <a:avLst/>
@@ -22916,8 +22916,8 @@
         </p:nvSpPr>
         <p:spPr>
           <a:xfrm>
-            <a:off x="411480" y="3593591"/>
-            <a:ext cx="5806440" cy="54864"/>
+            <a:off x="8119872" y="1051560"/>
+            <a:ext cx="3694176" cy="54864"/>
           </a:xfrm>
           <a:prstGeom prst="rect">
             <a:avLst/>
@@ -22959,8 +22959,8 @@
         </p:nvSpPr>
         <p:spPr>
           <a:xfrm>
-            <a:off x="576072" y="3685031"/>
-            <a:ext cx="5440679" cy="292608"/>
+            <a:off x="8257032" y="1143000"/>
+            <a:ext cx="3419856" cy="274320"/>
           </a:xfrm>
           <a:prstGeom prst="rect">
             <a:avLst/>
@@ -22994,8 +22994,8 @@
         </p:nvSpPr>
         <p:spPr>
           <a:xfrm>
-            <a:off x="576072" y="3977639"/>
-            <a:ext cx="5440679" cy="201168"/>
+            <a:off x="8257032" y="1417319"/>
+            <a:ext cx="3419856" cy="182880"/>
           </a:xfrm>
           <a:prstGeom prst="rect">
             <a:avLst/>
@@ -23029,8 +23029,8 @@
         </p:nvSpPr>
         <p:spPr>
           <a:xfrm>
-            <a:off x="576072" y="4187952"/>
-            <a:ext cx="5513831" cy="1719072"/>
+            <a:off x="8257032" y="1618488"/>
+            <a:ext cx="3438144" cy="1810512"/>
           </a:xfrm>
           <a:prstGeom prst="rect">
             <a:avLst/>
@@ -23148,8 +23148,8 @@
         </p:nvSpPr>
         <p:spPr>
           <a:xfrm>
-            <a:off x="6419088" y="3593591"/>
-            <a:ext cx="5806440" cy="2377440"/>
+            <a:off x="2313432" y="3703320"/>
+            <a:ext cx="3694176" cy="2450592"/>
           </a:xfrm>
           <a:prstGeom prst="rect">
             <a:avLst/>
@@ -23193,8 +23193,8 @@
         </p:nvSpPr>
         <p:spPr>
           <a:xfrm>
-            <a:off x="6419088" y="3593591"/>
-            <a:ext cx="5806440" cy="54864"/>
+            <a:off x="2313432" y="3703320"/>
+            <a:ext cx="3694176" cy="54864"/>
           </a:xfrm>
           <a:prstGeom prst="rect">
             <a:avLst/>
@@ -23236,8 +23236,8 @@
         </p:nvSpPr>
         <p:spPr>
           <a:xfrm>
-            <a:off x="6583679" y="3685031"/>
-            <a:ext cx="5440679" cy="292608"/>
+            <a:off x="2450591" y="3794760"/>
+            <a:ext cx="3419856" cy="274320"/>
           </a:xfrm>
           <a:prstGeom prst="rect">
             <a:avLst/>
@@ -23271,8 +23271,8 @@
         </p:nvSpPr>
         <p:spPr>
           <a:xfrm>
-            <a:off x="6583679" y="3977639"/>
-            <a:ext cx="5440679" cy="201168"/>
+            <a:off x="2450591" y="4069080"/>
+            <a:ext cx="3419856" cy="182880"/>
           </a:xfrm>
           <a:prstGeom prst="rect">
             <a:avLst/>
@@ -23306,8 +23306,8 @@
         </p:nvSpPr>
         <p:spPr>
           <a:xfrm>
-            <a:off x="6583679" y="4187952"/>
-            <a:ext cx="5513831" cy="1719072"/>
+            <a:off x="2450591" y="4270248"/>
+            <a:ext cx="3438144" cy="1810512"/>
           </a:xfrm>
           <a:prstGeom prst="rect">
             <a:avLst/>
@@ -23457,8 +23457,8 @@
         </p:nvSpPr>
         <p:spPr>
           <a:xfrm>
-            <a:off x="411480" y="6135623"/>
-            <a:ext cx="5806440" cy="2377440"/>
+            <a:off x="6181344" y="3703320"/>
+            <a:ext cx="3694176" cy="2450592"/>
           </a:xfrm>
           <a:prstGeom prst="rect">
             <a:avLst/>
@@ -23502,8 +23502,8 @@
         </p:nvSpPr>
         <p:spPr>
           <a:xfrm>
-            <a:off x="411480" y="6135623"/>
-            <a:ext cx="5806440" cy="54864"/>
+            <a:off x="6181344" y="3703320"/>
+            <a:ext cx="3694176" cy="54864"/>
           </a:xfrm>
           <a:prstGeom prst="rect">
             <a:avLst/>
@@ -23545,8 +23545,8 @@
         </p:nvSpPr>
         <p:spPr>
           <a:xfrm>
-            <a:off x="576072" y="6227063"/>
-            <a:ext cx="5440679" cy="292608"/>
+            <a:off x="6318504" y="3794760"/>
+            <a:ext cx="3419856" cy="274320"/>
           </a:xfrm>
           <a:prstGeom prst="rect">
             <a:avLst/>
@@ -23580,8 +23580,8 @@
         </p:nvSpPr>
         <p:spPr>
           <a:xfrm>
-            <a:off x="576072" y="6519671"/>
-            <a:ext cx="5440679" cy="201168"/>
+            <a:off x="6318504" y="4069080"/>
+            <a:ext cx="3419856" cy="182880"/>
           </a:xfrm>
           <a:prstGeom prst="rect">
             <a:avLst/>
@@ -23615,8 +23615,8 @@
         </p:nvSpPr>
         <p:spPr>
           <a:xfrm>
-            <a:off x="576072" y="6729983"/>
-            <a:ext cx="5513831" cy="1719072"/>
+            <a:off x="6318504" y="4270248"/>
+            <a:ext cx="3438144" cy="1810512"/>
           </a:xfrm>
           <a:prstGeom prst="rect">
             <a:avLst/>
@@ -23729,283 +23729,6 @@
       <p:sp>
         <p:nvSpPr>
           <p:cNvPr id="32" name="Rectangle 31"/>
-          <p:cNvSpPr/>
-          <p:nvPr/>
-        </p:nvSpPr>
-        <p:spPr>
-          <a:xfrm>
-            <a:off x="3415284" y="6135623"/>
-            <a:ext cx="5806440" cy="2377440"/>
-          </a:xfrm>
-          <a:prstGeom prst="rect">
-            <a:avLst/>
-          </a:prstGeom>
-          <a:solidFill>
-            <a:srgbClr val="FFFFFF"/>
-          </a:solidFill>
-          <a:ln w="9525">
-            <a:solidFill>
-              <a:srgbClr val="D6D3D1"/>
-            </a:solidFill>
-          </a:ln>
-        </p:spPr>
-        <p:style>
-          <a:lnRef idx="1">
-            <a:schemeClr val="accent1"/>
-          </a:lnRef>
-          <a:fillRef idx="3">
-            <a:schemeClr val="accent1"/>
-          </a:fillRef>
-          <a:effectRef idx="2">
-            <a:schemeClr val="accent1"/>
-          </a:effectRef>
-          <a:fontRef idx="minor">
-            <a:schemeClr val="lt1"/>
-          </a:fontRef>
-        </p:style>
-        <p:txBody>
-          <a:bodyPr rtlCol="0" anchor="ctr"/>
-          <a:lstStyle/>
-          <a:p>
-            <a:pPr algn="ctr"/>
-          </a:p>
-        </p:txBody>
-      </p:sp>
-      <p:sp>
-        <p:nvSpPr>
-          <p:cNvPr id="33" name="Rectangle 32"/>
-          <p:cNvSpPr/>
-          <p:nvPr/>
-        </p:nvSpPr>
-        <p:spPr>
-          <a:xfrm>
-            <a:off x="3415284" y="6135623"/>
-            <a:ext cx="5806440" cy="54864"/>
-          </a:xfrm>
-          <a:prstGeom prst="rect">
-            <a:avLst/>
-          </a:prstGeom>
-          <a:solidFill>
-            <a:srgbClr val="C8102E"/>
-          </a:solidFill>
-          <a:ln>
-            <a:noFill/>
-          </a:ln>
-        </p:spPr>
-        <p:style>
-          <a:lnRef idx="1">
-            <a:schemeClr val="accent1"/>
-          </a:lnRef>
-          <a:fillRef idx="3">
-            <a:schemeClr val="accent1"/>
-          </a:fillRef>
-          <a:effectRef idx="2">
-            <a:schemeClr val="accent1"/>
-          </a:effectRef>
-          <a:fontRef idx="minor">
-            <a:schemeClr val="lt1"/>
-          </a:fontRef>
-        </p:style>
-        <p:txBody>
-          <a:bodyPr rtlCol="0" anchor="ctr"/>
-          <a:lstStyle/>
-          <a:p>
-            <a:pPr algn="ctr"/>
-          </a:p>
-        </p:txBody>
-      </p:sp>
-      <p:sp>
-        <p:nvSpPr>
-          <p:cNvPr id="34" name="TextBox 33"/>
-          <p:cNvSpPr txBox="1"/>
-          <p:nvPr/>
-        </p:nvSpPr>
-        <p:spPr>
-          <a:xfrm>
-            <a:off x="3579876" y="6227063"/>
-            <a:ext cx="5440679" cy="292608"/>
-          </a:xfrm>
-          <a:prstGeom prst="rect">
-            <a:avLst/>
-          </a:prstGeom>
-          <a:noFill/>
-        </p:spPr>
-        <p:txBody>
-          <a:bodyPr wrap="square">
-            <a:spAutoFit/>
-          </a:bodyPr>
-          <a:lstStyle/>
-          <a:p>
-            <a:pPr algn="l"/>
-            <a:r>
-              <a:rPr sz="1100" b="1" i="0">
-                <a:solidFill>
-                  <a:srgbClr val="1C1917"/>
-                </a:solidFill>
-                <a:latin typeface="Calibri"/>
-              </a:rPr>
-              <a:t>Audit Trail</a:t>
-            </a:r>
-          </a:p>
-        </p:txBody>
-      </p:sp>
-      <p:sp>
-        <p:nvSpPr>
-          <p:cNvPr id="35" name="TextBox 34"/>
-          <p:cNvSpPr txBox="1"/>
-          <p:nvPr/>
-        </p:nvSpPr>
-        <p:spPr>
-          <a:xfrm>
-            <a:off x="3579876" y="6519671"/>
-            <a:ext cx="5440679" cy="201168"/>
-          </a:xfrm>
-          <a:prstGeom prst="rect">
-            <a:avLst/>
-          </a:prstGeom>
-          <a:noFill/>
-        </p:spPr>
-        <p:txBody>
-          <a:bodyPr wrap="square">
-            <a:spAutoFit/>
-          </a:bodyPr>
-          <a:lstStyle/>
-          <a:p>
-            <a:pPr algn="l"/>
-            <a:r>
-              <a:rPr sz="800" b="0" i="1">
-                <a:solidFill>
-                  <a:srgbClr val="78716C"/>
-                </a:solidFill>
-                <a:latin typeface="Calibri"/>
-              </a:rPr>
-              <a:t>tab: 'audit'</a:t>
-            </a:r>
-          </a:p>
-        </p:txBody>
-      </p:sp>
-      <p:sp>
-        <p:nvSpPr>
-          <p:cNvPr id="36" name="TextBox 35"/>
-          <p:cNvSpPr txBox="1"/>
-          <p:nvPr/>
-        </p:nvSpPr>
-        <p:spPr>
-          <a:xfrm>
-            <a:off x="3579876" y="6729983"/>
-            <a:ext cx="5513831" cy="1719072"/>
-          </a:xfrm>
-          <a:prstGeom prst="rect">
-            <a:avLst/>
-          </a:prstGeom>
-          <a:noFill/>
-        </p:spPr>
-        <p:txBody>
-          <a:bodyPr wrap="square">
-            <a:spAutoFit/>
-          </a:bodyPr>
-          <a:lstStyle/>
-          <a:p>
-            <a:pPr>
-              <a:spcAft>
-                <a:spcPts val="300"/>
-              </a:spcAft>
-            </a:pPr>
-            <a:r>
-              <a:rPr sz="850">
-                <a:solidFill>
-                  <a:srgbClr val="44403C"/>
-                </a:solidFill>
-                <a:latin typeface="Calibri"/>
-              </a:rPr>
-              <a:t>· FCA SYSC 9 compliant — 7-year retention, append-only</a:t>
-            </a:r>
-          </a:p>
-          <a:p>
-            <a:pPr>
-              <a:spcAft>
-                <a:spcPts val="300"/>
-              </a:spcAft>
-            </a:pPr>
-            <a:r>
-              <a:rPr sz="850">
-                <a:solidFill>
-                  <a:srgbClr val="44403C"/>
-                </a:solidFill>
-                <a:latin typeface="Calibri"/>
-              </a:rPr>
-              <a:t>· Every action: workflow steps, sign events, rejections, system alerts</a:t>
-            </a:r>
-          </a:p>
-          <a:p>
-            <a:pPr>
-              <a:spcAft>
-                <a:spcPts val="300"/>
-              </a:spcAft>
-            </a:pPr>
-            <a:r>
-              <a:rPr sz="850">
-                <a:solidFill>
-                  <a:srgbClr val="44403C"/>
-                </a:solidFill>
-                <a:latin typeface="Calibri"/>
-              </a:rPr>
-              <a:t>· Each entry: timestamp, actor name, action type, account/reference</a:t>
-            </a:r>
-          </a:p>
-          <a:p>
-            <a:pPr>
-              <a:spcAft>
-                <a:spcPts val="300"/>
-              </a:spcAft>
-            </a:pPr>
-            <a:r>
-              <a:rPr sz="850">
-                <a:solidFill>
-                  <a:srgbClr val="44403C"/>
-                </a:solidFill>
-                <a:latin typeface="Calibri"/>
-              </a:rPr>
-              <a:t>· Session anomaly events logged with device/location metadata</a:t>
-            </a:r>
-          </a:p>
-          <a:p>
-            <a:pPr>
-              <a:spcAft>
-                <a:spcPts val="300"/>
-              </a:spcAft>
-            </a:pPr>
-            <a:r>
-              <a:rPr sz="850">
-                <a:solidFill>
-                  <a:srgbClr val="44403C"/>
-                </a:solidFill>
-                <a:latin typeface="Calibri"/>
-              </a:rPr>
-              <a:t>· Filter by event type or actor</a:t>
-            </a:r>
-          </a:p>
-          <a:p>
-            <a:pPr>
-              <a:spcAft>
-                <a:spcPts val="300"/>
-              </a:spcAft>
-            </a:pPr>
-            <a:r>
-              <a:rPr sz="850">
-                <a:solidFill>
-                  <a:srgbClr val="44403C"/>
-                </a:solidFill>
-                <a:latin typeface="Calibri"/>
-              </a:rPr>
-              <a:t>· Export for compliance reporting</a:t>
-            </a:r>
-          </a:p>
-        </p:txBody>
-      </p:sp>
-      <p:sp>
-        <p:nvSpPr>
-          <p:cNvPr id="37" name="Rectangle 36"/>
           <p:cNvSpPr/>
           <p:nvPr/>
         </p:nvSpPr>
@@ -24048,7 +23771,7 @@
       </p:sp>
       <p:sp>
         <p:nvSpPr>
-          <p:cNvPr id="38" name="TextBox 37"/>
+          <p:cNvPr id="33" name="TextBox 32"/>
           <p:cNvSpPr txBox="1"/>
           <p:nvPr/>
         </p:nvSpPr>
@@ -24083,7 +23806,7 @@
       </p:sp>
       <p:sp>
         <p:nvSpPr>
-          <p:cNvPr id="39" name="TextBox 38"/>
+          <p:cNvPr id="34" name="TextBox 33"/>
           <p:cNvSpPr txBox="1"/>
           <p:nvPr/>
         </p:nvSpPr>

</xml_diff>

<commit_message>
Rebuild all five PowerPoint decks from scripts
- Santander_Architecture.pptx: 12 slides — full technical architecture report
- Santander_June2026_Changes.pptx: 15 slides — idempotent build (base 11 + 4 session-2 slides)
- Santander_LimitedCompany_Walkthrough.pptx: 31 slides — nav guide + Command Centre deep-dive
- Santander_Project_Record.pptx: 13 slides — project manifest
- Santander_Digital_Banking_Future.pptx: 16 slides — pitch deck

Fix build_changes_slides.py: now idempotent — always starts from the
clean 11-slide git base template so repeated runs produce exactly 15 slides.

Co-Authored-By: Claude Opus 4.8 <noreply@anthropic.com>
Claude-Session: https://claude.ai/code/session_012EFETGbhdxdnPCjpmQ9UDz
</commit_message>
<xml_diff>
--- a/Santander_Project_Record.pptx
+++ b/Santander_Project_Record.pptx
@@ -4378,7 +4378,7 @@
                 </a:solidFill>
                 <a:latin typeface="Calibri"/>
               </a:rPr>
-              <a:t>12,523 lines · 57 sections · 71 books synthesised into a single indexed technical reference</a:t>
+              <a:t>5,024 lines · 26 sections · 41 books synthesised into a single indexed technical reference</a:t>
             </a:r>
           </a:p>
         </p:txBody>
@@ -17743,7 +17743,7 @@
                 </a:solidFill>
                 <a:latin typeface="Calibri"/>
               </a:rPr>
-              <a:t>Reference library (57 sections)</a:t>
+              <a:t>Reference library (26 sections)</a:t>
             </a:r>
           </a:p>
         </p:txBody>
@@ -20660,7 +20660,7 @@
                 </a:solidFill>
                 <a:latin typeface="Calibri"/>
               </a:rPr>
-              <a:t>App.jsx — ~5,700-lines · ~300KB source · Single React component</a:t>
+              <a:t>App.jsx — ~5,300 lines · ~300KB source · Single React component</a:t>
             </a:r>
           </a:p>
           <a:p>

</xml_diff>

<commit_message>
Update MANIFEST, build_manifest.py, and PPTX for 88-section library
- MANIFEST.md: stats updated to 21,689 lines · 88 sections · 97 books & docs
- Added new domain groups: Banking/Payments/Regulation (§86-88 added),
  Prudential & Market Regulation (§87-88 new), Digital Banking Transformation
  (§82/83/85 new), UI/Frontend updated to include §78-81 (Tailwind ×3, React Hooks)
- build_manifest.py: updated slide 10 stats banner and domain blocks to match
- Rebuilt Santander_Project_Record.pptx with new stats and domain layout

Co-Authored-By: Claude Opus 4.8 <noreply@anthropic.com>
Claude-Session: https://claude.ai/code/session_012EFETGbhdxdnPCjpmQ9UDz
</commit_message>
<xml_diff>
--- a/Santander_Project_Record.pptx
+++ b/Santander_Project_Record.pptx
@@ -4378,7 +4378,7 @@
                 </a:solidFill>
                 <a:latin typeface="Calibri"/>
               </a:rPr>
-              <a:t>15,552 lines · 77 sections · 86 books &amp; regulatory documents · Quick Lookup decision index</a:t>
+              <a:t>21,689 lines · 88 sections · 97 books &amp; regulatory documents · Quick Lookup decision index</a:t>
             </a:r>
           </a:p>
         </p:txBody>
@@ -4499,7 +4499,7 @@
                 </a:solidFill>
                 <a:latin typeface="Calibri"/>
               </a:rPr>
-              <a:t>15,552</a:t>
+              <a:t>21,689</a:t>
             </a:r>
           </a:p>
         </p:txBody>
@@ -4612,7 +4612,7 @@
                 </a:solidFill>
                 <a:latin typeface="Calibri"/>
               </a:rPr>
-              <a:t>77</a:t>
+              <a:t>88</a:t>
             </a:r>
           </a:p>
         </p:txBody>
@@ -4725,7 +4725,7 @@
                 </a:solidFill>
                 <a:latin typeface="Calibri"/>
               </a:rPr>
-              <a:t>86</a:t>
+              <a:t>97</a:t>
             </a:r>
           </a:p>
         </p:txBody>
@@ -5337,7 +5337,7 @@
                 </a:solidFill>
                 <a:latin typeface="Calibri"/>
               </a:rPr>
-              <a:t>Banking · Payments · Open Banking</a:t>
+              <a:t>Banking · Payments · Regulation</a:t>
             </a:r>
           </a:p>
         </p:txBody>
@@ -5372,7 +5372,7 @@
                 </a:solidFill>
                 <a:latin typeface="Calibri"/>
               </a:rPr>
-              <a:t>§35–41, §70–71</a:t>
+              <a:t>§35–41, §66–70, §84, §86–88</a:t>
             </a:r>
           </a:p>
         </p:txBody>
@@ -5452,7 +5452,7 @@
                 </a:solidFill>
                 <a:latin typeface="Calibri"/>
               </a:rPr>
-              <a:t>PSD2 · MTD HMRC · WCAG · FPS/BACS/CHAPS/SWIFT · KYC/AML · Companies House · Financial Inclusion</a:t>
+              <a:t>PSD2 · FPS/BACS/CHAPS/SWIFT · PSR · FCA Consumer Duty · AML · Ring-Fencing · SCA · BCOBS · FCA Compliance · UK Resolution · Post-Trade</a:t>
             </a:r>
           </a:p>
         </p:txBody>
@@ -5530,7 +5530,7 @@
                 </a:solidFill>
                 <a:latin typeface="Calibri"/>
               </a:rPr>
-              <a:t>FCA Regulation</a:t>
+              <a:t>Prudential &amp; Market Regulation</a:t>
             </a:r>
           </a:p>
         </p:txBody>
@@ -5565,7 +5565,7 @@
                 </a:solidFill>
                 <a:latin typeface="Calibri"/>
               </a:rPr>
-              <a:t>§66–70</a:t>
+              <a:t>§36–40, §87–88</a:t>
             </a:r>
           </a:p>
         </p:txBody>
@@ -5645,7 +5645,7 @@
                 </a:solidFill>
                 <a:latin typeface="Calibri"/>
               </a:rPr>
-              <a:t>Consumer Duty PS22/9 · AML MLR 2017 · Ring-Fencing FSMA · BCOBS/CASS · SCA/UK-RTS exemptions</a:t>
+              <a:t>PRA/PRC · Basel 3.1 · SS19/13 Resolution Planning · MREL · CNRF · Deposit Aggregators · LEI/SSI · KYC Passporting · Post-Trade Task Force</a:t>
             </a:r>
           </a:p>
         </p:txBody>
@@ -5951,7 +5951,7 @@
                 </a:solidFill>
                 <a:latin typeface="Calibri"/>
               </a:rPr>
-              <a:t>§11, §26, §42, §50–56</a:t>
+              <a:t>§11, §26, §42, §50–56, §78–81</a:t>
             </a:r>
           </a:p>
         </p:txBody>
@@ -6031,7 +6031,7 @@
                 </a:solidFill>
                 <a:latin typeface="Calibri"/>
               </a:rPr>
-              <a:t>React/JS patterns · Refactoring UI · Tailwind CSS v3 · CSS Animation · Vite/TS · React 19 · UX · Photoshop · KiCad</a:t>
+              <a:t>React/JS patterns · Refactoring UI · Tailwind CSS v3 (×3 books) · CSS Animation · Vite/TS · React 19 · React Hooks (Larsen) · UX · Photoshop · KiCad</a:t>
             </a:r>
           </a:p>
         </p:txBody>
@@ -6688,7 +6688,7 @@
                 </a:solidFill>
                 <a:latin typeface="Calibri"/>
               </a:rPr>
-              <a:t>Quick Lookup Decision Index</a:t>
+              <a:t>Digital Banking Transformation</a:t>
             </a:r>
           </a:p>
         </p:txBody>
@@ -6723,7 +6723,7 @@
                 </a:solidFill>
                 <a:latin typeface="Calibri"/>
               </a:rPr>
-              <a:t>NEW — Jun 2026</a:t>
+              <a:t>§82, §83, §85</a:t>
             </a:r>
           </a:p>
         </p:txBody>
@@ -6803,7 +6803,7 @@
                 </a:solidFill>
                 <a:latin typeface="Calibri"/>
               </a:rPr>
-              <a:t>70+ answers · 8 themed tables · Design rules · Payment rails · GDPR deadlines · FCA rules · SCA · AI prompt modes</a:t>
+              <a:t>DBS World's Best Bank (Speculand) · The Autonomous Bank AI/ML (Dhillon) · TMRW Digital Bank Build (Khoo/UOB) · Quick Lookup Decision Index</a:t>
             </a:r>
           </a:p>
         </p:txBody>
@@ -14949,7 +14949,7 @@
                 </a:solidFill>
                 <a:latin typeface="Calibri"/>
               </a:rPr>
-              <a:t>Reference library (77 sections · Quick Lookup index)</a:t>
+              <a:t>Reference library (88 sections · Quick Lookup index)</a:t>
             </a:r>
           </a:p>
         </p:txBody>

</xml_diff>

<commit_message>
Add §89 Geometrical Tolerancing (ISO GD&T) to REFERENCE.md
Distilled The Geometrical Tolerancing Desk Reference (Paul Green, Elsevier,
ISBN 9780080460857) into §89 — 436 lines covering all 15 geometric
characteristics (form/profile/orientation/location/runout), tolerance frame
structure, datum system, MMC/LMC, envelope requirement, ISO 2768 general
tolerances, and KiCad/PCB relevance. Joins the Electronics/Hardware cluster
(§43-49, §54, §57).

Stats: 98 books & regulatory docs · 89 sections · 22,128 lines.

Co-Authored-By: Claude Opus 4.8 <noreply@anthropic.com>
Claude-Session: https://claude.ai/code/session_012EFETGbhdxdnPCjpmQ9UDz
</commit_message>
<xml_diff>
--- a/Santander_Project_Record.pptx
+++ b/Santander_Project_Record.pptx
@@ -4378,7 +4378,7 @@
                 </a:solidFill>
                 <a:latin typeface="Calibri"/>
               </a:rPr>
-              <a:t>21,689 lines · 88 sections · 97 books &amp; regulatory documents · Quick Lookup decision index</a:t>
+              <a:t>22,128 lines · 89 sections · 98 books &amp; regulatory documents · Quick Lookup decision index</a:t>
             </a:r>
           </a:p>
         </p:txBody>
@@ -4499,7 +4499,7 @@
                 </a:solidFill>
                 <a:latin typeface="Calibri"/>
               </a:rPr>
-              <a:t>21,689</a:t>
+              <a:t>22,128</a:t>
             </a:r>
           </a:p>
         </p:txBody>
@@ -4612,7 +4612,7 @@
                 </a:solidFill>
                 <a:latin typeface="Calibri"/>
               </a:rPr>
-              <a:t>88</a:t>
+              <a:t>89</a:t>
             </a:r>
           </a:p>
         </p:txBody>
@@ -4725,7 +4725,7 @@
                 </a:solidFill>
                 <a:latin typeface="Calibri"/>
               </a:rPr>
-              <a:t>97</a:t>
+              <a:t>98</a:t>
             </a:r>
           </a:p>
         </p:txBody>
@@ -6530,7 +6530,7 @@
                 </a:solidFill>
                 <a:latin typeface="Calibri"/>
               </a:rPr>
-              <a:t>§43–49, §54, §57</a:t>
+              <a:t>§43–49, §54, §57, §89</a:t>
             </a:r>
           </a:p>
         </p:txBody>
@@ -6610,7 +6610,7 @@
                 </a:solidFill>
                 <a:latin typeface="Calibri"/>
               </a:rPr>
-              <a:t>MakerSpace · Electronics · Mechatronics · Digital Logic · Devices &amp; Circuits · Arduino/IoT · Embedded Linux</a:t>
+              <a:t>MakerSpace · Electronics · Mechatronics · Digital Logic · Devices &amp; Circuits · Arduino/IoT · Embedded Linux · ISO GD&amp;T (Green)</a:t>
             </a:r>
           </a:p>
         </p:txBody>
@@ -14949,7 +14949,7 @@
                 </a:solidFill>
                 <a:latin typeface="Calibri"/>
               </a:rPr>
-              <a:t>Reference library (88 sections · Quick Lookup index)</a:t>
+              <a:t>Reference library (89 sections · Quick Lookup index)</a:t>
             </a:r>
           </a:p>
         </p:txBody>

</xml_diff>

<commit_message>
Add §86.33–§86.34: digital wallets and cryptoassets to REFERENCE.md
§86.33 — Digital and Mobile Wallets
  Apple Pay / Google Pay / Samsung Pay: tokenisation on card rails, not new payment
  systems. Biometric SCA lifts contactless limit. FCA regulates e-money wallets (EMIs).
  PSR competition concern: Apple NFC restriction. BNPL in wallets (Klarna/Apple Pay).
  Protection: same as underlying card (chargeback/Section 75 for credit).

§86.34 — Cryptoassets
  Not PSR-designated. FCA via MLR 2017 (AML registration), FPO (promo rules Oct 2023).
  FSCS: none. Chargeback: none. PS23/3: none. Consumer protection: minimal.
  Stablecoin regime: FSMA 2023 powers; FCA consultation 2024; PSR potential future role.
  Digital pound (CBDC): Bank of England/HMT consultation 2023; no decision; pre-2030.

Completes the PSR Ways of Paying page coverage (§86.27–§86.34).
Stats updated: 22,692 lines. Manifest PPTX rebuilt.

Co-Authored-By: Claude <noreply@anthropic.com>
</commit_message>
<xml_diff>
--- a/Santander_Project_Record.pptx
+++ b/Santander_Project_Record.pptx
@@ -4378,7 +4378,7 @@
                 </a:solidFill>
                 <a:latin typeface="Calibri"/>
               </a:rPr>
-              <a:t>22,590 lines · 89 sections · 98 books &amp; regulatory documents · Quick Lookup decision index</a:t>
+              <a:t>22,692 lines · 89 sections · 98 books &amp; regulatory documents · Quick Lookup decision index</a:t>
             </a:r>
           </a:p>
         </p:txBody>
@@ -4499,7 +4499,7 @@
                 </a:solidFill>
                 <a:latin typeface="Calibri"/>
               </a:rPr>
-              <a:t>22,590</a:t>
+              <a:t>22,692</a:t>
             </a:r>
           </a:p>
         </p:txBody>

</xml_diff>

<commit_message>
Update Project Record deck and MANIFEST for complaint workflow additions
- Workflow count: 11 → 12 (complaint handling workflow added)
- Slide 1 stat box: 11 → 12 workflows
- Slide 4: Eleven → Twelve Workflow Wizards + complaint entry
- Slide 10: reference library stats corrected to 90 sections / 99 books
- Slide 11: complaint tools added to npm commands
- Slide 12: Project Record updated to 14 slides
- Slide 13 (new): Complaint Handling Tools — all 4 tools with descriptions
- Slide 14: Business Case (renumbered from 13)
- MANIFEST.md §7 (new): complaint tools section + trigger phrase table

Co-Authored-By: Claude Opus 4.8 <noreply@anthropic.com>
Claude-Session: https://claude.ai/code/session_012EFETGbhdxdnPCjpmQ9UDz
</commit_message>
<xml_diff>
--- a/Santander_Project_Record.pptx
+++ b/Santander_Project_Record.pptx
@@ -18,6 +18,7 @@
     <p:sldId id="266" r:id="rId17"/>
     <p:sldId id="267" r:id="rId18"/>
     <p:sldId id="268" r:id="rId19"/>
+    <p:sldId id="269" r:id="rId20"/>
   </p:sldIdLst>
   <p:sldSz cx="12188952" cy="6858000" type="screen4x3"/>
   <p:notesSz cx="6858000" cy="9144000"/>
@@ -3822,7 +3823,7 @@
                 </a:solidFill>
                 <a:latin typeface="Calibri"/>
               </a:rPr>
-              <a:t>11</a:t>
+              <a:t>12</a:t>
             </a:r>
           </a:p>
         </p:txBody>
@@ -4378,7 +4379,7 @@
                 </a:solidFill>
                 <a:latin typeface="Calibri"/>
               </a:rPr>
-              <a:t>22,935 lines · 90 sections · 99 books &amp; regulatory documents · Quick Lookup decision index</a:t>
+              <a:t>22,935 lines · 90 sections · 99 books &amp; regulatory documents · §90 complaint handling framework</a:t>
             </a:r>
           </a:p>
         </p:txBody>
@@ -4612,7 +4613,7 @@
                 </a:solidFill>
                 <a:latin typeface="Calibri"/>
               </a:rPr>
-              <a:t>89</a:t>
+              <a:t>90</a:t>
             </a:r>
           </a:p>
         </p:txBody>
@@ -4725,7 +4726,7 @@
                 </a:solidFill>
                 <a:latin typeface="Calibri"/>
               </a:rPr>
-              <a:t>98</a:t>
+              <a:t>99</a:t>
             </a:r>
           </a:p>
         </p:txBody>
@@ -9722,7 +9723,7 @@
                 </a:solidFill>
                 <a:latin typeface="Calibri"/>
               </a:rPr>
-              <a:t>Regenerate this project record (13 slides)</a:t>
+              <a:t>Regenerate this project record (14 slides)</a:t>
             </a:r>
           </a:p>
         </p:txBody>
@@ -9730,6 +9731,236 @@
       <p:sp>
         <p:nvSpPr>
           <p:cNvPr id="74" name="Rectangle 73"/>
+          <p:cNvSpPr/>
+          <p:nvPr/>
+        </p:nvSpPr>
+        <p:spPr>
+          <a:xfrm>
+            <a:off x="566928" y="6345936"/>
+            <a:ext cx="4937760" cy="274320"/>
+          </a:xfrm>
+          <a:prstGeom prst="rect">
+            <a:avLst/>
+          </a:prstGeom>
+          <a:solidFill>
+            <a:srgbClr val="FFFFFF"/>
+          </a:solidFill>
+          <a:ln w="9525">
+            <a:solidFill>
+              <a:srgbClr val="E7E5E4"/>
+            </a:solidFill>
+          </a:ln>
+        </p:spPr>
+        <p:style>
+          <a:lnRef idx="1">
+            <a:schemeClr val="accent1"/>
+          </a:lnRef>
+          <a:fillRef idx="3">
+            <a:schemeClr val="accent1"/>
+          </a:fillRef>
+          <a:effectRef idx="2">
+            <a:schemeClr val="accent1"/>
+          </a:effectRef>
+          <a:fontRef idx="minor">
+            <a:schemeClr val="lt1"/>
+          </a:fontRef>
+        </p:style>
+        <p:txBody>
+          <a:bodyPr rtlCol="0" anchor="ctr"/>
+          <a:lstStyle/>
+          <a:p>
+            <a:pPr algn="ctr"/>
+          </a:p>
+        </p:txBody>
+      </p:sp>
+      <p:sp>
+        <p:nvSpPr>
+          <p:cNvPr id="75" name="TextBox 74"/>
+          <p:cNvSpPr txBox="1"/>
+          <p:nvPr/>
+        </p:nvSpPr>
+        <p:spPr>
+          <a:xfrm>
+            <a:off x="658368" y="6382512"/>
+            <a:ext cx="1920240" cy="210312"/>
+          </a:xfrm>
+          <a:prstGeom prst="rect">
+            <a:avLst/>
+          </a:prstGeom>
+          <a:noFill/>
+        </p:spPr>
+        <p:txBody>
+          <a:bodyPr wrap="square">
+            <a:noAutofit/>
+          </a:bodyPr>
+          <a:lstStyle/>
+          <a:p>
+            <a:pPr algn="l"/>
+            <a:r>
+              <a:rPr sz="800" b="1" i="0">
+                <a:solidFill>
+                  <a:srgbClr val="1C1917"/>
+                </a:solidFill>
+                <a:latin typeface="Calibri"/>
+              </a:rPr>
+              <a:t>python3 build_complaint_guide.py</a:t>
+            </a:r>
+          </a:p>
+        </p:txBody>
+      </p:sp>
+      <p:sp>
+        <p:nvSpPr>
+          <p:cNvPr id="76" name="TextBox 75"/>
+          <p:cNvSpPr txBox="1"/>
+          <p:nvPr/>
+        </p:nvSpPr>
+        <p:spPr>
+          <a:xfrm>
+            <a:off x="2606040" y="6382512"/>
+            <a:ext cx="2834640" cy="210312"/>
+          </a:xfrm>
+          <a:prstGeom prst="rect">
+            <a:avLst/>
+          </a:prstGeom>
+          <a:noFill/>
+        </p:spPr>
+        <p:txBody>
+          <a:bodyPr wrap="square">
+            <a:noAutofit/>
+          </a:bodyPr>
+          <a:lstStyle/>
+          <a:p>
+            <a:pPr algn="l"/>
+            <a:r>
+              <a:rPr sz="800" b="0" i="0">
+                <a:solidFill>
+                  <a:srgbClr val="78716C"/>
+                </a:solidFill>
+                <a:latin typeface="Calibri"/>
+              </a:rPr>
+              <a:t>Regenerate Santander_Complaint_Guide.docx</a:t>
+            </a:r>
+          </a:p>
+        </p:txBody>
+      </p:sp>
+      <p:sp>
+        <p:nvSpPr>
+          <p:cNvPr id="77" name="Rectangle 76"/>
+          <p:cNvSpPr/>
+          <p:nvPr/>
+        </p:nvSpPr>
+        <p:spPr>
+          <a:xfrm>
+            <a:off x="566928" y="6620256"/>
+            <a:ext cx="4937760" cy="274320"/>
+          </a:xfrm>
+          <a:prstGeom prst="rect">
+            <a:avLst/>
+          </a:prstGeom>
+          <a:solidFill>
+            <a:srgbClr val="F5F5F4"/>
+          </a:solidFill>
+          <a:ln w="9525">
+            <a:solidFill>
+              <a:srgbClr val="E7E5E4"/>
+            </a:solidFill>
+          </a:ln>
+        </p:spPr>
+        <p:style>
+          <a:lnRef idx="1">
+            <a:schemeClr val="accent1"/>
+          </a:lnRef>
+          <a:fillRef idx="3">
+            <a:schemeClr val="accent1"/>
+          </a:fillRef>
+          <a:effectRef idx="2">
+            <a:schemeClr val="accent1"/>
+          </a:effectRef>
+          <a:fontRef idx="minor">
+            <a:schemeClr val="lt1"/>
+          </a:fontRef>
+        </p:style>
+        <p:txBody>
+          <a:bodyPr rtlCol="0" anchor="ctr"/>
+          <a:lstStyle/>
+          <a:p>
+            <a:pPr algn="ctr"/>
+          </a:p>
+        </p:txBody>
+      </p:sp>
+      <p:sp>
+        <p:nvSpPr>
+          <p:cNvPr id="78" name="TextBox 77"/>
+          <p:cNvSpPr txBox="1"/>
+          <p:nvPr/>
+        </p:nvSpPr>
+        <p:spPr>
+          <a:xfrm>
+            <a:off x="658368" y="6656832"/>
+            <a:ext cx="1920240" cy="210312"/>
+          </a:xfrm>
+          <a:prstGeom prst="rect">
+            <a:avLst/>
+          </a:prstGeom>
+          <a:noFill/>
+        </p:spPr>
+        <p:txBody>
+          <a:bodyPr wrap="square">
+            <a:noAutofit/>
+          </a:bodyPr>
+          <a:lstStyle/>
+          <a:p>
+            <a:pPr algn="l"/>
+            <a:r>
+              <a:rPr sz="800" b="1" i="0">
+                <a:solidFill>
+                  <a:srgbClr val="1C1917"/>
+                </a:solidFill>
+                <a:latin typeface="Calibri"/>
+              </a:rPr>
+              <a:t>python3 complaint_letter_writer.py</a:t>
+            </a:r>
+          </a:p>
+        </p:txBody>
+      </p:sp>
+      <p:sp>
+        <p:nvSpPr>
+          <p:cNvPr id="79" name="TextBox 78"/>
+          <p:cNvSpPr txBox="1"/>
+          <p:nvPr/>
+        </p:nvSpPr>
+        <p:spPr>
+          <a:xfrm>
+            <a:off x="2606040" y="6656832"/>
+            <a:ext cx="2834640" cy="210312"/>
+          </a:xfrm>
+          <a:prstGeom prst="rect">
+            <a:avLst/>
+          </a:prstGeom>
+          <a:noFill/>
+        </p:spPr>
+        <p:txBody>
+          <a:bodyPr wrap="square">
+            <a:noAutofit/>
+          </a:bodyPr>
+          <a:lstStyle/>
+          <a:p>
+            <a:pPr algn="l"/>
+            <a:r>
+              <a:rPr sz="800" b="0" i="0">
+                <a:solidFill>
+                  <a:srgbClr val="78716C"/>
+                </a:solidFill>
+                <a:latin typeface="Calibri"/>
+              </a:rPr>
+              <a:t>Interactive FCA DISP letter writer (Evelyn/Angus)</a:t>
+            </a:r>
+          </a:p>
+        </p:txBody>
+      </p:sp>
+      <p:sp>
+        <p:nvSpPr>
+          <p:cNvPr id="80" name="Rectangle 79"/>
           <p:cNvSpPr/>
           <p:nvPr/>
         </p:nvSpPr>
@@ -9774,7 +10005,7 @@
       </p:sp>
       <p:sp>
         <p:nvSpPr>
-          <p:cNvPr id="75" name="Rectangle 74"/>
+          <p:cNvPr id="81" name="Rectangle 80"/>
           <p:cNvSpPr/>
           <p:nvPr/>
         </p:nvSpPr>
@@ -9817,7 +10048,7 @@
       </p:sp>
       <p:sp>
         <p:nvSpPr>
-          <p:cNvPr id="76" name="TextBox 75"/>
+          <p:cNvPr id="82" name="TextBox 81"/>
           <p:cNvSpPr txBox="1"/>
           <p:nvPr/>
         </p:nvSpPr>
@@ -9852,7 +10083,7 @@
       </p:sp>
       <p:sp>
         <p:nvSpPr>
-          <p:cNvPr id="77" name="TextBox 76"/>
+          <p:cNvPr id="83" name="TextBox 82"/>
           <p:cNvSpPr txBox="1"/>
           <p:nvPr/>
         </p:nvSpPr>
@@ -9955,7 +10186,7 @@
       </p:sp>
       <p:sp>
         <p:nvSpPr>
-          <p:cNvPr id="78" name="Rectangle 77"/>
+          <p:cNvPr id="84" name="Rectangle 83"/>
           <p:cNvSpPr/>
           <p:nvPr/>
         </p:nvSpPr>
@@ -9998,7 +10229,7 @@
       </p:sp>
       <p:sp>
         <p:nvSpPr>
-          <p:cNvPr id="79" name="TextBox 78"/>
+          <p:cNvPr id="85" name="TextBox 84"/>
           <p:cNvSpPr txBox="1"/>
           <p:nvPr/>
         </p:nvSpPr>
@@ -10033,7 +10264,7 @@
       </p:sp>
       <p:sp>
         <p:nvSpPr>
-          <p:cNvPr id="80" name="TextBox 79"/>
+          <p:cNvPr id="86" name="TextBox 85"/>
           <p:cNvSpPr txBox="1"/>
           <p:nvPr/>
         </p:nvSpPr>
@@ -13741,7 +13972,7 @@
                 </a:solidFill>
                 <a:latin typeface="Calibri"/>
               </a:rPr>
-              <a:t>Project Record · 13 slides (this deck)</a:t>
+              <a:t>Project Record · 14 slides (this deck)</a:t>
             </a:r>
           </a:p>
         </p:txBody>
@@ -14271,7 +14502,7 @@
                 </a:solidFill>
                 <a:latin typeface="Calibri"/>
               </a:rPr>
-              <a:t>Eleven workflows</a:t>
+              <a:t>Twelve workflows</a:t>
             </a:r>
           </a:p>
         </p:txBody>
@@ -14949,7 +15180,7 @@
                 </a:solidFill>
                 <a:latin typeface="Calibri"/>
               </a:rPr>
-              <a:t>Reference library (90 sections · Quick Lookup index)</a:t>
+              <a:t>Reference library (90 sections · §90 complaints)</a:t>
             </a:r>
           </a:p>
         </p:txBody>
@@ -15175,6 +15406,232 @@
                 </a:solidFill>
                 <a:latin typeface="Calibri"/>
               </a:rPr>
+              <a:t>Presentation deliverables</a:t>
+            </a:r>
+          </a:p>
+        </p:txBody>
+      </p:sp>
+      <p:sp>
+        <p:nvSpPr>
+          <p:cNvPr id="136" name="Rectangle 135"/>
+          <p:cNvSpPr/>
+          <p:nvPr/>
+        </p:nvSpPr>
+        <p:spPr>
+          <a:xfrm>
+            <a:off x="8449056" y="4937759"/>
+            <a:ext cx="475488" cy="237744"/>
+          </a:xfrm>
+          <a:prstGeom prst="rect">
+            <a:avLst/>
+          </a:prstGeom>
+          <a:solidFill>
+            <a:srgbClr val="F5F5F4"/>
+          </a:solidFill>
+          <a:ln>
+            <a:noFill/>
+          </a:ln>
+        </p:spPr>
+        <p:style>
+          <a:lnRef idx="1">
+            <a:schemeClr val="accent1"/>
+          </a:lnRef>
+          <a:fillRef idx="3">
+            <a:schemeClr val="accent1"/>
+          </a:fillRef>
+          <a:effectRef idx="2">
+            <a:schemeClr val="accent1"/>
+          </a:effectRef>
+          <a:fontRef idx="minor">
+            <a:schemeClr val="lt1"/>
+          </a:fontRef>
+        </p:style>
+        <p:txBody>
+          <a:bodyPr rtlCol="0" anchor="ctr"/>
+          <a:lstStyle/>
+          <a:p>
+            <a:pPr algn="ctr"/>
+          </a:p>
+        </p:txBody>
+      </p:sp>
+      <p:sp>
+        <p:nvSpPr>
+          <p:cNvPr id="137" name="TextBox 136"/>
+          <p:cNvSpPr txBox="1"/>
+          <p:nvPr/>
+        </p:nvSpPr>
+        <p:spPr>
+          <a:xfrm>
+            <a:off x="8467344" y="4965192"/>
+            <a:ext cx="457200" cy="201168"/>
+          </a:xfrm>
+          <a:prstGeom prst="rect">
+            <a:avLst/>
+          </a:prstGeom>
+          <a:noFill/>
+        </p:spPr>
+        <p:txBody>
+          <a:bodyPr wrap="square">
+            <a:noAutofit/>
+          </a:bodyPr>
+          <a:lstStyle/>
+          <a:p>
+            <a:pPr algn="l"/>
+            <a:r>
+              <a:rPr sz="750" b="1" i="0">
+                <a:solidFill>
+                  <a:srgbClr val="44403C"/>
+                </a:solidFill>
+                <a:latin typeface="Calibri"/>
+              </a:rPr>
+              <a:t>Slide 13</a:t>
+            </a:r>
+          </a:p>
+        </p:txBody>
+      </p:sp>
+      <p:sp>
+        <p:nvSpPr>
+          <p:cNvPr id="138" name="TextBox 137"/>
+          <p:cNvSpPr txBox="1"/>
+          <p:nvPr/>
+        </p:nvSpPr>
+        <p:spPr>
+          <a:xfrm>
+            <a:off x="8970264" y="4965192"/>
+            <a:ext cx="3017520" cy="201168"/>
+          </a:xfrm>
+          <a:prstGeom prst="rect">
+            <a:avLst/>
+          </a:prstGeom>
+          <a:noFill/>
+        </p:spPr>
+        <p:txBody>
+          <a:bodyPr wrap="square">
+            <a:noAutofit/>
+          </a:bodyPr>
+          <a:lstStyle/>
+          <a:p>
+            <a:pPr algn="l"/>
+            <a:r>
+              <a:rPr sz="800" b="0" i="0">
+                <a:solidFill>
+                  <a:srgbClr val="1C1917"/>
+                </a:solidFill>
+                <a:latin typeface="Calibri"/>
+              </a:rPr>
+              <a:t>Complaint handling tools (Evelyn/Angus)</a:t>
+            </a:r>
+          </a:p>
+        </p:txBody>
+      </p:sp>
+      <p:sp>
+        <p:nvSpPr>
+          <p:cNvPr id="139" name="Rectangle 138"/>
+          <p:cNvSpPr/>
+          <p:nvPr/>
+        </p:nvSpPr>
+        <p:spPr>
+          <a:xfrm>
+            <a:off x="8449056" y="5202936"/>
+            <a:ext cx="475488" cy="237744"/>
+          </a:xfrm>
+          <a:prstGeom prst="rect">
+            <a:avLst/>
+          </a:prstGeom>
+          <a:solidFill>
+            <a:srgbClr val="F5F5F4"/>
+          </a:solidFill>
+          <a:ln>
+            <a:noFill/>
+          </a:ln>
+        </p:spPr>
+        <p:style>
+          <a:lnRef idx="1">
+            <a:schemeClr val="accent1"/>
+          </a:lnRef>
+          <a:fillRef idx="3">
+            <a:schemeClr val="accent1"/>
+          </a:fillRef>
+          <a:effectRef idx="2">
+            <a:schemeClr val="accent1"/>
+          </a:effectRef>
+          <a:fontRef idx="minor">
+            <a:schemeClr val="lt1"/>
+          </a:fontRef>
+        </p:style>
+        <p:txBody>
+          <a:bodyPr rtlCol="0" anchor="ctr"/>
+          <a:lstStyle/>
+          <a:p>
+            <a:pPr algn="ctr"/>
+          </a:p>
+        </p:txBody>
+      </p:sp>
+      <p:sp>
+        <p:nvSpPr>
+          <p:cNvPr id="140" name="TextBox 139"/>
+          <p:cNvSpPr txBox="1"/>
+          <p:nvPr/>
+        </p:nvSpPr>
+        <p:spPr>
+          <a:xfrm>
+            <a:off x="8467344" y="5230368"/>
+            <a:ext cx="457200" cy="201168"/>
+          </a:xfrm>
+          <a:prstGeom prst="rect">
+            <a:avLst/>
+          </a:prstGeom>
+          <a:noFill/>
+        </p:spPr>
+        <p:txBody>
+          <a:bodyPr wrap="square">
+            <a:noAutofit/>
+          </a:bodyPr>
+          <a:lstStyle/>
+          <a:p>
+            <a:pPr algn="l"/>
+            <a:r>
+              <a:rPr sz="750" b="1" i="0">
+                <a:solidFill>
+                  <a:srgbClr val="44403C"/>
+                </a:solidFill>
+                <a:latin typeface="Calibri"/>
+              </a:rPr>
+              <a:t>Slide 14</a:t>
+            </a:r>
+          </a:p>
+        </p:txBody>
+      </p:sp>
+      <p:sp>
+        <p:nvSpPr>
+          <p:cNvPr id="141" name="TextBox 140"/>
+          <p:cNvSpPr txBox="1"/>
+          <p:nvPr/>
+        </p:nvSpPr>
+        <p:spPr>
+          <a:xfrm>
+            <a:off x="8970264" y="5230368"/>
+            <a:ext cx="3017520" cy="201168"/>
+          </a:xfrm>
+          <a:prstGeom prst="rect">
+            <a:avLst/>
+          </a:prstGeom>
+          <a:noFill/>
+        </p:spPr>
+        <p:txBody>
+          <a:bodyPr wrap="square">
+            <a:noAutofit/>
+          </a:bodyPr>
+          <a:lstStyle/>
+          <a:p>
+            <a:pPr algn="l"/>
+            <a:r>
+              <a:rPr sz="800" b="0" i="0">
+                <a:solidFill>
+                  <a:srgbClr val="1C1917"/>
+                </a:solidFill>
+                <a:latin typeface="Calibri"/>
+              </a:rPr>
               <a:t>Business case summary</a:t>
             </a:r>
           </a:p>
@@ -15182,7 +15639,7 @@
       </p:sp>
       <p:sp>
         <p:nvSpPr>
-          <p:cNvPr id="136" name="TextBox 135"/>
+          <p:cNvPr id="142" name="TextBox 141"/>
           <p:cNvSpPr txBox="1"/>
           <p:nvPr/>
         </p:nvSpPr>
@@ -15217,7 +15674,7 @@
       </p:sp>
       <p:sp>
         <p:nvSpPr>
-          <p:cNvPr id="137" name="Rectangle 136"/>
+          <p:cNvPr id="143" name="Rectangle 142"/>
           <p:cNvSpPr/>
           <p:nvPr/>
         </p:nvSpPr>
@@ -15260,7 +15717,7 @@
       </p:sp>
       <p:sp>
         <p:nvSpPr>
-          <p:cNvPr id="138" name="TextBox 137"/>
+          <p:cNvPr id="144" name="TextBox 143"/>
           <p:cNvSpPr txBox="1"/>
           <p:nvPr/>
         </p:nvSpPr>
@@ -15295,7 +15752,7 @@
       </p:sp>
       <p:sp>
         <p:nvSpPr>
-          <p:cNvPr id="139" name="TextBox 138"/>
+          <p:cNvPr id="145" name="TextBox 144"/>
           <p:cNvSpPr txBox="1"/>
           <p:nvPr/>
         </p:nvSpPr>
@@ -15361,7 +15818,7 @@
             <a:avLst/>
           </a:prstGeom>
           <a:solidFill>
-            <a:srgbClr val="1C1917"/>
+            <a:srgbClr val="FAF6EF"/>
           </a:solidFill>
           <a:ln>
             <a:noFill/>
@@ -15398,7 +15855,7 @@
         <p:spPr>
           <a:xfrm>
             <a:off x="0" y="0"/>
-            <a:ext cx="12188952" cy="64008"/>
+            <a:ext cx="12188952" cy="54864"/>
           </a:xfrm>
           <a:prstGeom prst="rect">
             <a:avLst/>
@@ -15440,8 +15897,8 @@
         </p:nvSpPr>
         <p:spPr>
           <a:xfrm>
-            <a:off x="548640" y="201168"/>
-            <a:ext cx="9144000" cy="411480"/>
+            <a:off x="457200" y="137160"/>
+            <a:ext cx="10972800" cy="475488"/>
           </a:xfrm>
           <a:prstGeom prst="rect">
             <a:avLst/>
@@ -15458,11 +15915,11 @@
             <a:r>
               <a:rPr sz="2200" b="1" i="0">
                 <a:solidFill>
-                  <a:srgbClr val="FFFFFF"/>
-                </a:solidFill>
-                <a:latin typeface="Calibri"/>
-              </a:rPr>
-              <a:t>Business Case Summary</a:t>
+                  <a:srgbClr val="1C1917"/>
+                </a:solidFill>
+                <a:latin typeface="Calibri"/>
+              </a:rPr>
+              <a:t>Complaint Handling Tools — Evelyn Workflow (Angus)</a:t>
             </a:r>
           </a:p>
         </p:txBody>
@@ -15475,7 +15932,7 @@
         </p:nvSpPr>
         <p:spPr>
           <a:xfrm>
-            <a:off x="548640" y="640080"/>
+            <a:off x="457200" y="621792"/>
             <a:ext cx="10972800" cy="274320"/>
           </a:xfrm>
           <a:prstGeom prst="rect">
@@ -15491,13 +15948,13 @@
           <a:p>
             <a:pPr algn="l"/>
             <a:r>
-              <a:rPr sz="1200" b="0" i="1">
+              <a:rPr sz="1100" b="0" i="0">
                 <a:solidFill>
                   <a:srgbClr val="78716C"/>
                 </a:solidFill>
                 <a:latin typeface="Calibri"/>
               </a:rPr>
-              <a:t>Phase 1 complete. Phase 2 awaiting stakeholder approval. Zero days to readiness.</a:t>
+              <a:t>FCA DISP-compliant complaint record, letter writing, and Copilot agent — built alongside the in-app workflow</a:t>
             </a:r>
           </a:p>
         </p:txBody>
@@ -15510,8 +15967,96 @@
         </p:nvSpPr>
         <p:spPr>
           <a:xfrm>
-            <a:off x="548640" y="960120"/>
-            <a:ext cx="11064240" cy="18288"/>
+            <a:off x="457200" y="896112"/>
+            <a:ext cx="11274552" cy="16459"/>
+          </a:xfrm>
+          <a:prstGeom prst="rect">
+            <a:avLst/>
+          </a:prstGeom>
+          <a:solidFill>
+            <a:srgbClr val="D6D3D1"/>
+          </a:solidFill>
+          <a:ln>
+            <a:noFill/>
+          </a:ln>
+        </p:spPr>
+        <p:style>
+          <a:lnRef idx="1">
+            <a:schemeClr val="accent1"/>
+          </a:lnRef>
+          <a:fillRef idx="3">
+            <a:schemeClr val="accent1"/>
+          </a:fillRef>
+          <a:effectRef idx="2">
+            <a:schemeClr val="accent1"/>
+          </a:effectRef>
+          <a:fontRef idx="minor">
+            <a:schemeClr val="lt1"/>
+          </a:fontRef>
+        </p:style>
+        <p:txBody>
+          <a:bodyPr rtlCol="0" anchor="ctr"/>
+          <a:lstStyle/>
+          <a:p>
+            <a:pPr algn="ctr"/>
+          </a:p>
+        </p:txBody>
+      </p:sp>
+      <p:sp>
+        <p:nvSpPr>
+          <p:cNvPr id="7" name="Rectangle 6"/>
+          <p:cNvSpPr/>
+          <p:nvPr/>
+        </p:nvSpPr>
+        <p:spPr>
+          <a:xfrm>
+            <a:off x="274320" y="1024128"/>
+            <a:ext cx="2816352" cy="4919472"/>
+          </a:xfrm>
+          <a:prstGeom prst="rect">
+            <a:avLst/>
+          </a:prstGeom>
+          <a:solidFill>
+            <a:srgbClr val="FFFFFF"/>
+          </a:solidFill>
+          <a:ln w="9525">
+            <a:solidFill>
+              <a:srgbClr val="E7E5E4"/>
+            </a:solidFill>
+          </a:ln>
+        </p:spPr>
+        <p:style>
+          <a:lnRef idx="1">
+            <a:schemeClr val="accent1"/>
+          </a:lnRef>
+          <a:fillRef idx="3">
+            <a:schemeClr val="accent1"/>
+          </a:fillRef>
+          <a:effectRef idx="2">
+            <a:schemeClr val="accent1"/>
+          </a:effectRef>
+          <a:fontRef idx="minor">
+            <a:schemeClr val="lt1"/>
+          </a:fontRef>
+        </p:style>
+        <p:txBody>
+          <a:bodyPr rtlCol="0" anchor="ctr"/>
+          <a:lstStyle/>
+          <a:p>
+            <a:pPr algn="ctr"/>
+          </a:p>
+        </p:txBody>
+      </p:sp>
+      <p:sp>
+        <p:nvSpPr>
+          <p:cNvPr id="8" name="Rectangle 7"/>
+          <p:cNvSpPr/>
+          <p:nvPr/>
+        </p:nvSpPr>
+        <p:spPr>
+          <a:xfrm>
+            <a:off x="274320" y="1024128"/>
+            <a:ext cx="2816352" cy="64008"/>
           </a:xfrm>
           <a:prstGeom prst="rect">
             <a:avLst/>
@@ -15547,6 +16092,1707 @@
       </p:sp>
       <p:sp>
         <p:nvSpPr>
+          <p:cNvPr id="9" name="TextBox 8"/>
+          <p:cNvSpPr txBox="1"/>
+          <p:nvPr/>
+        </p:nvSpPr>
+        <p:spPr>
+          <a:xfrm>
+            <a:off x="384048" y="1115568"/>
+            <a:ext cx="2633472" cy="274320"/>
+          </a:xfrm>
+          <a:prstGeom prst="rect">
+            <a:avLst/>
+          </a:prstGeom>
+          <a:noFill/>
+        </p:spPr>
+        <p:txBody>
+          <a:bodyPr wrap="square">
+            <a:noAutofit/>
+          </a:bodyPr>
+          <a:lstStyle/>
+          <a:p>
+            <a:pPr algn="l"/>
+            <a:r>
+              <a:rPr sz="1000" b="1" i="0">
+                <a:solidFill>
+                  <a:srgbClr val="C8102E"/>
+                </a:solidFill>
+                <a:latin typeface="Calibri"/>
+              </a:rPr>
+              <a:t>Interactive Letter Writer</a:t>
+            </a:r>
+          </a:p>
+        </p:txBody>
+      </p:sp>
+      <p:sp>
+        <p:nvSpPr>
+          <p:cNvPr id="10" name="TextBox 9"/>
+          <p:cNvSpPr txBox="1"/>
+          <p:nvPr/>
+        </p:nvSpPr>
+        <p:spPr>
+          <a:xfrm>
+            <a:off x="384048" y="1408176"/>
+            <a:ext cx="2633472" cy="201168"/>
+          </a:xfrm>
+          <a:prstGeom prst="rect">
+            <a:avLst/>
+          </a:prstGeom>
+          <a:noFill/>
+        </p:spPr>
+        <p:txBody>
+          <a:bodyPr wrap="square">
+            <a:noAutofit/>
+          </a:bodyPr>
+          <a:lstStyle/>
+          <a:p>
+            <a:pPr algn="l"/>
+            <a:r>
+              <a:rPr sz="750" b="0" i="1">
+                <a:solidFill>
+                  <a:srgbClr val="78716C"/>
+                </a:solidFill>
+                <a:latin typeface="Calibri"/>
+              </a:rPr>
+              <a:t>complaint_letter_writer.py</a:t>
+            </a:r>
+          </a:p>
+        </p:txBody>
+      </p:sp>
+      <p:sp>
+        <p:nvSpPr>
+          <p:cNvPr id="11" name="Rectangle 10"/>
+          <p:cNvSpPr/>
+          <p:nvPr/>
+        </p:nvSpPr>
+        <p:spPr>
+          <a:xfrm>
+            <a:off x="384048" y="1627632"/>
+            <a:ext cx="2615184" cy="14630"/>
+          </a:xfrm>
+          <a:prstGeom prst="rect">
+            <a:avLst/>
+          </a:prstGeom>
+          <a:solidFill>
+            <a:srgbClr val="D6D3D1"/>
+          </a:solidFill>
+          <a:ln>
+            <a:noFill/>
+          </a:ln>
+        </p:spPr>
+        <p:style>
+          <a:lnRef idx="1">
+            <a:schemeClr val="accent1"/>
+          </a:lnRef>
+          <a:fillRef idx="3">
+            <a:schemeClr val="accent1"/>
+          </a:fillRef>
+          <a:effectRef idx="2">
+            <a:schemeClr val="accent1"/>
+          </a:effectRef>
+          <a:fontRef idx="minor">
+            <a:schemeClr val="lt1"/>
+          </a:fontRef>
+        </p:style>
+        <p:txBody>
+          <a:bodyPr rtlCol="0" anchor="ctr"/>
+          <a:lstStyle/>
+          <a:p>
+            <a:pPr algn="ctr"/>
+          </a:p>
+        </p:txBody>
+      </p:sp>
+      <p:sp>
+        <p:nvSpPr>
+          <p:cNvPr id="12" name="TextBox 11"/>
+          <p:cNvSpPr txBox="1"/>
+          <p:nvPr/>
+        </p:nvSpPr>
+        <p:spPr>
+          <a:xfrm>
+            <a:off x="384048" y="1682496"/>
+            <a:ext cx="2615184" cy="4133087"/>
+          </a:xfrm>
+          <a:prstGeom prst="rect">
+            <a:avLst/>
+          </a:prstGeom>
+          <a:noFill/>
+        </p:spPr>
+        <p:txBody>
+          <a:bodyPr wrap="square">
+            <a:noAutofit/>
+          </a:bodyPr>
+          <a:lstStyle/>
+          <a:p>
+            <a:pPr>
+              <a:spcAft>
+                <a:spcPts val="400"/>
+              </a:spcAft>
+            </a:pPr>
+            <a:r>
+              <a:rPr sz="800">
+                <a:solidFill>
+                  <a:srgbClr val="44403C"/>
+                </a:solidFill>
+                <a:latin typeface="Calibri"/>
+              </a:rPr>
+              <a:t>· Trigger-phrase driven — Evelyn's exact workflow</a:t>
+            </a:r>
+          </a:p>
+          <a:p>
+            <a:pPr>
+              <a:spcAft>
+                <a:spcPts val="400"/>
+              </a:spcAft>
+            </a:pPr>
+            <a:r>
+              <a:rPr sz="800">
+                <a:solidFill>
+                  <a:srgbClr val="44403C"/>
+                </a:solidFill>
+                <a:latin typeface="Calibri"/>
+              </a:rPr>
+              <a:t>· Stage 1 record: 5 verbatim questions</a:t>
+            </a:r>
+          </a:p>
+          <a:p>
+            <a:pPr>
+              <a:spcAft>
+                <a:spcPts val="400"/>
+              </a:spcAft>
+            </a:pPr>
+            <a:r>
+              <a:rPr sz="800">
+                <a:solidFill>
+                  <a:srgbClr val="44403C"/>
+                </a:solidFill>
+                <a:latin typeface="Calibri"/>
+              </a:rPr>
+              <a:t>· Escalation record: 4 verbatim questions</a:t>
+            </a:r>
+          </a:p>
+          <a:p>
+            <a:pPr>
+              <a:spcAft>
+                <a:spcPts val="400"/>
+              </a:spcAft>
+            </a:pPr>
+            <a:r>
+              <a:rPr sz="800">
+                <a:solidFill>
+                  <a:srgbClr val="44403C"/>
+                </a:solidFill>
+                <a:latin typeface="Calibri"/>
+              </a:rPr>
+              <a:t>· Uphold letter: Sorry → Cause → Impact → Fix → Payment</a:t>
+            </a:r>
+          </a:p>
+          <a:p>
+            <a:pPr>
+              <a:spcAft>
+                <a:spcPts val="400"/>
+              </a:spcAft>
+            </a:pPr>
+            <a:r>
+              <a:rPr sz="800">
+                <a:solidFill>
+                  <a:srgbClr val="44403C"/>
+                </a:solidFill>
+                <a:latin typeface="Calibri"/>
+              </a:rPr>
+              <a:t>· Declined letter: Sorry → Not our fault → Reason → Explanation</a:t>
+            </a:r>
+          </a:p>
+          <a:p>
+            <a:pPr>
+              <a:spcAft>
+                <a:spcPts val="400"/>
+              </a:spcAft>
+            </a:pPr>
+            <a:r>
+              <a:rPr sz="800">
+                <a:solidFill>
+                  <a:srgbClr val="44403C"/>
+                </a:solidFill>
+                <a:latin typeface="Calibri"/>
+              </a:rPr>
+              <a:t>· Escalation: resolution changed / no change</a:t>
+            </a:r>
+          </a:p>
+          <a:p>
+            <a:pPr>
+              <a:spcAft>
+                <a:spcPts val="400"/>
+              </a:spcAft>
+            </a:pPr>
+            <a:r>
+              <a:rPr sz="800">
+                <a:solidFill>
+                  <a:srgbClr val="44403C"/>
+                </a:solidFill>
+                <a:latin typeface="Calibri"/>
+              </a:rPr>
+              <a:t>· Dual mode: complaint record + letter in one doc</a:t>
+            </a:r>
+          </a:p>
+          <a:p>
+            <a:pPr>
+              <a:spcAft>
+                <a:spcPts val="400"/>
+              </a:spcAft>
+            </a:pPr>
+            <a:r>
+              <a:rPr sz="800">
+                <a:solidFill>
+                  <a:srgbClr val="44403C"/>
+                </a:solidFill>
+                <a:latin typeface="Calibri"/>
+              </a:rPr>
+              <a:t>· Output: [REF]_[SURNAME]_[TRIGGER]_[DATE].docx</a:t>
+            </a:r>
+          </a:p>
+        </p:txBody>
+      </p:sp>
+      <p:sp>
+        <p:nvSpPr>
+          <p:cNvPr id="13" name="Rectangle 12"/>
+          <p:cNvSpPr/>
+          <p:nvPr/>
+        </p:nvSpPr>
+        <p:spPr>
+          <a:xfrm>
+            <a:off x="3264408" y="1024128"/>
+            <a:ext cx="2816352" cy="4919472"/>
+          </a:xfrm>
+          <a:prstGeom prst="rect">
+            <a:avLst/>
+          </a:prstGeom>
+          <a:solidFill>
+            <a:srgbClr val="FFFFFF"/>
+          </a:solidFill>
+          <a:ln w="9525">
+            <a:solidFill>
+              <a:srgbClr val="E7E5E4"/>
+            </a:solidFill>
+          </a:ln>
+        </p:spPr>
+        <p:style>
+          <a:lnRef idx="1">
+            <a:schemeClr val="accent1"/>
+          </a:lnRef>
+          <a:fillRef idx="3">
+            <a:schemeClr val="accent1"/>
+          </a:fillRef>
+          <a:effectRef idx="2">
+            <a:schemeClr val="accent1"/>
+          </a:effectRef>
+          <a:fontRef idx="minor">
+            <a:schemeClr val="lt1"/>
+          </a:fontRef>
+        </p:style>
+        <p:txBody>
+          <a:bodyPr rtlCol="0" anchor="ctr"/>
+          <a:lstStyle/>
+          <a:p>
+            <a:pPr algn="ctr"/>
+          </a:p>
+        </p:txBody>
+      </p:sp>
+      <p:sp>
+        <p:nvSpPr>
+          <p:cNvPr id="14" name="Rectangle 13"/>
+          <p:cNvSpPr/>
+          <p:nvPr/>
+        </p:nvSpPr>
+        <p:spPr>
+          <a:xfrm>
+            <a:off x="3264408" y="1024128"/>
+            <a:ext cx="2816352" cy="64008"/>
+          </a:xfrm>
+          <a:prstGeom prst="rect">
+            <a:avLst/>
+          </a:prstGeom>
+          <a:solidFill>
+            <a:srgbClr val="1D4ED8"/>
+          </a:solidFill>
+          <a:ln>
+            <a:noFill/>
+          </a:ln>
+        </p:spPr>
+        <p:style>
+          <a:lnRef idx="1">
+            <a:schemeClr val="accent1"/>
+          </a:lnRef>
+          <a:fillRef idx="3">
+            <a:schemeClr val="accent1"/>
+          </a:fillRef>
+          <a:effectRef idx="2">
+            <a:schemeClr val="accent1"/>
+          </a:effectRef>
+          <a:fontRef idx="minor">
+            <a:schemeClr val="lt1"/>
+          </a:fontRef>
+        </p:style>
+        <p:txBody>
+          <a:bodyPr rtlCol="0" anchor="ctr"/>
+          <a:lstStyle/>
+          <a:p>
+            <a:pPr algn="ctr"/>
+          </a:p>
+        </p:txBody>
+      </p:sp>
+      <p:sp>
+        <p:nvSpPr>
+          <p:cNvPr id="15" name="TextBox 14"/>
+          <p:cNvSpPr txBox="1"/>
+          <p:nvPr/>
+        </p:nvSpPr>
+        <p:spPr>
+          <a:xfrm>
+            <a:off x="3374136" y="1115568"/>
+            <a:ext cx="2633472" cy="274320"/>
+          </a:xfrm>
+          <a:prstGeom prst="rect">
+            <a:avLst/>
+          </a:prstGeom>
+          <a:noFill/>
+        </p:spPr>
+        <p:txBody>
+          <a:bodyPr wrap="square">
+            <a:noAutofit/>
+          </a:bodyPr>
+          <a:lstStyle/>
+          <a:p>
+            <a:pPr algn="l"/>
+            <a:r>
+              <a:rPr sz="1000" b="1" i="0">
+                <a:solidFill>
+                  <a:srgbClr val="1D4ED8"/>
+                </a:solidFill>
+                <a:latin typeface="Calibri"/>
+              </a:rPr>
+              <a:t>Complaint Reference Guide</a:t>
+            </a:r>
+          </a:p>
+        </p:txBody>
+      </p:sp>
+      <p:sp>
+        <p:nvSpPr>
+          <p:cNvPr id="16" name="TextBox 15"/>
+          <p:cNvSpPr txBox="1"/>
+          <p:nvPr/>
+        </p:nvSpPr>
+        <p:spPr>
+          <a:xfrm>
+            <a:off x="3374136" y="1408176"/>
+            <a:ext cx="2633472" cy="201168"/>
+          </a:xfrm>
+          <a:prstGeom prst="rect">
+            <a:avLst/>
+          </a:prstGeom>
+          <a:noFill/>
+        </p:spPr>
+        <p:txBody>
+          <a:bodyPr wrap="square">
+            <a:noAutofit/>
+          </a:bodyPr>
+          <a:lstStyle/>
+          <a:p>
+            <a:pPr algn="l"/>
+            <a:r>
+              <a:rPr sz="750" b="0" i="1">
+                <a:solidFill>
+                  <a:srgbClr val="78716C"/>
+                </a:solidFill>
+                <a:latin typeface="Calibri"/>
+              </a:rPr>
+              <a:t>Santander_Complaint_Guide.docx</a:t>
+            </a:r>
+          </a:p>
+        </p:txBody>
+      </p:sp>
+      <p:sp>
+        <p:nvSpPr>
+          <p:cNvPr id="17" name="Rectangle 16"/>
+          <p:cNvSpPr/>
+          <p:nvPr/>
+        </p:nvSpPr>
+        <p:spPr>
+          <a:xfrm>
+            <a:off x="3374136" y="1627632"/>
+            <a:ext cx="2615184" cy="14630"/>
+          </a:xfrm>
+          <a:prstGeom prst="rect">
+            <a:avLst/>
+          </a:prstGeom>
+          <a:solidFill>
+            <a:srgbClr val="D6D3D1"/>
+          </a:solidFill>
+          <a:ln>
+            <a:noFill/>
+          </a:ln>
+        </p:spPr>
+        <p:style>
+          <a:lnRef idx="1">
+            <a:schemeClr val="accent1"/>
+          </a:lnRef>
+          <a:fillRef idx="3">
+            <a:schemeClr val="accent1"/>
+          </a:fillRef>
+          <a:effectRef idx="2">
+            <a:schemeClr val="accent1"/>
+          </a:effectRef>
+          <a:fontRef idx="minor">
+            <a:schemeClr val="lt1"/>
+          </a:fontRef>
+        </p:style>
+        <p:txBody>
+          <a:bodyPr rtlCol="0" anchor="ctr"/>
+          <a:lstStyle/>
+          <a:p>
+            <a:pPr algn="ctr"/>
+          </a:p>
+        </p:txBody>
+      </p:sp>
+      <p:sp>
+        <p:nvSpPr>
+          <p:cNvPr id="18" name="TextBox 17"/>
+          <p:cNvSpPr txBox="1"/>
+          <p:nvPr/>
+        </p:nvSpPr>
+        <p:spPr>
+          <a:xfrm>
+            <a:off x="3374136" y="1682496"/>
+            <a:ext cx="2615184" cy="4133087"/>
+          </a:xfrm>
+          <a:prstGeom prst="rect">
+            <a:avLst/>
+          </a:prstGeom>
+          <a:noFill/>
+        </p:spPr>
+        <p:txBody>
+          <a:bodyPr wrap="square">
+            <a:noAutofit/>
+          </a:bodyPr>
+          <a:lstStyle/>
+          <a:p>
+            <a:pPr>
+              <a:spcAft>
+                <a:spcPts val="400"/>
+              </a:spcAft>
+            </a:pPr>
+            <a:r>
+              <a:rPr sz="800">
+                <a:solidFill>
+                  <a:srgbClr val="44403C"/>
+                </a:solidFill>
+                <a:latin typeface="Calibri"/>
+              </a:rPr>
+              <a:t>· 7 complaint types × Stage 1 + escalation scenarios</a:t>
+            </a:r>
+          </a:p>
+          <a:p>
+            <a:pPr>
+              <a:spcAft>
+                <a:spcPts val="400"/>
+              </a:spcAft>
+            </a:pPr>
+            <a:r>
+              <a:rPr sz="800">
+                <a:solidFill>
+                  <a:srgbClr val="44403C"/>
+                </a:solidFill>
+                <a:latin typeface="Calibri"/>
+              </a:rPr>
+              <a:t>· ISA Transfer Delay — 3 scenarios (upheld/declined/escalation)</a:t>
+            </a:r>
+          </a:p>
+          <a:p>
+            <a:pPr>
+              <a:spcAft>
+                <a:spcPts val="400"/>
+              </a:spcAft>
+            </a:pPr>
+            <a:r>
+              <a:rPr sz="800">
+                <a:solidFill>
+                  <a:srgbClr val="44403C"/>
+                </a:solidFill>
+                <a:latin typeface="Calibri"/>
+              </a:rPr>
+              <a:t>· Incorrect Charge / Fee</a:t>
+            </a:r>
+          </a:p>
+          <a:p>
+            <a:pPr>
+              <a:spcAft>
+                <a:spcPts val="400"/>
+              </a:spcAft>
+            </a:pPr>
+            <a:r>
+              <a:rPr sz="800">
+                <a:solidFill>
+                  <a:srgbClr val="44403C"/>
+                </a:solidFill>
+                <a:latin typeface="Calibri"/>
+              </a:rPr>
+              <a:t>· Payment Error</a:t>
+            </a:r>
+          </a:p>
+          <a:p>
+            <a:pPr>
+              <a:spcAft>
+                <a:spcPts val="400"/>
+              </a:spcAft>
+            </a:pPr>
+            <a:r>
+              <a:rPr sz="800">
+                <a:solidFill>
+                  <a:srgbClr val="44403C"/>
+                </a:solidFill>
+                <a:latin typeface="Calibri"/>
+              </a:rPr>
+              <a:t>· APP Fraud — PSR PS23/3 reimbursement</a:t>
+            </a:r>
+          </a:p>
+          <a:p>
+            <a:pPr>
+              <a:spcAft>
+                <a:spcPts val="400"/>
+              </a:spcAft>
+            </a:pPr>
+            <a:r>
+              <a:rPr sz="800">
+                <a:solidFill>
+                  <a:srgbClr val="44403C"/>
+                </a:solidFill>
+                <a:latin typeface="Calibri"/>
+              </a:rPr>
+              <a:t>· Mandate Change Error</a:t>
+            </a:r>
+          </a:p>
+          <a:p>
+            <a:pPr>
+              <a:spcAft>
+                <a:spcPts val="400"/>
+              </a:spcAft>
+            </a:pPr>
+            <a:r>
+              <a:rPr sz="800">
+                <a:solidFill>
+                  <a:srgbClr val="44403C"/>
+                </a:solidFill>
+                <a:latin typeface="Calibri"/>
+              </a:rPr>
+              <a:t>· Poor Service / Communication</a:t>
+            </a:r>
+          </a:p>
+          <a:p>
+            <a:pPr>
+              <a:spcAft>
+                <a:spcPts val="400"/>
+              </a:spcAft>
+            </a:pPr>
+            <a:r>
+              <a:rPr sz="800">
+                <a:solidFill>
+                  <a:srgbClr val="44403C"/>
+                </a:solidFill>
+                <a:latin typeface="Calibri"/>
+              </a:rPr>
+              <a:t>· Account Closure Delay</a:t>
+            </a:r>
+          </a:p>
+          <a:p>
+            <a:pPr>
+              <a:spcAft>
+                <a:spcPts val="400"/>
+              </a:spcAft>
+            </a:pPr>
+            <a:r>
+              <a:rPr sz="800">
+                <a:solidFill>
+                  <a:srgbClr val="44403C"/>
+                </a:solidFill>
+                <a:latin typeface="Calibri"/>
+              </a:rPr>
+              <a:t>· Full letter templates, interest formula, DISP table</a:t>
+            </a:r>
+          </a:p>
+        </p:txBody>
+      </p:sp>
+      <p:sp>
+        <p:nvSpPr>
+          <p:cNvPr id="19" name="Rectangle 18"/>
+          <p:cNvSpPr/>
+          <p:nvPr/>
+        </p:nvSpPr>
+        <p:spPr>
+          <a:xfrm>
+            <a:off x="6254496" y="1024128"/>
+            <a:ext cx="2816352" cy="4919472"/>
+          </a:xfrm>
+          <a:prstGeom prst="rect">
+            <a:avLst/>
+          </a:prstGeom>
+          <a:solidFill>
+            <a:srgbClr val="FFFFFF"/>
+          </a:solidFill>
+          <a:ln w="9525">
+            <a:solidFill>
+              <a:srgbClr val="E7E5E4"/>
+            </a:solidFill>
+          </a:ln>
+        </p:spPr>
+        <p:style>
+          <a:lnRef idx="1">
+            <a:schemeClr val="accent1"/>
+          </a:lnRef>
+          <a:fillRef idx="3">
+            <a:schemeClr val="accent1"/>
+          </a:fillRef>
+          <a:effectRef idx="2">
+            <a:schemeClr val="accent1"/>
+          </a:effectRef>
+          <a:fontRef idx="minor">
+            <a:schemeClr val="lt1"/>
+          </a:fontRef>
+        </p:style>
+        <p:txBody>
+          <a:bodyPr rtlCol="0" anchor="ctr"/>
+          <a:lstStyle/>
+          <a:p>
+            <a:pPr algn="ctr"/>
+          </a:p>
+        </p:txBody>
+      </p:sp>
+      <p:sp>
+        <p:nvSpPr>
+          <p:cNvPr id="20" name="Rectangle 19"/>
+          <p:cNvSpPr/>
+          <p:nvPr/>
+        </p:nvSpPr>
+        <p:spPr>
+          <a:xfrm>
+            <a:off x="6254496" y="1024128"/>
+            <a:ext cx="2816352" cy="64008"/>
+          </a:xfrm>
+          <a:prstGeom prst="rect">
+            <a:avLst/>
+          </a:prstGeom>
+          <a:solidFill>
+            <a:srgbClr val="059669"/>
+          </a:solidFill>
+          <a:ln>
+            <a:noFill/>
+          </a:ln>
+        </p:spPr>
+        <p:style>
+          <a:lnRef idx="1">
+            <a:schemeClr val="accent1"/>
+          </a:lnRef>
+          <a:fillRef idx="3">
+            <a:schemeClr val="accent1"/>
+          </a:fillRef>
+          <a:effectRef idx="2">
+            <a:schemeClr val="accent1"/>
+          </a:effectRef>
+          <a:fontRef idx="minor">
+            <a:schemeClr val="lt1"/>
+          </a:fontRef>
+        </p:style>
+        <p:txBody>
+          <a:bodyPr rtlCol="0" anchor="ctr"/>
+          <a:lstStyle/>
+          <a:p>
+            <a:pPr algn="ctr"/>
+          </a:p>
+        </p:txBody>
+      </p:sp>
+      <p:sp>
+        <p:nvSpPr>
+          <p:cNvPr id="21" name="TextBox 20"/>
+          <p:cNvSpPr txBox="1"/>
+          <p:nvPr/>
+        </p:nvSpPr>
+        <p:spPr>
+          <a:xfrm>
+            <a:off x="6364224" y="1115568"/>
+            <a:ext cx="2633472" cy="274320"/>
+          </a:xfrm>
+          <a:prstGeom prst="rect">
+            <a:avLst/>
+          </a:prstGeom>
+          <a:noFill/>
+        </p:spPr>
+        <p:txBody>
+          <a:bodyPr wrap="square">
+            <a:noAutofit/>
+          </a:bodyPr>
+          <a:lstStyle/>
+          <a:p>
+            <a:pPr algn="l"/>
+            <a:r>
+              <a:rPr sz="1000" b="1" i="0">
+                <a:solidFill>
+                  <a:srgbClr val="059669"/>
+                </a:solidFill>
+                <a:latin typeface="Calibri"/>
+              </a:rPr>
+              <a:t>Microsoft Copilot Agent</a:t>
+            </a:r>
+          </a:p>
+        </p:txBody>
+      </p:sp>
+      <p:sp>
+        <p:nvSpPr>
+          <p:cNvPr id="22" name="TextBox 21"/>
+          <p:cNvSpPr txBox="1"/>
+          <p:nvPr/>
+        </p:nvSpPr>
+        <p:spPr>
+          <a:xfrm>
+            <a:off x="6364224" y="1408176"/>
+            <a:ext cx="2633472" cy="201168"/>
+          </a:xfrm>
+          <a:prstGeom prst="rect">
+            <a:avLst/>
+          </a:prstGeom>
+          <a:noFill/>
+        </p:spPr>
+        <p:txBody>
+          <a:bodyPr wrap="square">
+            <a:noAutofit/>
+          </a:bodyPr>
+          <a:lstStyle/>
+          <a:p>
+            <a:pPr algn="l"/>
+            <a:r>
+              <a:rPr sz="750" b="0" i="1">
+                <a:solidFill>
+                  <a:srgbClr val="78716C"/>
+                </a:solidFill>
+                <a:latin typeface="Calibri"/>
+              </a:rPr>
+              <a:t>Evelyn_Complaint_Agent_Angus.md</a:t>
+            </a:r>
+          </a:p>
+        </p:txBody>
+      </p:sp>
+      <p:sp>
+        <p:nvSpPr>
+          <p:cNvPr id="23" name="Rectangle 22"/>
+          <p:cNvSpPr/>
+          <p:nvPr/>
+        </p:nvSpPr>
+        <p:spPr>
+          <a:xfrm>
+            <a:off x="6364224" y="1627632"/>
+            <a:ext cx="2615184" cy="14630"/>
+          </a:xfrm>
+          <a:prstGeom prst="rect">
+            <a:avLst/>
+          </a:prstGeom>
+          <a:solidFill>
+            <a:srgbClr val="D6D3D1"/>
+          </a:solidFill>
+          <a:ln>
+            <a:noFill/>
+          </a:ln>
+        </p:spPr>
+        <p:style>
+          <a:lnRef idx="1">
+            <a:schemeClr val="accent1"/>
+          </a:lnRef>
+          <a:fillRef idx="3">
+            <a:schemeClr val="accent1"/>
+          </a:fillRef>
+          <a:effectRef idx="2">
+            <a:schemeClr val="accent1"/>
+          </a:effectRef>
+          <a:fontRef idx="minor">
+            <a:schemeClr val="lt1"/>
+          </a:fontRef>
+        </p:style>
+        <p:txBody>
+          <a:bodyPr rtlCol="0" anchor="ctr"/>
+          <a:lstStyle/>
+          <a:p>
+            <a:pPr algn="ctr"/>
+          </a:p>
+        </p:txBody>
+      </p:sp>
+      <p:sp>
+        <p:nvSpPr>
+          <p:cNvPr id="24" name="TextBox 23"/>
+          <p:cNvSpPr txBox="1"/>
+          <p:nvPr/>
+        </p:nvSpPr>
+        <p:spPr>
+          <a:xfrm>
+            <a:off x="6364224" y="1682496"/>
+            <a:ext cx="2615184" cy="4133087"/>
+          </a:xfrm>
+          <a:prstGeom prst="rect">
+            <a:avLst/>
+          </a:prstGeom>
+          <a:noFill/>
+        </p:spPr>
+        <p:txBody>
+          <a:bodyPr wrap="square">
+            <a:noAutofit/>
+          </a:bodyPr>
+          <a:lstStyle/>
+          <a:p>
+            <a:pPr>
+              <a:spcAft>
+                <a:spcPts val="400"/>
+              </a:spcAft>
+            </a:pPr>
+            <a:r>
+              <a:rPr sz="800">
+                <a:solidFill>
+                  <a:srgbClr val="44403C"/>
+                </a:solidFill>
+                <a:latin typeface="Calibri"/>
+              </a:rPr>
+              <a:t>· Complete system prompt for Copilot / Copilot Studio</a:t>
+            </a:r>
+          </a:p>
+          <a:p>
+            <a:pPr>
+              <a:spcAft>
+                <a:spcPts val="400"/>
+              </a:spcAft>
+            </a:pPr>
+            <a:r>
+              <a:rPr sz="800">
+                <a:solidFill>
+                  <a:srgbClr val="44403C"/>
+                </a:solidFill>
+                <a:latin typeface="Calibri"/>
+              </a:rPr>
+              <a:t>· All 9 trigger phrases with output definitions</a:t>
+            </a:r>
+          </a:p>
+          <a:p>
+            <a:pPr>
+              <a:spcAft>
+                <a:spcPts val="400"/>
+              </a:spcAft>
+            </a:pPr>
+            <a:r>
+              <a:rPr sz="800">
+                <a:solidFill>
+                  <a:srgbClr val="44403C"/>
+                </a:solidFill>
+                <a:latin typeface="Calibri"/>
+              </a:rPr>
+              <a:t>· Verbatim Stage 1 (5Q) and escalation (4Q) headings</a:t>
+            </a:r>
+          </a:p>
+          <a:p>
+            <a:pPr>
+              <a:spcAft>
+                <a:spcPts val="400"/>
+              </a:spcAft>
+            </a:pPr>
+            <a:r>
+              <a:rPr sz="800">
+                <a:solidFill>
+                  <a:srgbClr val="44403C"/>
+                </a:solidFill>
+                <a:latin typeface="Calibri"/>
+              </a:rPr>
+              <a:t>· Upheld and declined letter templates with exact language</a:t>
+            </a:r>
+          </a:p>
+          <a:p>
+            <a:pPr>
+              <a:spcAft>
+                <a:spcPts val="400"/>
+              </a:spcAft>
+            </a:pPr>
+            <a:r>
+              <a:rPr sz="800">
+                <a:solidFill>
+                  <a:srgbClr val="44403C"/>
+                </a:solidFill>
+                <a:latin typeface="Calibri"/>
+              </a:rPr>
+              <a:t>· FOS referral block — copy-exact text</a:t>
+            </a:r>
+          </a:p>
+          <a:p>
+            <a:pPr>
+              <a:spcAft>
+                <a:spcPts val="400"/>
+              </a:spcAft>
+            </a:pPr>
+            <a:r>
+              <a:rPr sz="800">
+                <a:solidFill>
+                  <a:srgbClr val="44403C"/>
+                </a:solidFill>
+                <a:latin typeface="Calibri"/>
+              </a:rPr>
+              <a:t>· Standard sign-off block</a:t>
+            </a:r>
+          </a:p>
+          <a:p>
+            <a:pPr>
+              <a:spcAft>
+                <a:spcPts val="400"/>
+              </a:spcAft>
+            </a:pPr>
+            <a:r>
+              <a:rPr sz="800">
+                <a:solidFill>
+                  <a:srgbClr val="44403C"/>
+                </a:solidFill>
+                <a:latin typeface="Calibri"/>
+              </a:rPr>
+              <a:t>· System behaviour rules (vault-ready, consistency)</a:t>
+            </a:r>
+          </a:p>
+          <a:p>
+            <a:pPr>
+              <a:spcAft>
+                <a:spcPts val="400"/>
+              </a:spcAft>
+            </a:pPr>
+            <a:r>
+              <a:rPr sz="800">
+                <a:solidFill>
+                  <a:srgbClr val="44403C"/>
+                </a:solidFill>
+                <a:latin typeface="Calibri"/>
+              </a:rPr>
+              <a:t>· Paste into Copilot custom instructions or Copilot Studio</a:t>
+            </a:r>
+          </a:p>
+        </p:txBody>
+      </p:sp>
+      <p:sp>
+        <p:nvSpPr>
+          <p:cNvPr id="25" name="Rectangle 24"/>
+          <p:cNvSpPr/>
+          <p:nvPr/>
+        </p:nvSpPr>
+        <p:spPr>
+          <a:xfrm>
+            <a:off x="9244584" y="1024128"/>
+            <a:ext cx="2816352" cy="4919472"/>
+          </a:xfrm>
+          <a:prstGeom prst="rect">
+            <a:avLst/>
+          </a:prstGeom>
+          <a:solidFill>
+            <a:srgbClr val="FFFFFF"/>
+          </a:solidFill>
+          <a:ln w="9525">
+            <a:solidFill>
+              <a:srgbClr val="E7E5E4"/>
+            </a:solidFill>
+          </a:ln>
+        </p:spPr>
+        <p:style>
+          <a:lnRef idx="1">
+            <a:schemeClr val="accent1"/>
+          </a:lnRef>
+          <a:fillRef idx="3">
+            <a:schemeClr val="accent1"/>
+          </a:fillRef>
+          <a:effectRef idx="2">
+            <a:schemeClr val="accent1"/>
+          </a:effectRef>
+          <a:fontRef idx="minor">
+            <a:schemeClr val="lt1"/>
+          </a:fontRef>
+        </p:style>
+        <p:txBody>
+          <a:bodyPr rtlCol="0" anchor="ctr"/>
+          <a:lstStyle/>
+          <a:p>
+            <a:pPr algn="ctr"/>
+          </a:p>
+        </p:txBody>
+      </p:sp>
+      <p:sp>
+        <p:nvSpPr>
+          <p:cNvPr id="26" name="Rectangle 25"/>
+          <p:cNvSpPr/>
+          <p:nvPr/>
+        </p:nvSpPr>
+        <p:spPr>
+          <a:xfrm>
+            <a:off x="9244584" y="1024128"/>
+            <a:ext cx="2816352" cy="64008"/>
+          </a:xfrm>
+          <a:prstGeom prst="rect">
+            <a:avLst/>
+          </a:prstGeom>
+          <a:solidFill>
+            <a:srgbClr val="44403C"/>
+          </a:solidFill>
+          <a:ln>
+            <a:noFill/>
+          </a:ln>
+        </p:spPr>
+        <p:style>
+          <a:lnRef idx="1">
+            <a:schemeClr val="accent1"/>
+          </a:lnRef>
+          <a:fillRef idx="3">
+            <a:schemeClr val="accent1"/>
+          </a:fillRef>
+          <a:effectRef idx="2">
+            <a:schemeClr val="accent1"/>
+          </a:effectRef>
+          <a:fontRef idx="minor">
+            <a:schemeClr val="lt1"/>
+          </a:fontRef>
+        </p:style>
+        <p:txBody>
+          <a:bodyPr rtlCol="0" anchor="ctr"/>
+          <a:lstStyle/>
+          <a:p>
+            <a:pPr algn="ctr"/>
+          </a:p>
+        </p:txBody>
+      </p:sp>
+      <p:sp>
+        <p:nvSpPr>
+          <p:cNvPr id="27" name="TextBox 26"/>
+          <p:cNvSpPr txBox="1"/>
+          <p:nvPr/>
+        </p:nvSpPr>
+        <p:spPr>
+          <a:xfrm>
+            <a:off x="9354312" y="1115568"/>
+            <a:ext cx="2633472" cy="274320"/>
+          </a:xfrm>
+          <a:prstGeom prst="rect">
+            <a:avLst/>
+          </a:prstGeom>
+          <a:noFill/>
+        </p:spPr>
+        <p:txBody>
+          <a:bodyPr wrap="square">
+            <a:noAutofit/>
+          </a:bodyPr>
+          <a:lstStyle/>
+          <a:p>
+            <a:pPr algn="l"/>
+            <a:r>
+              <a:rPr sz="1000" b="1" i="0">
+                <a:solidFill>
+                  <a:srgbClr val="44403C"/>
+                </a:solidFill>
+                <a:latin typeface="Calibri"/>
+              </a:rPr>
+              <a:t>App.jsx Workflow</a:t>
+            </a:r>
+          </a:p>
+        </p:txBody>
+      </p:sp>
+      <p:sp>
+        <p:nvSpPr>
+          <p:cNvPr id="28" name="TextBox 27"/>
+          <p:cNvSpPr txBox="1"/>
+          <p:nvPr/>
+        </p:nvSpPr>
+        <p:spPr>
+          <a:xfrm>
+            <a:off x="9354312" y="1408176"/>
+            <a:ext cx="2633472" cy="201168"/>
+          </a:xfrm>
+          <a:prstGeom prst="rect">
+            <a:avLst/>
+          </a:prstGeom>
+          <a:noFill/>
+        </p:spPr>
+        <p:txBody>
+          <a:bodyPr wrap="square">
+            <a:noAutofit/>
+          </a:bodyPr>
+          <a:lstStyle/>
+          <a:p>
+            <a:pPr algn="l"/>
+            <a:r>
+              <a:rPr sz="750" b="0" i="1">
+                <a:solidFill>
+                  <a:srgbClr val="78716C"/>
+                </a:solidFill>
+                <a:latin typeface="Calibri"/>
+              </a:rPr>
+              <a:t>In-app: renderComplaint()</a:t>
+            </a:r>
+          </a:p>
+        </p:txBody>
+      </p:sp>
+      <p:sp>
+        <p:nvSpPr>
+          <p:cNvPr id="29" name="Rectangle 28"/>
+          <p:cNvSpPr/>
+          <p:nvPr/>
+        </p:nvSpPr>
+        <p:spPr>
+          <a:xfrm>
+            <a:off x="9354312" y="1627632"/>
+            <a:ext cx="2615184" cy="14630"/>
+          </a:xfrm>
+          <a:prstGeom prst="rect">
+            <a:avLst/>
+          </a:prstGeom>
+          <a:solidFill>
+            <a:srgbClr val="D6D3D1"/>
+          </a:solidFill>
+          <a:ln>
+            <a:noFill/>
+          </a:ln>
+        </p:spPr>
+        <p:style>
+          <a:lnRef idx="1">
+            <a:schemeClr val="accent1"/>
+          </a:lnRef>
+          <a:fillRef idx="3">
+            <a:schemeClr val="accent1"/>
+          </a:fillRef>
+          <a:effectRef idx="2">
+            <a:schemeClr val="accent1"/>
+          </a:effectRef>
+          <a:fontRef idx="minor">
+            <a:schemeClr val="lt1"/>
+          </a:fontRef>
+        </p:style>
+        <p:txBody>
+          <a:bodyPr rtlCol="0" anchor="ctr"/>
+          <a:lstStyle/>
+          <a:p>
+            <a:pPr algn="ctr"/>
+          </a:p>
+        </p:txBody>
+      </p:sp>
+      <p:sp>
+        <p:nvSpPr>
+          <p:cNvPr id="30" name="TextBox 29"/>
+          <p:cNvSpPr txBox="1"/>
+          <p:nvPr/>
+        </p:nvSpPr>
+        <p:spPr>
+          <a:xfrm>
+            <a:off x="9354312" y="1682496"/>
+            <a:ext cx="2615184" cy="4133087"/>
+          </a:xfrm>
+          <a:prstGeom prst="rect">
+            <a:avLst/>
+          </a:prstGeom>
+          <a:noFill/>
+        </p:spPr>
+        <p:txBody>
+          <a:bodyPr wrap="square">
+            <a:noAutofit/>
+          </a:bodyPr>
+          <a:lstStyle/>
+          <a:p>
+            <a:pPr>
+              <a:spcAft>
+                <a:spcPts val="400"/>
+              </a:spcAft>
+            </a:pPr>
+            <a:r>
+              <a:rPr sz="800">
+                <a:solidFill>
+                  <a:srgbClr val="44403C"/>
+                </a:solidFill>
+                <a:latin typeface="Calibri"/>
+              </a:rPr>
+              <a:t>· 4-step workflow wizard built into the prototype</a:t>
+            </a:r>
+          </a:p>
+          <a:p>
+            <a:pPr>
+              <a:spcAft>
+                <a:spcPts val="400"/>
+              </a:spcAft>
+            </a:pPr>
+            <a:r>
+              <a:rPr sz="800">
+                <a:solidFill>
+                  <a:srgbClr val="44403C"/>
+                </a:solidFill>
+                <a:latin typeface="Calibri"/>
+              </a:rPr>
+              <a:t>· Step 1: Intake — category, date, eligible complainant check</a:t>
+            </a:r>
+          </a:p>
+          <a:p>
+            <a:pPr>
+              <a:spcAft>
+                <a:spcPts val="400"/>
+              </a:spcAft>
+            </a:pPr>
+            <a:r>
+              <a:rPr sz="800">
+                <a:solidFill>
+                  <a:srgbClr val="44403C"/>
+                </a:solidFill>
+                <a:latin typeface="Calibri"/>
+              </a:rPr>
+              <a:t>· Step 2: Escalation triage — flag selection</a:t>
+            </a:r>
+          </a:p>
+          <a:p>
+            <a:pPr>
+              <a:spcAft>
+                <a:spcPts val="400"/>
+              </a:spcAft>
+            </a:pPr>
+            <a:r>
+              <a:rPr sz="800">
+                <a:solidFill>
+                  <a:srgbClr val="44403C"/>
+                </a:solidFill>
+                <a:latin typeface="Calibri"/>
+              </a:rPr>
+              <a:t>· Step 3: Denial reason (if not upheld)</a:t>
+            </a:r>
+          </a:p>
+          <a:p>
+            <a:pPr>
+              <a:spcAft>
+                <a:spcPts val="400"/>
+              </a:spcAft>
+            </a:pPr>
+            <a:r>
+              <a:rPr sz="800">
+                <a:solidFill>
+                  <a:srgbClr val="44403C"/>
+                </a:solidFill>
+                <a:latin typeface="Calibri"/>
+              </a:rPr>
+              <a:t>· Step 4: Case outcome — goodwill gesture option</a:t>
+            </a:r>
+          </a:p>
+          <a:p>
+            <a:pPr>
+              <a:spcAft>
+                <a:spcPts val="400"/>
+              </a:spcAft>
+            </a:pPr>
+            <a:r>
+              <a:rPr sz="800">
+                <a:solidFill>
+                  <a:srgbClr val="44403C"/>
+                </a:solidFill>
+                <a:latin typeface="Calibri"/>
+              </a:rPr>
+              <a:t>· Triggered from Home screen 'Log complaint' action tile</a:t>
+            </a:r>
+          </a:p>
+          <a:p>
+            <a:pPr>
+              <a:spcAft>
+                <a:spcPts val="400"/>
+              </a:spcAft>
+            </a:pPr>
+            <a:r>
+              <a:rPr sz="800">
+                <a:solidFill>
+                  <a:srgbClr val="44403C"/>
+                </a:solidFill>
+                <a:latin typeface="Calibri"/>
+              </a:rPr>
+              <a:t>· FCA DISP-compliant flow throughout</a:t>
+            </a:r>
+          </a:p>
+          <a:p>
+            <a:pPr>
+              <a:spcAft>
+                <a:spcPts val="400"/>
+              </a:spcAft>
+            </a:pPr>
+            <a:r>
+              <a:rPr sz="800">
+                <a:solidFill>
+                  <a:srgbClr val="44403C"/>
+                </a:solidFill>
+                <a:latin typeface="Calibri"/>
+              </a:rPr>
+              <a:t>· State reset in closeWorkflow() — no ghost state</a:t>
+            </a:r>
+          </a:p>
+        </p:txBody>
+      </p:sp>
+      <p:sp>
+        <p:nvSpPr>
+          <p:cNvPr id="31" name="TextBox 30"/>
+          <p:cNvSpPr txBox="1"/>
+          <p:nvPr/>
+        </p:nvSpPr>
+        <p:spPr>
+          <a:xfrm>
+            <a:off x="274320" y="6108192"/>
+            <a:ext cx="11612880" cy="228600"/>
+          </a:xfrm>
+          <a:prstGeom prst="rect">
+            <a:avLst/>
+          </a:prstGeom>
+          <a:noFill/>
+        </p:spPr>
+        <p:txBody>
+          <a:bodyPr wrap="square">
+            <a:noAutofit/>
+          </a:bodyPr>
+          <a:lstStyle/>
+          <a:p>
+            <a:pPr algn="l"/>
+            <a:r>
+              <a:rPr sz="750" b="0" i="1">
+                <a:solidFill>
+                  <a:srgbClr val="78716C"/>
+                </a:solidFill>
+                <a:latin typeface="Calibri"/>
+              </a:rPr>
+              <a:t>Trigger phrases: 'evidence to support complaint stage 1' · 'Uphold - stage 1 letter' · 'Declined - stage 1 letter' · 'Escalation - resolution changed' and 5 more</a:t>
+            </a:r>
+          </a:p>
+        </p:txBody>
+      </p:sp>
+      <p:sp>
+        <p:nvSpPr>
+          <p:cNvPr id="32" name="Rectangle 31"/>
+          <p:cNvSpPr/>
+          <p:nvPr/>
+        </p:nvSpPr>
+        <p:spPr>
+          <a:xfrm>
+            <a:off x="0" y="6601968"/>
+            <a:ext cx="12188952" cy="256032"/>
+          </a:xfrm>
+          <a:prstGeom prst="rect">
+            <a:avLst/>
+          </a:prstGeom>
+          <a:solidFill>
+            <a:srgbClr val="1C1917"/>
+          </a:solidFill>
+          <a:ln>
+            <a:noFill/>
+          </a:ln>
+        </p:spPr>
+        <p:style>
+          <a:lnRef idx="1">
+            <a:schemeClr val="accent1"/>
+          </a:lnRef>
+          <a:fillRef idx="3">
+            <a:schemeClr val="accent1"/>
+          </a:fillRef>
+          <a:effectRef idx="2">
+            <a:schemeClr val="accent1"/>
+          </a:effectRef>
+          <a:fontRef idx="minor">
+            <a:schemeClr val="lt1"/>
+          </a:fontRef>
+        </p:style>
+        <p:txBody>
+          <a:bodyPr rtlCol="0" anchor="ctr"/>
+          <a:lstStyle/>
+          <a:p>
+            <a:pPr algn="ctr"/>
+          </a:p>
+        </p:txBody>
+      </p:sp>
+      <p:sp>
+        <p:nvSpPr>
+          <p:cNvPr id="33" name="TextBox 32"/>
+          <p:cNvSpPr txBox="1"/>
+          <p:nvPr/>
+        </p:nvSpPr>
+        <p:spPr>
+          <a:xfrm>
+            <a:off x="457200" y="6620256"/>
+            <a:ext cx="11274552" cy="201168"/>
+          </a:xfrm>
+          <a:prstGeom prst="rect">
+            <a:avLst/>
+          </a:prstGeom>
+          <a:noFill/>
+        </p:spPr>
+        <p:txBody>
+          <a:bodyPr wrap="square">
+            <a:noAutofit/>
+          </a:bodyPr>
+          <a:lstStyle/>
+          <a:p>
+            <a:pPr algn="ctr"/>
+            <a:r>
+              <a:rPr sz="800" b="0" i="0">
+                <a:solidFill>
+                  <a:srgbClr val="D6D3D1"/>
+                </a:solidFill>
+                <a:latin typeface="Calibri"/>
+              </a:rPr>
+              <a:t>Alan Davidson · Business Banking Advisor · Self-initiated · Completed out of hours in own time · June 2026</a:t>
+            </a:r>
+          </a:p>
+        </p:txBody>
+      </p:sp>
+      <p:sp>
+        <p:nvSpPr>
+          <p:cNvPr id="34" name="TextBox 33"/>
+          <p:cNvSpPr txBox="1"/>
+          <p:nvPr/>
+        </p:nvSpPr>
+        <p:spPr>
+          <a:xfrm>
+            <a:off x="11795760" y="6583680"/>
+            <a:ext cx="320040" cy="228600"/>
+          </a:xfrm>
+          <a:prstGeom prst="rect">
+            <a:avLst/>
+          </a:prstGeom>
+          <a:noFill/>
+        </p:spPr>
+        <p:txBody>
+          <a:bodyPr wrap="square">
+            <a:noAutofit/>
+          </a:bodyPr>
+          <a:lstStyle/>
+          <a:p>
+            <a:pPr algn="r"/>
+            <a:r>
+              <a:rPr sz="800" b="0" i="0">
+                <a:solidFill>
+                  <a:srgbClr val="78716C"/>
+                </a:solidFill>
+                <a:latin typeface="Calibri"/>
+              </a:rPr>
+              <a:t>13</a:t>
+            </a:r>
+          </a:p>
+        </p:txBody>
+      </p:sp>
+    </p:spTree>
+  </p:cSld>
+  <p:clrMapOvr>
+    <a:masterClrMapping/>
+  </p:clrMapOvr>
+</p:sld>
+</file>
+
+<file path=ppt/slides/slide14.xml><?xml version="1.0" encoding="utf-8"?>
+<p:sld xmlns:a="http://schemas.openxmlformats.org/drawingml/2006/main" xmlns:p="http://schemas.openxmlformats.org/presentationml/2006/main" xmlns:r="http://schemas.openxmlformats.org/officeDocument/2006/relationships">
+  <p:cSld>
+    <p:spTree>
+      <p:nvGrpSpPr>
+        <p:cNvPr id="1" name=""/>
+        <p:cNvGrpSpPr/>
+        <p:nvPr/>
+      </p:nvGrpSpPr>
+      <p:grpSpPr/>
+      <p:sp>
+        <p:nvSpPr>
+          <p:cNvPr id="2" name="Rectangle 1"/>
+          <p:cNvSpPr/>
+          <p:nvPr/>
+        </p:nvSpPr>
+        <p:spPr>
+          <a:xfrm>
+            <a:off x="0" y="0"/>
+            <a:ext cx="12188952" cy="6858000"/>
+          </a:xfrm>
+          <a:prstGeom prst="rect">
+            <a:avLst/>
+          </a:prstGeom>
+          <a:solidFill>
+            <a:srgbClr val="1C1917"/>
+          </a:solidFill>
+          <a:ln>
+            <a:noFill/>
+          </a:ln>
+        </p:spPr>
+        <p:style>
+          <a:lnRef idx="1">
+            <a:schemeClr val="accent1"/>
+          </a:lnRef>
+          <a:fillRef idx="3">
+            <a:schemeClr val="accent1"/>
+          </a:fillRef>
+          <a:effectRef idx="2">
+            <a:schemeClr val="accent1"/>
+          </a:effectRef>
+          <a:fontRef idx="minor">
+            <a:schemeClr val="lt1"/>
+          </a:fontRef>
+        </p:style>
+        <p:txBody>
+          <a:bodyPr rtlCol="0" anchor="ctr"/>
+          <a:lstStyle/>
+          <a:p>
+            <a:pPr algn="ctr"/>
+          </a:p>
+        </p:txBody>
+      </p:sp>
+      <p:sp>
+        <p:nvSpPr>
+          <p:cNvPr id="3" name="Rectangle 2"/>
+          <p:cNvSpPr/>
+          <p:nvPr/>
+        </p:nvSpPr>
+        <p:spPr>
+          <a:xfrm>
+            <a:off x="0" y="0"/>
+            <a:ext cx="12188952" cy="64008"/>
+          </a:xfrm>
+          <a:prstGeom prst="rect">
+            <a:avLst/>
+          </a:prstGeom>
+          <a:solidFill>
+            <a:srgbClr val="C8102E"/>
+          </a:solidFill>
+          <a:ln>
+            <a:noFill/>
+          </a:ln>
+        </p:spPr>
+        <p:style>
+          <a:lnRef idx="1">
+            <a:schemeClr val="accent1"/>
+          </a:lnRef>
+          <a:fillRef idx="3">
+            <a:schemeClr val="accent1"/>
+          </a:fillRef>
+          <a:effectRef idx="2">
+            <a:schemeClr val="accent1"/>
+          </a:effectRef>
+          <a:fontRef idx="minor">
+            <a:schemeClr val="lt1"/>
+          </a:fontRef>
+        </p:style>
+        <p:txBody>
+          <a:bodyPr rtlCol="0" anchor="ctr"/>
+          <a:lstStyle/>
+          <a:p>
+            <a:pPr algn="ctr"/>
+          </a:p>
+        </p:txBody>
+      </p:sp>
+      <p:sp>
+        <p:nvSpPr>
+          <p:cNvPr id="4" name="TextBox 3"/>
+          <p:cNvSpPr txBox="1"/>
+          <p:nvPr/>
+        </p:nvSpPr>
+        <p:spPr>
+          <a:xfrm>
+            <a:off x="548640" y="201168"/>
+            <a:ext cx="9144000" cy="411480"/>
+          </a:xfrm>
+          <a:prstGeom prst="rect">
+            <a:avLst/>
+          </a:prstGeom>
+          <a:noFill/>
+        </p:spPr>
+        <p:txBody>
+          <a:bodyPr wrap="square">
+            <a:noAutofit/>
+          </a:bodyPr>
+          <a:lstStyle/>
+          <a:p>
+            <a:pPr algn="l"/>
+            <a:r>
+              <a:rPr sz="2200" b="1" i="0">
+                <a:solidFill>
+                  <a:srgbClr val="FFFFFF"/>
+                </a:solidFill>
+                <a:latin typeface="Calibri"/>
+              </a:rPr>
+              <a:t>Business Case Summary</a:t>
+            </a:r>
+          </a:p>
+        </p:txBody>
+      </p:sp>
+      <p:sp>
+        <p:nvSpPr>
+          <p:cNvPr id="5" name="TextBox 4"/>
+          <p:cNvSpPr txBox="1"/>
+          <p:nvPr/>
+        </p:nvSpPr>
+        <p:spPr>
+          <a:xfrm>
+            <a:off x="548640" y="640080"/>
+            <a:ext cx="10972800" cy="274320"/>
+          </a:xfrm>
+          <a:prstGeom prst="rect">
+            <a:avLst/>
+          </a:prstGeom>
+          <a:noFill/>
+        </p:spPr>
+        <p:txBody>
+          <a:bodyPr wrap="square">
+            <a:noAutofit/>
+          </a:bodyPr>
+          <a:lstStyle/>
+          <a:p>
+            <a:pPr algn="l"/>
+            <a:r>
+              <a:rPr sz="1200" b="0" i="1">
+                <a:solidFill>
+                  <a:srgbClr val="78716C"/>
+                </a:solidFill>
+                <a:latin typeface="Calibri"/>
+              </a:rPr>
+              <a:t>Phase 1 complete. Phase 2 awaiting stakeholder approval. Zero days to readiness.</a:t>
+            </a:r>
+          </a:p>
+        </p:txBody>
+      </p:sp>
+      <p:sp>
+        <p:nvSpPr>
+          <p:cNvPr id="6" name="Rectangle 5"/>
+          <p:cNvSpPr/>
+          <p:nvPr/>
+        </p:nvSpPr>
+        <p:spPr>
+          <a:xfrm>
+            <a:off x="548640" y="960120"/>
+            <a:ext cx="11064240" cy="18288"/>
+          </a:xfrm>
+          <a:prstGeom prst="rect">
+            <a:avLst/>
+          </a:prstGeom>
+          <a:solidFill>
+            <a:srgbClr val="C8102E"/>
+          </a:solidFill>
+          <a:ln>
+            <a:noFill/>
+          </a:ln>
+        </p:spPr>
+        <p:style>
+          <a:lnRef idx="1">
+            <a:schemeClr val="accent1"/>
+          </a:lnRef>
+          <a:fillRef idx="3">
+            <a:schemeClr val="accent1"/>
+          </a:fillRef>
+          <a:effectRef idx="2">
+            <a:schemeClr val="accent1"/>
+          </a:effectRef>
+          <a:fontRef idx="minor">
+            <a:schemeClr val="lt1"/>
+          </a:fontRef>
+        </p:style>
+        <p:txBody>
+          <a:bodyPr rtlCol="0" anchor="ctr"/>
+          <a:lstStyle/>
+          <a:p>
+            <a:pPr algn="ctr"/>
+          </a:p>
+        </p:txBody>
+      </p:sp>
+      <p:sp>
+        <p:nvSpPr>
           <p:cNvPr id="7" name="Rectangle 6"/>
           <p:cNvSpPr/>
           <p:nvPr/>
@@ -16132,7 +18378,7 @@
                 </a:solidFill>
                 <a:latin typeface="Calibri"/>
               </a:rPr>
-              <a:t>11</a:t>
+              <a:t>12</a:t>
             </a:r>
           </a:p>
         </p:txBody>
@@ -17575,7 +19821,7 @@
                 </a:solidFill>
                 <a:latin typeface="Calibri"/>
               </a:rPr>
-              <a:t>13</a:t>
+              <a:t>14</a:t>
             </a:r>
           </a:p>
         </p:txBody>
@@ -17898,7 +20144,7 @@
                 </a:solidFill>
                 <a:latin typeface="Calibri"/>
               </a:rPr>
-              <a:t>11 step-based workflow wizards covering every key banking operation</a:t>
+              <a:t>12 step-based workflow wizards covering every key banking operation</a:t>
             </a:r>
           </a:p>
           <a:p>
@@ -21179,7 +23425,7 @@
                 </a:solidFill>
                 <a:latin typeface="Calibri"/>
               </a:rPr>
-              <a:t>Eleven Workflow Wizards</a:t>
+              <a:t>Twelve Workflow Wizards</a:t>
             </a:r>
           </a:p>
         </p:txBody>
@@ -23437,6 +25683,203 @@
         </p:nvSpPr>
         <p:spPr>
           <a:xfrm>
+            <a:off x="7863840" y="5248655"/>
+            <a:ext cx="3566160" cy="1261872"/>
+          </a:xfrm>
+          <a:prstGeom prst="rect">
+            <a:avLst/>
+          </a:prstGeom>
+          <a:solidFill>
+            <a:srgbClr val="FFFFFF"/>
+          </a:solidFill>
+          <a:ln w="9525">
+            <a:solidFill>
+              <a:srgbClr val="E7E5E4"/>
+            </a:solidFill>
+          </a:ln>
+        </p:spPr>
+        <p:style>
+          <a:lnRef idx="1">
+            <a:schemeClr val="accent1"/>
+          </a:lnRef>
+          <a:fillRef idx="3">
+            <a:schemeClr val="accent1"/>
+          </a:fillRef>
+          <a:effectRef idx="2">
+            <a:schemeClr val="accent1"/>
+          </a:effectRef>
+          <a:fontRef idx="minor">
+            <a:schemeClr val="lt1"/>
+          </a:fontRef>
+        </p:style>
+        <p:txBody>
+          <a:bodyPr rtlCol="0" anchor="ctr"/>
+          <a:lstStyle/>
+          <a:p>
+            <a:pPr algn="ctr"/>
+          </a:p>
+        </p:txBody>
+      </p:sp>
+      <p:sp>
+        <p:nvSpPr>
+          <p:cNvPr id="63" name="Rectangle 62"/>
+          <p:cNvSpPr/>
+          <p:nvPr/>
+        </p:nvSpPr>
+        <p:spPr>
+          <a:xfrm>
+            <a:off x="7863840" y="5248655"/>
+            <a:ext cx="50292" cy="1261872"/>
+          </a:xfrm>
+          <a:prstGeom prst="rect">
+            <a:avLst/>
+          </a:prstGeom>
+          <a:solidFill>
+            <a:srgbClr val="C8102E"/>
+          </a:solidFill>
+          <a:ln>
+            <a:noFill/>
+          </a:ln>
+        </p:spPr>
+        <p:style>
+          <a:lnRef idx="1">
+            <a:schemeClr val="accent1"/>
+          </a:lnRef>
+          <a:fillRef idx="3">
+            <a:schemeClr val="accent1"/>
+          </a:fillRef>
+          <a:effectRef idx="2">
+            <a:schemeClr val="accent1"/>
+          </a:effectRef>
+          <a:fontRef idx="minor">
+            <a:schemeClr val="lt1"/>
+          </a:fontRef>
+        </p:style>
+        <p:txBody>
+          <a:bodyPr rtlCol="0" anchor="ctr"/>
+          <a:lstStyle/>
+          <a:p>
+            <a:pPr algn="ctr"/>
+          </a:p>
+        </p:txBody>
+      </p:sp>
+      <p:sp>
+        <p:nvSpPr>
+          <p:cNvPr id="64" name="TextBox 63"/>
+          <p:cNvSpPr txBox="1"/>
+          <p:nvPr/>
+        </p:nvSpPr>
+        <p:spPr>
+          <a:xfrm>
+            <a:off x="8028431" y="5340095"/>
+            <a:ext cx="3310128" cy="256032"/>
+          </a:xfrm>
+          <a:prstGeom prst="rect">
+            <a:avLst/>
+          </a:prstGeom>
+          <a:noFill/>
+        </p:spPr>
+        <p:txBody>
+          <a:bodyPr wrap="square">
+            <a:noAutofit/>
+          </a:bodyPr>
+          <a:lstStyle/>
+          <a:p>
+            <a:pPr algn="l"/>
+            <a:r>
+              <a:rPr sz="950" b="1" i="0">
+                <a:solidFill>
+                  <a:srgbClr val="1C1917"/>
+                </a:solidFill>
+                <a:latin typeface="Calibri"/>
+              </a:rPr>
+              <a:t>Complaint Handling</a:t>
+            </a:r>
+          </a:p>
+        </p:txBody>
+      </p:sp>
+      <p:sp>
+        <p:nvSpPr>
+          <p:cNvPr id="65" name="TextBox 64"/>
+          <p:cNvSpPr txBox="1"/>
+          <p:nvPr/>
+        </p:nvSpPr>
+        <p:spPr>
+          <a:xfrm>
+            <a:off x="8028431" y="5577840"/>
+            <a:ext cx="1097280" cy="182880"/>
+          </a:xfrm>
+          <a:prstGeom prst="rect">
+            <a:avLst/>
+          </a:prstGeom>
+          <a:noFill/>
+        </p:spPr>
+        <p:txBody>
+          <a:bodyPr wrap="square">
+            <a:noAutofit/>
+          </a:bodyPr>
+          <a:lstStyle/>
+          <a:p>
+            <a:pPr algn="l"/>
+            <a:r>
+              <a:rPr sz="750" b="1" i="0">
+                <a:solidFill>
+                  <a:srgbClr val="C8102E"/>
+                </a:solidFill>
+                <a:latin typeface="Calibri"/>
+              </a:rPr>
+              <a:t>4 steps</a:t>
+            </a:r>
+          </a:p>
+        </p:txBody>
+      </p:sp>
+      <p:sp>
+        <p:nvSpPr>
+          <p:cNvPr id="66" name="TextBox 65"/>
+          <p:cNvSpPr txBox="1"/>
+          <p:nvPr/>
+        </p:nvSpPr>
+        <p:spPr>
+          <a:xfrm>
+            <a:off x="8028431" y="5751575"/>
+            <a:ext cx="3291840" cy="713232"/>
+          </a:xfrm>
+          <a:prstGeom prst="rect">
+            <a:avLst/>
+          </a:prstGeom>
+          <a:noFill/>
+        </p:spPr>
+        <p:txBody>
+          <a:bodyPr wrap="square">
+            <a:noAutofit/>
+          </a:bodyPr>
+          <a:lstStyle/>
+          <a:p>
+            <a:pPr>
+              <a:spcAft>
+                <a:spcPts val="300"/>
+              </a:spcAft>
+            </a:pPr>
+            <a:r>
+              <a:rPr sz="800">
+                <a:solidFill>
+                  <a:srgbClr val="78716C"/>
+                </a:solidFill>
+                <a:latin typeface="Calibri"/>
+              </a:rPr>
+              <a:t>Intake → escalation triage → denial → case outcome. FCA DISP-compliant. Eligible complainant check (DISP 2.7), escalation flag selection, denial reason, optional goodwill gesture. Triggers from Home screen Log complaint tile.</a:t>
+            </a:r>
+          </a:p>
+        </p:txBody>
+      </p:sp>
+      <p:sp>
+        <p:nvSpPr>
+          <p:cNvPr id="67" name="Rectangle 66"/>
+          <p:cNvSpPr/>
+          <p:nvPr/>
+        </p:nvSpPr>
+        <p:spPr>
+          <a:xfrm>
             <a:off x="0" y="6601968"/>
             <a:ext cx="12188952" cy="256032"/>
           </a:xfrm>
@@ -23474,7 +25917,7 @@
       </p:sp>
       <p:sp>
         <p:nvSpPr>
-          <p:cNvPr id="63" name="TextBox 62"/>
+          <p:cNvPr id="68" name="TextBox 67"/>
           <p:cNvSpPr txBox="1"/>
           <p:nvPr/>
         </p:nvSpPr>
@@ -23509,7 +25952,7 @@
       </p:sp>
       <p:sp>
         <p:nvSpPr>
-          <p:cNvPr id="64" name="TextBox 63"/>
+          <p:cNvPr id="69" name="TextBox 68"/>
           <p:cNvSpPr txBox="1"/>
           <p:nvPr/>
         </p:nvSpPr>

</xml_diff>

<commit_message>
Add REFERENCE.md §91–§93: system design, PowerPoint 365, materials selection
- §91 System Design Interview (Groks King) — framework, capacity estimation,
  11 worked system designs, consistent hashing, mapped to prototype back-end
- §92 Microsoft PowerPoint 365 Pro (Lemmings) — environment, masters,
  typography, animations, presenting, shortcuts, design principles
- §93 Computer-Aided Materials Selection / CAMSS (NMAB-467) — knowledge-base
  and expert-system design, concurrent engineering, transferable to rules engines

Library now 23,112 lines · 93 sections · 102 books. Stats updated across
CLAUDE.md, MANIFEST.md, build_manifest.py; Project Record deck rebuilt.

Co-Authored-By: Claude Opus 4.8 <noreply@anthropic.com>
Claude-Session: https://claude.ai/code/session_012EFETGbhdxdnPCjpmQ9UDz
</commit_message>
<xml_diff>
--- a/Santander_Project_Record.pptx
+++ b/Santander_Project_Record.pptx
@@ -4379,7 +4379,7 @@
                 </a:solidFill>
                 <a:latin typeface="Calibri"/>
               </a:rPr>
-              <a:t>22,935 lines · 90 sections · 99 books &amp; regulatory documents · §90 complaint handling framework</a:t>
+              <a:t>23,112 lines · 93 sections · 102 books &amp; regulatory documents · §91–93 system design, PowerPoint, materials</a:t>
             </a:r>
           </a:p>
         </p:txBody>
@@ -4500,7 +4500,7 @@
                 </a:solidFill>
                 <a:latin typeface="Calibri"/>
               </a:rPr>
-              <a:t>22,935</a:t>
+              <a:t>23,112</a:t>
             </a:r>
           </a:p>
         </p:txBody>
@@ -4613,7 +4613,7 @@
                 </a:solidFill>
                 <a:latin typeface="Calibri"/>
               </a:rPr>
-              <a:t>90</a:t>
+              <a:t>93</a:t>
             </a:r>
           </a:p>
         </p:txBody>
@@ -4726,7 +4726,7 @@
                 </a:solidFill>
                 <a:latin typeface="Calibri"/>
               </a:rPr>
-              <a:t>99</a:t>
+              <a:t>102</a:t>
             </a:r>
           </a:p>
         </p:txBody>
@@ -4987,7 +4987,7 @@
                 </a:solidFill>
                 <a:latin typeface="Calibri"/>
               </a:rPr>
-              <a:t>§1–22</a:t>
+              <a:t>§1–22, §91</a:t>
             </a:r>
           </a:p>
         </p:txBody>
@@ -5067,7 +5067,7 @@
                 </a:solidFill>
                 <a:latin typeface="Calibri"/>
               </a:rPr>
-              <a:t>Python · SQL · FastAPI · Docker · Git · React/JS · JWT · HTTP · Linux · Security · Pydantic · async · pytest</a:t>
+              <a:t>Python · SQL · FastAPI · Docker · Git · React/JS · JWT · HTTP · Linux · Security · Pydantic · async · pytest · System Design Interview (King)</a:t>
             </a:r>
           </a:p>
         </p:txBody>
@@ -6145,7 +6145,7 @@
                 </a:solidFill>
                 <a:latin typeface="Calibri"/>
               </a:rPr>
-              <a:t>§27–33, §64–65, §76</a:t>
+              <a:t>§27–33, §64–65, §76, §92</a:t>
             </a:r>
           </a:p>
         </p:txBody>
@@ -6225,7 +6225,7 @@
                 </a:solidFill>
                 <a:latin typeface="Calibri"/>
               </a:rPr>
-              <a:t>Power Teams · Power BI (×2) · PowerPoint (×2) · SharePoint · Dynamics 365 BC AL · Azure AI Engineer AI-102</a:t>
+              <a:t>Power Teams · Power BI (×2) · PowerPoint (×3 — incl. 365 Pro/Lemmings) · SharePoint · Dynamics 365 BC AL · Azure AI Engineer AI-102</a:t>
             </a:r>
           </a:p>
         </p:txBody>
@@ -6496,7 +6496,7 @@
                 </a:solidFill>
                 <a:latin typeface="Calibri"/>
               </a:rPr>
-              <a:t>Electronics · Hardware · IoT</a:t>
+              <a:t>Electronics · Hardware · Engineering Design</a:t>
             </a:r>
           </a:p>
         </p:txBody>
@@ -6531,7 +6531,7 @@
                 </a:solidFill>
                 <a:latin typeface="Calibri"/>
               </a:rPr>
-              <a:t>§43–49, §54, §57, §89</a:t>
+              <a:t>§43–49, §54, §57, §89, §93</a:t>
             </a:r>
           </a:p>
         </p:txBody>
@@ -6611,7 +6611,7 @@
                 </a:solidFill>
                 <a:latin typeface="Calibri"/>
               </a:rPr>
-              <a:t>MakerSpace · Electronics · Mechatronics · Digital Logic · Devices &amp; Circuits · Arduino/IoT · Embedded Linux · ISO GD&amp;T (Green)</a:t>
+              <a:t>MakerSpace · Electronics · Mechatronics · Digital Logic · Arduino/IoT · Embedded Linux · ISO GD&amp;T (Green) · CAMSS Materials Selection (NMAB-467)</a:t>
             </a:r>
           </a:p>
         </p:txBody>
@@ -15180,7 +15180,7 @@
                 </a:solidFill>
                 <a:latin typeface="Calibri"/>
               </a:rPr>
-              <a:t>Reference library (90 sections · §90 complaints)</a:t>
+              <a:t>Reference library (93 sections · 102 books)</a:t>
             </a:r>
           </a:p>
         </p:txBody>

</xml_diff>

<commit_message>
Add REFERENCE.md §94–§96: LibreOffice extensions, KDP formatting, PDF→EPUB
- §94 Installing Extensions in LibreOffice (Weber/TDF) — Extension Manager,
  .oxt install, unopkg, popular extension categories
- §95 KDP Formatting with LibreOffice (Heliose) — trim sizes, paperback vs
  hardcover, page styles, gutters, print-ready PDF export, reusable templates
- §96 Converting PDF Books to EPUB with Calibre & LibreOffice (Frobnitz) —
  Calibre+Writer+regex workflow, Styles-as-structure, paragraph-rejoin regex

Library now 23,260 lines · 96 sections · 105 books. Stats synced across
CLAUDE.md, MANIFEST.md, build_manifest.py; Project Record deck rebuilt.

Co-Authored-By: Claude Opus 4.8 <noreply@anthropic.com>
Claude-Session: https://claude.ai/code/session_012EFETGbhdxdnPCjpmQ9UDz
</commit_message>
<xml_diff>
--- a/Santander_Project_Record.pptx
+++ b/Santander_Project_Record.pptx
@@ -4457,7 +4457,7 @@
                 </a:solidFill>
                 <a:latin typeface="Calibri"/>
               </a:rPr>
-              <a:t>23,112 lines · 93 sections · 102 books &amp; regulatory documents · §91–93 system design, PowerPoint, materials</a:t>
+              <a:t>23,260 lines · 96 sections · 105 books &amp; regulatory documents · §94–96 LibreOffice, KDP, PDF→EPUB</a:t>
             </a:r>
           </a:p>
         </p:txBody>
@@ -4578,7 +4578,7 @@
                 </a:solidFill>
                 <a:latin typeface="Calibri"/>
               </a:rPr>
-              <a:t>23,112</a:t>
+              <a:t>23,260</a:t>
             </a:r>
           </a:p>
         </p:txBody>
@@ -4691,7 +4691,7 @@
                 </a:solidFill>
                 <a:latin typeface="Calibri"/>
               </a:rPr>
-              <a:t>93</a:t>
+              <a:t>96</a:t>
             </a:r>
           </a:p>
         </p:txBody>
@@ -4804,7 +4804,7 @@
                 </a:solidFill>
                 <a:latin typeface="Calibri"/>
               </a:rPr>
-              <a:t>102</a:t>
+              <a:t>105</a:t>
             </a:r>
           </a:p>
         </p:txBody>
@@ -6188,7 +6188,7 @@
                 </a:solidFill>
                 <a:latin typeface="Calibri"/>
               </a:rPr>
-              <a:t>Microsoft Ecosystem</a:t>
+              <a:t>Office, Docs &amp; Publishing</a:t>
             </a:r>
           </a:p>
         </p:txBody>
@@ -6223,7 +6223,7 @@
                 </a:solidFill>
                 <a:latin typeface="Calibri"/>
               </a:rPr>
-              <a:t>§27–33, §64–65, §76, §92</a:t>
+              <a:t>§27–33, §64–65, §76, §92, §94–96</a:t>
             </a:r>
           </a:p>
         </p:txBody>
@@ -6303,7 +6303,7 @@
                 </a:solidFill>
                 <a:latin typeface="Calibri"/>
               </a:rPr>
-              <a:t>Power Teams · Power BI (×2) · PowerPoint (×3 — incl. 365 Pro/Lemmings) · SharePoint · Dynamics 365 BC AL · Azure AI Engineer AI-102</a:t>
+              <a:t>Power Teams · Power BI · PowerPoint (×3) · SharePoint · Dynamics 365 BC AL · Azure AI-102 · LibreOffice Extensions · KDP Formatting · PDF→EPUB (Calibre)</a:t>
             </a:r>
           </a:p>
         </p:txBody>
@@ -15328,7 +15328,7 @@
                 </a:solidFill>
                 <a:latin typeface="Calibri"/>
               </a:rPr>
-              <a:t>Reference library (93 sections · 102 books)</a:t>
+              <a:t>Reference library (96 sections · 105 books)</a:t>
             </a:r>
           </a:p>
         </p:txBody>

</xml_diff>

<commit_message>
Add REFERENCE.md §97 Senior Managers Regime and §98 Mastering Prezi
- §97 Individual Accountability Under the SMR (Berman, Macfarlanes/Thomson
  Reuters) — SMFs, Statements of Responsibilities, Conduct Rules, Duty of
  Responsibility, reasonable steps, NEDs, cultural attribution, attestations,
  directors' dilemma, key cases (Pottage, Cummings, HomeServe, Swinton,
  Caplin, Burns); mapped to prototype dual-auth and audit-trail controls
- §98 Mastering Prezi for Business Presentations (Anderson-Williams/Sylvia,
  Packt) — non-linear design, BIG picture, mechanics, branding/CSS, slide
  import, raster vs vector, audio/video, projectors, API menus, collaboration

Library now 23,427 lines · 98 sections · 107 books. Stats synced across
CLAUDE.md, MANIFEST.md, build_manifest.py; Project Record deck rebuilt.

Co-Authored-By: Claude Opus 4.8 <noreply@anthropic.com>
Claude-Session: https://claude.ai/code/session_012EFETGbhdxdnPCjpmQ9UDz
</commit_message>
<xml_diff>
--- a/Santander_Project_Record.pptx
+++ b/Santander_Project_Record.pptx
@@ -4457,7 +4457,7 @@
                 </a:solidFill>
                 <a:latin typeface="Calibri"/>
               </a:rPr>
-              <a:t>23,260 lines · 96 sections · 105 books &amp; regulatory documents · §94–96 LibreOffice, KDP, PDF→EPUB</a:t>
+              <a:t>23,427 lines · 98 sections · 107 books &amp; regulatory documents · §97 Senior Managers Regime · §98 Prezi</a:t>
             </a:r>
           </a:p>
         </p:txBody>
@@ -4578,7 +4578,7 @@
                 </a:solidFill>
                 <a:latin typeface="Calibri"/>
               </a:rPr>
-              <a:t>23,260</a:t>
+              <a:t>23,427</a:t>
             </a:r>
           </a:p>
         </p:txBody>
@@ -4691,7 +4691,7 @@
                 </a:solidFill>
                 <a:latin typeface="Calibri"/>
               </a:rPr>
-              <a:t>96</a:t>
+              <a:t>98</a:t>
             </a:r>
           </a:p>
         </p:txBody>
@@ -4804,7 +4804,7 @@
                 </a:solidFill>
                 <a:latin typeface="Calibri"/>
               </a:rPr>
-              <a:t>105</a:t>
+              <a:t>107</a:t>
             </a:r>
           </a:p>
         </p:txBody>
@@ -5644,7 +5644,7 @@
                 </a:solidFill>
                 <a:latin typeface="Calibri"/>
               </a:rPr>
-              <a:t>§36–40, §87–88</a:t>
+              <a:t>§36–40, §87–88, §97</a:t>
             </a:r>
           </a:p>
         </p:txBody>
@@ -5724,7 +5724,7 @@
                 </a:solidFill>
                 <a:latin typeface="Calibri"/>
               </a:rPr>
-              <a:t>PRA/PRC · Basel 3.1 · SS19/13 Resolution Planning · MREL · CNRF · Deposit Aggregators · LEI/SSI · KYC Passporting · Post-Trade Task Force</a:t>
+              <a:t>PRA/PRC · Basel 3.1 · SS19/13 Resolution · MREL · CNRF · Deposit Aggregators · Post-Trade Task Force · Senior Managers Regime (Berman)</a:t>
             </a:r>
           </a:p>
         </p:txBody>
@@ -6223,7 +6223,7 @@
                 </a:solidFill>
                 <a:latin typeface="Calibri"/>
               </a:rPr>
-              <a:t>§27–33, §64–65, §76, §92, §94–96</a:t>
+              <a:t>§27–33, §64–65, §76, §92, §94–96, §98</a:t>
             </a:r>
           </a:p>
         </p:txBody>
@@ -6303,7 +6303,7 @@
                 </a:solidFill>
                 <a:latin typeface="Calibri"/>
               </a:rPr>
-              <a:t>Power Teams · Power BI · PowerPoint (×3) · SharePoint · Dynamics 365 BC AL · Azure AI-102 · LibreOffice Extensions · KDP Formatting · PDF→EPUB (Calibre)</a:t>
+              <a:t>Power Teams · Power BI · PowerPoint (×3) · SharePoint · Dynamics 365 BC AL · Azure AI-102 · LibreOffice · KDP · PDF→EPUB · Mastering Prezi (Anderson-Williams)</a:t>
             </a:r>
           </a:p>
         </p:txBody>
@@ -15328,7 +15328,7 @@
                 </a:solidFill>
                 <a:latin typeface="Calibri"/>
               </a:rPr>
-              <a:t>Reference library (96 sections · 105 books)</a:t>
+              <a:t>Reference library (98 sections · 107 books)</a:t>
             </a:r>
           </a:p>
         </p:txBody>

</xml_diff>

<commit_message>
Add REFERENCE.md §99: Accessibility — WCAG colour contrast
WCAG 2.1 contrast guidance (1.4.3/1.4.6/1.4.11): AA 4.5:1 normal, 3:1 large/UI;
AAA 7:1/4.5:1. Large-text thresholds, WebAIM Contrast Checker + Colour Contrast
Analyser tooling, JSON result interpretation, don't-rely-on-colour for data.
Mapped directly to Bosun's Law standing orders with worked checks of the brand
palette (white on #c8102e ~4.8:1 pass; stone-500 on warm bg ~4.0:1 fail).

Closes the accessibility gap flagged earlier. Library now 23,496 lines ·
99 sections · 108 books. Stats synced; Project Record deck rebuilt.

Co-Authored-By: Claude Opus 4.8 <noreply@anthropic.com>
Claude-Session: https://claude.ai/code/session_012EFETGbhdxdnPCjpmQ9UDz
</commit_message>
<xml_diff>
--- a/Santander_Project_Record.pptx
+++ b/Santander_Project_Record.pptx
@@ -4457,7 +4457,7 @@
                 </a:solidFill>
                 <a:latin typeface="Calibri"/>
               </a:rPr>
-              <a:t>23,427 lines · 98 sections · 107 books &amp; regulatory documents · §97 Senior Managers Regime · §98 Prezi</a:t>
+              <a:t>23,496 lines · 99 sections · 108 books &amp; regulatory documents · §97 SMR · §98 Prezi · §99 WCAG contrast</a:t>
             </a:r>
           </a:p>
         </p:txBody>
@@ -4578,7 +4578,7 @@
                 </a:solidFill>
                 <a:latin typeface="Calibri"/>
               </a:rPr>
-              <a:t>23,427</a:t>
+              <a:t>23,496</a:t>
             </a:r>
           </a:p>
         </p:txBody>
@@ -4691,7 +4691,7 @@
                 </a:solidFill>
                 <a:latin typeface="Calibri"/>
               </a:rPr>
-              <a:t>98</a:t>
+              <a:t>99</a:t>
             </a:r>
           </a:p>
         </p:txBody>
@@ -4804,7 +4804,7 @@
                 </a:solidFill>
                 <a:latin typeface="Calibri"/>
               </a:rPr>
-              <a:t>107</a:t>
+              <a:t>108</a:t>
             </a:r>
           </a:p>
         </p:txBody>
@@ -6381,7 +6381,7 @@
                 </a:solidFill>
                 <a:latin typeface="Calibri"/>
               </a:rPr>
-              <a:t>Employment &amp; Equality Law</a:t>
+              <a:t>Equality &amp; Accessibility</a:t>
             </a:r>
           </a:p>
         </p:txBody>
@@ -6416,7 +6416,7 @@
                 </a:solidFill>
                 <a:latin typeface="Calibri"/>
               </a:rPr>
-              <a:t>§34</a:t>
+              <a:t>§34, §99</a:t>
             </a:r>
           </a:p>
         </p:txBody>
@@ -6496,7 +6496,7 @@
                 </a:solidFill>
                 <a:latin typeface="Calibri"/>
               </a:rPr>
-              <a:t>Equality Act 2010 · Nine protected characteristics · WCAG accessibility legal duty · Reasonable adjustments</a:t>
+              <a:t>Equality Act 2010 · Protected characteristics · Reasonable adjustments · WCAG 2.1 colour contrast (4.5:1) · WebAIM/CCA testing</a:t>
             </a:r>
           </a:p>
         </p:txBody>
@@ -15328,7 +15328,7 @@
                 </a:solidFill>
                 <a:latin typeface="Calibri"/>
               </a:rPr>
-              <a:t>Reference library (98 sections · 107 books)</a:t>
+              <a:t>Reference library (99 sections · 108 books)</a:t>
             </a:r>
           </a:p>
         </p:txBody>

</xml_diff>

<commit_message>
Add REFERENCE.md §112: Financial Fraud Detection Using ML (Ma & Wu)
AI/ML fraud-detection counterpart to §107 (Financial Shenanigans) and §108
(Fraud Act): the statistics-to-AI detection arc (AUDITCHECK, Benford's Law,
ANN → random forests/XGBoost/LSTM/attention/LLMs), the fraud theories
(Triangle, GONE, Diamond, Pentagon, Hexagon), and the five research
categories. Mapped to the prototype's supplier-risk radar, APP-fraud
scoring, and AML — the Phase-2 path from static RAG badges to learned scores.

Library now 23,846 lines · 112 sections · 121 books. Stats synced across
CLAUDE.md, MANIFEST.md, build_manifest.py; Project Record deck rebuilt.

Co-Authored-By: Claude Opus 4.8 <noreply@anthropic.com>
Claude-Session: https://claude.ai/code/session_012EFETGbhdxdnPCjpmQ9UDz
</commit_message>
<xml_diff>
--- a/Santander_Project_Record.pptx
+++ b/Santander_Project_Record.pptx
@@ -4457,7 +4457,7 @@
                 </a:solidFill>
                 <a:latin typeface="Calibri"/>
               </a:rPr>
-              <a:t>23,812 lines · 111 sections · 120 books &amp; regulatory documents · §100–111 UX, Node.js, TypeScript, C++, financial crime</a:t>
+              <a:t>23,846 lines · 112 sections · 121 books &amp; regulatory documents · §100–112 UX, Node.js, TypeScript, C++, financial crime &amp; ML detection</a:t>
             </a:r>
           </a:p>
         </p:txBody>
@@ -4578,7 +4578,7 @@
                 </a:solidFill>
                 <a:latin typeface="Calibri"/>
               </a:rPr>
-              <a:t>23,812</a:t>
+              <a:t>23,846</a:t>
             </a:r>
           </a:p>
         </p:txBody>
@@ -4691,7 +4691,7 @@
                 </a:solidFill>
                 <a:latin typeface="Calibri"/>
               </a:rPr>
-              <a:t>111</a:t>
+              <a:t>112</a:t>
             </a:r>
           </a:p>
         </p:txBody>
@@ -4804,7 +4804,7 @@
                 </a:solidFill>
                 <a:latin typeface="Calibri"/>
               </a:rPr>
-              <a:t>120</a:t>
+              <a:t>121</a:t>
             </a:r>
           </a:p>
         </p:txBody>
@@ -5644,7 +5644,7 @@
                 </a:solidFill>
                 <a:latin typeface="Calibri"/>
               </a:rPr>
-              <a:t>§36–40, §87–88, §97, §107–108</a:t>
+              <a:t>§36–40, §87–88, §97, §107–108, §112</a:t>
             </a:r>
           </a:p>
         </p:txBody>
@@ -5724,7 +5724,7 @@
                 </a:solidFill>
                 <a:latin typeface="Calibri"/>
               </a:rPr>
-              <a:t>PRA/PRC · Basel 3.1 · Resolution · MREL · Senior Managers Regime (Berman) · Financial Shenanigans (Schilit) · Fraud Act 2006 / Corporate Misconduct (Monaghan)</a:t>
+              <a:t>PRA/PRC · Resolution · MREL · Senior Managers Regime (Berman) · Financial Shenanigans (Schilit) · Fraud Act (Monaghan) · ML Fraud Detection (Ma &amp; Wu)</a:t>
             </a:r>
           </a:p>
         </p:txBody>
@@ -15328,7 +15328,7 @@
                 </a:solidFill>
                 <a:latin typeface="Calibri"/>
               </a:rPr>
-              <a:t>Reference library (111 sections · 120 books)</a:t>
+              <a:t>Reference library (112 sections · 121 books)</a:t>
             </a:r>
           </a:p>
         </p:txBody>

</xml_diff>

<commit_message>
Update Project Record + MANIFEST to 13 workflows (add Standing Orders & DDs)
The prototype gained the Standing Orders & Direct Debits workflow (13 total),
but the technical record still said 12. Updated:
- MANIFEST: workflow count 12 -> 13, added the Standing Orders & DDs row,
  corrected the Signature Queue line (signing is now a personal PIN, not Face ID)
- Project Record deck: "Thirteen Workflow Wizards", stat box 12 -> 13, intro
  line, slide-index entry; added the Standing Orders & DDs card; reflowed the
  workflow grid from 3 to 4 columns so 13 fit in the same vertical space
  (verified zero shape overflow)

Pitch deck intentionally left at its curated "11 — every paper form retired"
headline (a paper-retirement framing) to preserve its clean layout for the
primary presentation; the two counts are each accurate under their framing.

Co-Authored-By: Claude Opus 4.8 <noreply@anthropic.com>
Claude-Session: https://claude.ai/code/session_012EFETGbhdxdnPCjpmQ9UDz
</commit_message>
<xml_diff>
--- a/Santander_Project_Record.pptx
+++ b/Santander_Project_Record.pptx
@@ -3901,7 +3901,7 @@
                 </a:solidFill>
                 <a:latin typeface="Calibri"/>
               </a:rPr>
-              <a:t>12</a:t>
+              <a:t>13</a:t>
             </a:r>
           </a:p>
         </p:txBody>
@@ -14650,7 +14650,7 @@
                 </a:solidFill>
                 <a:latin typeface="Calibri"/>
               </a:rPr>
-              <a:t>Twelve workflows</a:t>
+              <a:t>Thirteen workflows</a:t>
             </a:r>
           </a:p>
         </p:txBody>
@@ -20362,7 +20362,7 @@
                 </a:solidFill>
                 <a:latin typeface="Calibri"/>
               </a:rPr>
-              <a:t>12 step-based workflow wizards covering every key banking operation</a:t>
+              <a:t>13 step-based workflow wizards covering every key banking operation</a:t>
             </a:r>
           </a:p>
           <a:p>
@@ -23713,7 +23713,7 @@
                 </a:solidFill>
                 <a:latin typeface="Calibri"/>
               </a:rPr>
-              <a:t>Twelve Workflow Wizards</a:t>
+              <a:t>Thirteen Workflow Wizards</a:t>
             </a:r>
           </a:p>
         </p:txBody>
@@ -23805,7 +23805,7 @@
         <p:spPr>
           <a:xfrm>
             <a:off x="384048" y="1024128"/>
-            <a:ext cx="3566160" cy="1261872"/>
+            <a:ext cx="2697480" cy="1261872"/>
           </a:xfrm>
           <a:prstGeom prst="rect">
             <a:avLst/>
@@ -23892,23 +23892,23 @@
         </p:nvSpPr>
         <p:spPr>
           <a:xfrm>
-            <a:off x="548640" y="1115568"/>
-            <a:ext cx="3310128" cy="256032"/>
-          </a:xfrm>
-          <a:prstGeom prst="rect">
-            <a:avLst/>
-          </a:prstGeom>
-          <a:noFill/>
-        </p:spPr>
-        <p:txBody>
-          <a:bodyPr wrap="square">
-            <a:noAutofit/>
-          </a:bodyPr>
-          <a:lstStyle/>
-          <a:p>
-            <a:pPr algn="l"/>
-            <a:r>
-              <a:rPr sz="950" b="1" i="0">
+            <a:off x="530352" y="1115568"/>
+            <a:ext cx="2478024" cy="365760"/>
+          </a:xfrm>
+          <a:prstGeom prst="rect">
+            <a:avLst/>
+          </a:prstGeom>
+          <a:noFill/>
+        </p:spPr>
+        <p:txBody>
+          <a:bodyPr wrap="square">
+            <a:noAutofit/>
+          </a:bodyPr>
+          <a:lstStyle/>
+          <a:p>
+            <a:pPr algn="l"/>
+            <a:r>
+              <a:rPr sz="900" b="1" i="0">
                 <a:solidFill>
                   <a:srgbClr val="1C1917"/>
                 </a:solidFill>
@@ -23927,23 +23927,23 @@
         </p:nvSpPr>
         <p:spPr>
           <a:xfrm>
-            <a:off x="548640" y="1353312"/>
-            <a:ext cx="1097280" cy="182880"/>
-          </a:xfrm>
-          <a:prstGeom prst="rect">
-            <a:avLst/>
-          </a:prstGeom>
-          <a:noFill/>
-        </p:spPr>
-        <p:txBody>
-          <a:bodyPr wrap="square">
-            <a:noAutofit/>
-          </a:bodyPr>
-          <a:lstStyle/>
-          <a:p>
-            <a:pPr algn="l"/>
-            <a:r>
-              <a:rPr sz="750" b="1" i="0">
+            <a:off x="530352" y="1444752"/>
+            <a:ext cx="2478024" cy="182880"/>
+          </a:xfrm>
+          <a:prstGeom prst="rect">
+            <a:avLst/>
+          </a:prstGeom>
+          <a:noFill/>
+        </p:spPr>
+        <p:txBody>
+          <a:bodyPr wrap="square">
+            <a:noAutofit/>
+          </a:bodyPr>
+          <a:lstStyle/>
+          <a:p>
+            <a:pPr algn="l"/>
+            <a:r>
+              <a:rPr sz="700" b="1" i="0">
                 <a:solidFill>
                   <a:srgbClr val="C8102E"/>
                 </a:solidFill>
@@ -23962,8 +23962,8 @@
         </p:nvSpPr>
         <p:spPr>
           <a:xfrm>
-            <a:off x="548640" y="1527048"/>
-            <a:ext cx="3291840" cy="713232"/>
+            <a:off x="530352" y="1627632"/>
+            <a:ext cx="2441448" cy="603504"/>
           </a:xfrm>
           <a:prstGeom prst="rect">
             <a:avLst/>
@@ -23978,11 +23978,11 @@
           <a:p>
             <a:pPr>
               <a:spcAft>
-                <a:spcPts val="300"/>
+                <a:spcPts val="200"/>
               </a:spcAft>
             </a:pPr>
             <a:r>
-              <a:rPr sz="800">
+              <a:rPr sz="700">
                 <a:solidFill>
                   <a:srgbClr val="78716C"/>
                 </a:solidFill>
@@ -24001,8 +24001,8 @@
         </p:nvSpPr>
         <p:spPr>
           <a:xfrm>
-            <a:off x="4123944" y="1024128"/>
-            <a:ext cx="3566160" cy="1261872"/>
+            <a:off x="3246120" y="1024128"/>
+            <a:ext cx="2697480" cy="1261872"/>
           </a:xfrm>
           <a:prstGeom prst="rect">
             <a:avLst/>
@@ -24046,7 +24046,7 @@
         </p:nvSpPr>
         <p:spPr>
           <a:xfrm>
-            <a:off x="4123944" y="1024128"/>
+            <a:off x="3246120" y="1024128"/>
             <a:ext cx="50292" cy="1261872"/>
           </a:xfrm>
           <a:prstGeom prst="rect">
@@ -24089,23 +24089,23 @@
         </p:nvSpPr>
         <p:spPr>
           <a:xfrm>
-            <a:off x="4288536" y="1115568"/>
-            <a:ext cx="3310128" cy="256032"/>
-          </a:xfrm>
-          <a:prstGeom prst="rect">
-            <a:avLst/>
-          </a:prstGeom>
-          <a:noFill/>
-        </p:spPr>
-        <p:txBody>
-          <a:bodyPr wrap="square">
-            <a:noAutofit/>
-          </a:bodyPr>
-          <a:lstStyle/>
-          <a:p>
-            <a:pPr algn="l"/>
-            <a:r>
-              <a:rPr sz="950" b="1" i="0">
+            <a:off x="3392424" y="1115568"/>
+            <a:ext cx="2478024" cy="365760"/>
+          </a:xfrm>
+          <a:prstGeom prst="rect">
+            <a:avLst/>
+          </a:prstGeom>
+          <a:noFill/>
+        </p:spPr>
+        <p:txBody>
+          <a:bodyPr wrap="square">
+            <a:noAutofit/>
+          </a:bodyPr>
+          <a:lstStyle/>
+          <a:p>
+            <a:pPr algn="l"/>
+            <a:r>
+              <a:rPr sz="900" b="1" i="0">
                 <a:solidFill>
                   <a:srgbClr val="1C1917"/>
                 </a:solidFill>
@@ -24124,23 +24124,23 @@
         </p:nvSpPr>
         <p:spPr>
           <a:xfrm>
-            <a:off x="4288536" y="1353312"/>
-            <a:ext cx="1097280" cy="182880"/>
-          </a:xfrm>
-          <a:prstGeom prst="rect">
-            <a:avLst/>
-          </a:prstGeom>
-          <a:noFill/>
-        </p:spPr>
-        <p:txBody>
-          <a:bodyPr wrap="square">
-            <a:noAutofit/>
-          </a:bodyPr>
-          <a:lstStyle/>
-          <a:p>
-            <a:pPr algn="l"/>
-            <a:r>
-              <a:rPr sz="750" b="1" i="0">
+            <a:off x="3392424" y="1444752"/>
+            <a:ext cx="2478024" cy="182880"/>
+          </a:xfrm>
+          <a:prstGeom prst="rect">
+            <a:avLst/>
+          </a:prstGeom>
+          <a:noFill/>
+        </p:spPr>
+        <p:txBody>
+          <a:bodyPr wrap="square">
+            <a:noAutofit/>
+          </a:bodyPr>
+          <a:lstStyle/>
+          <a:p>
+            <a:pPr algn="l"/>
+            <a:r>
+              <a:rPr sz="700" b="1" i="0">
                 <a:solidFill>
                   <a:srgbClr val="C8102E"/>
                 </a:solidFill>
@@ -24159,8 +24159,8 @@
         </p:nvSpPr>
         <p:spPr>
           <a:xfrm>
-            <a:off x="4288536" y="1527048"/>
-            <a:ext cx="3291840" cy="713232"/>
+            <a:off x="3392424" y="1627632"/>
+            <a:ext cx="2441448" cy="603504"/>
           </a:xfrm>
           <a:prstGeom prst="rect">
             <a:avLst/>
@@ -24175,11 +24175,11 @@
           <a:p>
             <a:pPr>
               <a:spcAft>
-                <a:spcPts val="300"/>
+                <a:spcPts val="200"/>
               </a:spcAft>
             </a:pPr>
             <a:r>
-              <a:rPr sz="800">
+              <a:rPr sz="700">
                 <a:solidFill>
                   <a:srgbClr val="78716C"/>
                 </a:solidFill>
@@ -24198,8 +24198,8 @@
         </p:nvSpPr>
         <p:spPr>
           <a:xfrm>
-            <a:off x="7863840" y="1024128"/>
-            <a:ext cx="3566160" cy="1261872"/>
+            <a:off x="6108192" y="1024128"/>
+            <a:ext cx="2697480" cy="1261872"/>
           </a:xfrm>
           <a:prstGeom prst="rect">
             <a:avLst/>
@@ -24243,7 +24243,7 @@
         </p:nvSpPr>
         <p:spPr>
           <a:xfrm>
-            <a:off x="7863840" y="1024128"/>
+            <a:off x="6108192" y="1024128"/>
             <a:ext cx="50292" cy="1261872"/>
           </a:xfrm>
           <a:prstGeom prst="rect">
@@ -24286,23 +24286,23 @@
         </p:nvSpPr>
         <p:spPr>
           <a:xfrm>
-            <a:off x="8028431" y="1115568"/>
-            <a:ext cx="3310128" cy="256032"/>
-          </a:xfrm>
-          <a:prstGeom prst="rect">
-            <a:avLst/>
-          </a:prstGeom>
-          <a:noFill/>
-        </p:spPr>
-        <p:txBody>
-          <a:bodyPr wrap="square">
-            <a:noAutofit/>
-          </a:bodyPr>
-          <a:lstStyle/>
-          <a:p>
-            <a:pPr algn="l"/>
-            <a:r>
-              <a:rPr sz="950" b="1" i="0">
+            <a:off x="6254496" y="1115568"/>
+            <a:ext cx="2478024" cy="365760"/>
+          </a:xfrm>
+          <a:prstGeom prst="rect">
+            <a:avLst/>
+          </a:prstGeom>
+          <a:noFill/>
+        </p:spPr>
+        <p:txBody>
+          <a:bodyPr wrap="square">
+            <a:noAutofit/>
+          </a:bodyPr>
+          <a:lstStyle/>
+          <a:p>
+            <a:pPr algn="l"/>
+            <a:r>
+              <a:rPr sz="900" b="1" i="0">
                 <a:solidFill>
                   <a:srgbClr val="1C1917"/>
                 </a:solidFill>
@@ -24321,23 +24321,23 @@
         </p:nvSpPr>
         <p:spPr>
           <a:xfrm>
-            <a:off x="8028431" y="1353312"/>
-            <a:ext cx="1097280" cy="182880"/>
-          </a:xfrm>
-          <a:prstGeom prst="rect">
-            <a:avLst/>
-          </a:prstGeom>
-          <a:noFill/>
-        </p:spPr>
-        <p:txBody>
-          <a:bodyPr wrap="square">
-            <a:noAutofit/>
-          </a:bodyPr>
-          <a:lstStyle/>
-          <a:p>
-            <a:pPr algn="l"/>
-            <a:r>
-              <a:rPr sz="750" b="1" i="0">
+            <a:off x="6254496" y="1444752"/>
+            <a:ext cx="2478024" cy="182880"/>
+          </a:xfrm>
+          <a:prstGeom prst="rect">
+            <a:avLst/>
+          </a:prstGeom>
+          <a:noFill/>
+        </p:spPr>
+        <p:txBody>
+          <a:bodyPr wrap="square">
+            <a:noAutofit/>
+          </a:bodyPr>
+          <a:lstStyle/>
+          <a:p>
+            <a:pPr algn="l"/>
+            <a:r>
+              <a:rPr sz="700" b="1" i="0">
                 <a:solidFill>
                   <a:srgbClr val="C8102E"/>
                 </a:solidFill>
@@ -24356,8 +24356,8 @@
         </p:nvSpPr>
         <p:spPr>
           <a:xfrm>
-            <a:off x="8028431" y="1527048"/>
-            <a:ext cx="3291840" cy="713232"/>
+            <a:off x="6254496" y="1627632"/>
+            <a:ext cx="2441448" cy="603504"/>
           </a:xfrm>
           <a:prstGeom prst="rect">
             <a:avLst/>
@@ -24372,11 +24372,11 @@
           <a:p>
             <a:pPr>
               <a:spcAft>
-                <a:spcPts val="300"/>
+                <a:spcPts val="200"/>
               </a:spcAft>
             </a:pPr>
             <a:r>
-              <a:rPr sz="800">
+              <a:rPr sz="700">
                 <a:solidFill>
                   <a:srgbClr val="78716C"/>
                 </a:solidFill>
@@ -24395,8 +24395,8 @@
         </p:nvSpPr>
         <p:spPr>
           <a:xfrm>
-            <a:off x="384048" y="2432304"/>
-            <a:ext cx="3566160" cy="1261872"/>
+            <a:off x="8970264" y="1024128"/>
+            <a:ext cx="2697480" cy="1261872"/>
           </a:xfrm>
           <a:prstGeom prst="rect">
             <a:avLst/>
@@ -24440,7 +24440,7 @@
         </p:nvSpPr>
         <p:spPr>
           <a:xfrm>
-            <a:off x="384048" y="2432304"/>
+            <a:off x="8970264" y="1024128"/>
             <a:ext cx="50292" cy="1261872"/>
           </a:xfrm>
           <a:prstGeom prst="rect">
@@ -24483,23 +24483,23 @@
         </p:nvSpPr>
         <p:spPr>
           <a:xfrm>
-            <a:off x="548640" y="2523744"/>
-            <a:ext cx="3310128" cy="256032"/>
-          </a:xfrm>
-          <a:prstGeom prst="rect">
-            <a:avLst/>
-          </a:prstGeom>
-          <a:noFill/>
-        </p:spPr>
-        <p:txBody>
-          <a:bodyPr wrap="square">
-            <a:noAutofit/>
-          </a:bodyPr>
-          <a:lstStyle/>
-          <a:p>
-            <a:pPr algn="l"/>
-            <a:r>
-              <a:rPr sz="950" b="1" i="0">
+            <a:off x="9116568" y="1115568"/>
+            <a:ext cx="2478024" cy="365760"/>
+          </a:xfrm>
+          <a:prstGeom prst="rect">
+            <a:avLst/>
+          </a:prstGeom>
+          <a:noFill/>
+        </p:spPr>
+        <p:txBody>
+          <a:bodyPr wrap="square">
+            <a:noAutofit/>
+          </a:bodyPr>
+          <a:lstStyle/>
+          <a:p>
+            <a:pPr algn="l"/>
+            <a:r>
+              <a:rPr sz="900" b="1" i="0">
                 <a:solidFill>
                   <a:srgbClr val="1C1917"/>
                 </a:solidFill>
@@ -24518,23 +24518,23 @@
         </p:nvSpPr>
         <p:spPr>
           <a:xfrm>
-            <a:off x="548640" y="2761488"/>
-            <a:ext cx="1097280" cy="182880"/>
-          </a:xfrm>
-          <a:prstGeom prst="rect">
-            <a:avLst/>
-          </a:prstGeom>
-          <a:noFill/>
-        </p:spPr>
-        <p:txBody>
-          <a:bodyPr wrap="square">
-            <a:noAutofit/>
-          </a:bodyPr>
-          <a:lstStyle/>
-          <a:p>
-            <a:pPr algn="l"/>
-            <a:r>
-              <a:rPr sz="750" b="1" i="0">
+            <a:off x="9116568" y="1444752"/>
+            <a:ext cx="2478024" cy="182880"/>
+          </a:xfrm>
+          <a:prstGeom prst="rect">
+            <a:avLst/>
+          </a:prstGeom>
+          <a:noFill/>
+        </p:spPr>
+        <p:txBody>
+          <a:bodyPr wrap="square">
+            <a:noAutofit/>
+          </a:bodyPr>
+          <a:lstStyle/>
+          <a:p>
+            <a:pPr algn="l"/>
+            <a:r>
+              <a:rPr sz="700" b="1" i="0">
                 <a:solidFill>
                   <a:srgbClr val="C8102E"/>
                 </a:solidFill>
@@ -24553,8 +24553,8 @@
         </p:nvSpPr>
         <p:spPr>
           <a:xfrm>
-            <a:off x="548640" y="2935224"/>
-            <a:ext cx="3291840" cy="713232"/>
+            <a:off x="9116568" y="1627632"/>
+            <a:ext cx="2441448" cy="603504"/>
           </a:xfrm>
           <a:prstGeom prst="rect">
             <a:avLst/>
@@ -24569,11 +24569,11 @@
           <a:p>
             <a:pPr>
               <a:spcAft>
-                <a:spcPts val="300"/>
+                <a:spcPts val="200"/>
               </a:spcAft>
             </a:pPr>
             <a:r>
-              <a:rPr sz="800">
+              <a:rPr sz="700">
                 <a:solidFill>
                   <a:srgbClr val="78716C"/>
                 </a:solidFill>
@@ -24592,8 +24592,8 @@
         </p:nvSpPr>
         <p:spPr>
           <a:xfrm>
-            <a:off x="4123944" y="2432304"/>
-            <a:ext cx="3566160" cy="1261872"/>
+            <a:off x="384048" y="2432304"/>
+            <a:ext cx="2697480" cy="1261872"/>
           </a:xfrm>
           <a:prstGeom prst="rect">
             <a:avLst/>
@@ -24637,7 +24637,7 @@
         </p:nvSpPr>
         <p:spPr>
           <a:xfrm>
-            <a:off x="4123944" y="2432304"/>
+            <a:off x="384048" y="2432304"/>
             <a:ext cx="50292" cy="1261872"/>
           </a:xfrm>
           <a:prstGeom prst="rect">
@@ -24680,23 +24680,23 @@
         </p:nvSpPr>
         <p:spPr>
           <a:xfrm>
-            <a:off x="4288536" y="2523744"/>
-            <a:ext cx="3310128" cy="256032"/>
-          </a:xfrm>
-          <a:prstGeom prst="rect">
-            <a:avLst/>
-          </a:prstGeom>
-          <a:noFill/>
-        </p:spPr>
-        <p:txBody>
-          <a:bodyPr wrap="square">
-            <a:noAutofit/>
-          </a:bodyPr>
-          <a:lstStyle/>
-          <a:p>
-            <a:pPr algn="l"/>
-            <a:r>
-              <a:rPr sz="950" b="1" i="0">
+            <a:off x="530352" y="2523744"/>
+            <a:ext cx="2478024" cy="365760"/>
+          </a:xfrm>
+          <a:prstGeom prst="rect">
+            <a:avLst/>
+          </a:prstGeom>
+          <a:noFill/>
+        </p:spPr>
+        <p:txBody>
+          <a:bodyPr wrap="square">
+            <a:noAutofit/>
+          </a:bodyPr>
+          <a:lstStyle/>
+          <a:p>
+            <a:pPr algn="l"/>
+            <a:r>
+              <a:rPr sz="900" b="1" i="0">
                 <a:solidFill>
                   <a:srgbClr val="1C1917"/>
                 </a:solidFill>
@@ -24715,23 +24715,23 @@
         </p:nvSpPr>
         <p:spPr>
           <a:xfrm>
-            <a:off x="4288536" y="2761488"/>
-            <a:ext cx="1097280" cy="182880"/>
-          </a:xfrm>
-          <a:prstGeom prst="rect">
-            <a:avLst/>
-          </a:prstGeom>
-          <a:noFill/>
-        </p:spPr>
-        <p:txBody>
-          <a:bodyPr wrap="square">
-            <a:noAutofit/>
-          </a:bodyPr>
-          <a:lstStyle/>
-          <a:p>
-            <a:pPr algn="l"/>
-            <a:r>
-              <a:rPr sz="750" b="1" i="0">
+            <a:off x="530352" y="2852928"/>
+            <a:ext cx="2478024" cy="182880"/>
+          </a:xfrm>
+          <a:prstGeom prst="rect">
+            <a:avLst/>
+          </a:prstGeom>
+          <a:noFill/>
+        </p:spPr>
+        <p:txBody>
+          <a:bodyPr wrap="square">
+            <a:noAutofit/>
+          </a:bodyPr>
+          <a:lstStyle/>
+          <a:p>
+            <a:pPr algn="l"/>
+            <a:r>
+              <a:rPr sz="700" b="1" i="0">
                 <a:solidFill>
                   <a:srgbClr val="C8102E"/>
                 </a:solidFill>
@@ -24750,8 +24750,8 @@
         </p:nvSpPr>
         <p:spPr>
           <a:xfrm>
-            <a:off x="4288536" y="2935224"/>
-            <a:ext cx="3291840" cy="713232"/>
+            <a:off x="530352" y="3035808"/>
+            <a:ext cx="2441448" cy="603504"/>
           </a:xfrm>
           <a:prstGeom prst="rect">
             <a:avLst/>
@@ -24766,11 +24766,11 @@
           <a:p>
             <a:pPr>
               <a:spcAft>
-                <a:spcPts val="300"/>
+                <a:spcPts val="200"/>
               </a:spcAft>
             </a:pPr>
             <a:r>
-              <a:rPr sz="800">
+              <a:rPr sz="700">
                 <a:solidFill>
                   <a:srgbClr val="78716C"/>
                 </a:solidFill>
@@ -24789,8 +24789,8 @@
         </p:nvSpPr>
         <p:spPr>
           <a:xfrm>
-            <a:off x="7863840" y="2432304"/>
-            <a:ext cx="3566160" cy="1261872"/>
+            <a:off x="3246120" y="2432304"/>
+            <a:ext cx="2697480" cy="1261872"/>
           </a:xfrm>
           <a:prstGeom prst="rect">
             <a:avLst/>
@@ -24834,7 +24834,7 @@
         </p:nvSpPr>
         <p:spPr>
           <a:xfrm>
-            <a:off x="7863840" y="2432304"/>
+            <a:off x="3246120" y="2432304"/>
             <a:ext cx="50292" cy="1261872"/>
           </a:xfrm>
           <a:prstGeom prst="rect">
@@ -24877,23 +24877,23 @@
         </p:nvSpPr>
         <p:spPr>
           <a:xfrm>
-            <a:off x="8028431" y="2523744"/>
-            <a:ext cx="3310128" cy="256032"/>
-          </a:xfrm>
-          <a:prstGeom prst="rect">
-            <a:avLst/>
-          </a:prstGeom>
-          <a:noFill/>
-        </p:spPr>
-        <p:txBody>
-          <a:bodyPr wrap="square">
-            <a:noAutofit/>
-          </a:bodyPr>
-          <a:lstStyle/>
-          <a:p>
-            <a:pPr algn="l"/>
-            <a:r>
-              <a:rPr sz="950" b="1" i="0">
+            <a:off x="3392424" y="2523744"/>
+            <a:ext cx="2478024" cy="365760"/>
+          </a:xfrm>
+          <a:prstGeom prst="rect">
+            <a:avLst/>
+          </a:prstGeom>
+          <a:noFill/>
+        </p:spPr>
+        <p:txBody>
+          <a:bodyPr wrap="square">
+            <a:noAutofit/>
+          </a:bodyPr>
+          <a:lstStyle/>
+          <a:p>
+            <a:pPr algn="l"/>
+            <a:r>
+              <a:rPr sz="900" b="1" i="0">
                 <a:solidFill>
                   <a:srgbClr val="1C1917"/>
                 </a:solidFill>
@@ -24912,23 +24912,23 @@
         </p:nvSpPr>
         <p:spPr>
           <a:xfrm>
-            <a:off x="8028431" y="2761488"/>
-            <a:ext cx="1097280" cy="182880"/>
-          </a:xfrm>
-          <a:prstGeom prst="rect">
-            <a:avLst/>
-          </a:prstGeom>
-          <a:noFill/>
-        </p:spPr>
-        <p:txBody>
-          <a:bodyPr wrap="square">
-            <a:noAutofit/>
-          </a:bodyPr>
-          <a:lstStyle/>
-          <a:p>
-            <a:pPr algn="l"/>
-            <a:r>
-              <a:rPr sz="750" b="1" i="0">
+            <a:off x="3392424" y="2852928"/>
+            <a:ext cx="2478024" cy="182880"/>
+          </a:xfrm>
+          <a:prstGeom prst="rect">
+            <a:avLst/>
+          </a:prstGeom>
+          <a:noFill/>
+        </p:spPr>
+        <p:txBody>
+          <a:bodyPr wrap="square">
+            <a:noAutofit/>
+          </a:bodyPr>
+          <a:lstStyle/>
+          <a:p>
+            <a:pPr algn="l"/>
+            <a:r>
+              <a:rPr sz="700" b="1" i="0">
                 <a:solidFill>
                   <a:srgbClr val="C8102E"/>
                 </a:solidFill>
@@ -24947,8 +24947,8 @@
         </p:nvSpPr>
         <p:spPr>
           <a:xfrm>
-            <a:off x="8028431" y="2935224"/>
-            <a:ext cx="3291840" cy="713232"/>
+            <a:off x="3392424" y="3035808"/>
+            <a:ext cx="2441448" cy="603504"/>
           </a:xfrm>
           <a:prstGeom prst="rect">
             <a:avLst/>
@@ -24963,11 +24963,11 @@
           <a:p>
             <a:pPr>
               <a:spcAft>
-                <a:spcPts val="300"/>
+                <a:spcPts val="200"/>
               </a:spcAft>
             </a:pPr>
             <a:r>
-              <a:rPr sz="800">
+              <a:rPr sz="700">
                 <a:solidFill>
                   <a:srgbClr val="78716C"/>
                 </a:solidFill>
@@ -24986,8 +24986,8 @@
         </p:nvSpPr>
         <p:spPr>
           <a:xfrm>
-            <a:off x="384048" y="3840479"/>
-            <a:ext cx="3566160" cy="1261872"/>
+            <a:off x="6108192" y="2432304"/>
+            <a:ext cx="2697480" cy="1261872"/>
           </a:xfrm>
           <a:prstGeom prst="rect">
             <a:avLst/>
@@ -25031,7 +25031,7 @@
         </p:nvSpPr>
         <p:spPr>
           <a:xfrm>
-            <a:off x="384048" y="3840479"/>
+            <a:off x="6108192" y="2432304"/>
             <a:ext cx="50292" cy="1261872"/>
           </a:xfrm>
           <a:prstGeom prst="rect">
@@ -25074,23 +25074,23 @@
         </p:nvSpPr>
         <p:spPr>
           <a:xfrm>
-            <a:off x="548640" y="3931919"/>
-            <a:ext cx="3310128" cy="256032"/>
-          </a:xfrm>
-          <a:prstGeom prst="rect">
-            <a:avLst/>
-          </a:prstGeom>
-          <a:noFill/>
-        </p:spPr>
-        <p:txBody>
-          <a:bodyPr wrap="square">
-            <a:noAutofit/>
-          </a:bodyPr>
-          <a:lstStyle/>
-          <a:p>
-            <a:pPr algn="l"/>
-            <a:r>
-              <a:rPr sz="950" b="1" i="0">
+            <a:off x="6254496" y="2523744"/>
+            <a:ext cx="2478024" cy="365760"/>
+          </a:xfrm>
+          <a:prstGeom prst="rect">
+            <a:avLst/>
+          </a:prstGeom>
+          <a:noFill/>
+        </p:spPr>
+        <p:txBody>
+          <a:bodyPr wrap="square">
+            <a:noAutofit/>
+          </a:bodyPr>
+          <a:lstStyle/>
+          <a:p>
+            <a:pPr algn="l"/>
+            <a:r>
+              <a:rPr sz="900" b="1" i="0">
                 <a:solidFill>
                   <a:srgbClr val="1C1917"/>
                 </a:solidFill>
@@ -25109,23 +25109,23 @@
         </p:nvSpPr>
         <p:spPr>
           <a:xfrm>
-            <a:off x="548640" y="4169663"/>
-            <a:ext cx="1097280" cy="182880"/>
-          </a:xfrm>
-          <a:prstGeom prst="rect">
-            <a:avLst/>
-          </a:prstGeom>
-          <a:noFill/>
-        </p:spPr>
-        <p:txBody>
-          <a:bodyPr wrap="square">
-            <a:noAutofit/>
-          </a:bodyPr>
-          <a:lstStyle/>
-          <a:p>
-            <a:pPr algn="l"/>
-            <a:r>
-              <a:rPr sz="750" b="1" i="0">
+            <a:off x="6254496" y="2852928"/>
+            <a:ext cx="2478024" cy="182880"/>
+          </a:xfrm>
+          <a:prstGeom prst="rect">
+            <a:avLst/>
+          </a:prstGeom>
+          <a:noFill/>
+        </p:spPr>
+        <p:txBody>
+          <a:bodyPr wrap="square">
+            <a:noAutofit/>
+          </a:bodyPr>
+          <a:lstStyle/>
+          <a:p>
+            <a:pPr algn="l"/>
+            <a:r>
+              <a:rPr sz="700" b="1" i="0">
                 <a:solidFill>
                   <a:srgbClr val="C8102E"/>
                 </a:solidFill>
@@ -25144,8 +25144,8 @@
         </p:nvSpPr>
         <p:spPr>
           <a:xfrm>
-            <a:off x="548640" y="4343399"/>
-            <a:ext cx="3291840" cy="713232"/>
+            <a:off x="6254496" y="3035808"/>
+            <a:ext cx="2441448" cy="603504"/>
           </a:xfrm>
           <a:prstGeom prst="rect">
             <a:avLst/>
@@ -25160,11 +25160,11 @@
           <a:p>
             <a:pPr>
               <a:spcAft>
-                <a:spcPts val="300"/>
+                <a:spcPts val="200"/>
               </a:spcAft>
             </a:pPr>
             <a:r>
-              <a:rPr sz="800">
+              <a:rPr sz="700">
                 <a:solidFill>
                   <a:srgbClr val="78716C"/>
                 </a:solidFill>
@@ -25183,8 +25183,8 @@
         </p:nvSpPr>
         <p:spPr>
           <a:xfrm>
-            <a:off x="4123944" y="3840479"/>
-            <a:ext cx="3566160" cy="1261872"/>
+            <a:off x="8970264" y="2432304"/>
+            <a:ext cx="2697480" cy="1261872"/>
           </a:xfrm>
           <a:prstGeom prst="rect">
             <a:avLst/>
@@ -25228,7 +25228,7 @@
         </p:nvSpPr>
         <p:spPr>
           <a:xfrm>
-            <a:off x="4123944" y="3840479"/>
+            <a:off x="8970264" y="2432304"/>
             <a:ext cx="50292" cy="1261872"/>
           </a:xfrm>
           <a:prstGeom prst="rect">
@@ -25271,23 +25271,23 @@
         </p:nvSpPr>
         <p:spPr>
           <a:xfrm>
-            <a:off x="4288536" y="3931919"/>
-            <a:ext cx="3310128" cy="256032"/>
-          </a:xfrm>
-          <a:prstGeom prst="rect">
-            <a:avLst/>
-          </a:prstGeom>
-          <a:noFill/>
-        </p:spPr>
-        <p:txBody>
-          <a:bodyPr wrap="square">
-            <a:noAutofit/>
-          </a:bodyPr>
-          <a:lstStyle/>
-          <a:p>
-            <a:pPr algn="l"/>
-            <a:r>
-              <a:rPr sz="950" b="1" i="0">
+            <a:off x="9116568" y="2523744"/>
+            <a:ext cx="2478024" cy="365760"/>
+          </a:xfrm>
+          <a:prstGeom prst="rect">
+            <a:avLst/>
+          </a:prstGeom>
+          <a:noFill/>
+        </p:spPr>
+        <p:txBody>
+          <a:bodyPr wrap="square">
+            <a:noAutofit/>
+          </a:bodyPr>
+          <a:lstStyle/>
+          <a:p>
+            <a:pPr algn="l"/>
+            <a:r>
+              <a:rPr sz="900" b="1" i="0">
                 <a:solidFill>
                   <a:srgbClr val="1C1917"/>
                 </a:solidFill>
@@ -25306,23 +25306,23 @@
         </p:nvSpPr>
         <p:spPr>
           <a:xfrm>
-            <a:off x="4288536" y="4169663"/>
-            <a:ext cx="1097280" cy="182880"/>
-          </a:xfrm>
-          <a:prstGeom prst="rect">
-            <a:avLst/>
-          </a:prstGeom>
-          <a:noFill/>
-        </p:spPr>
-        <p:txBody>
-          <a:bodyPr wrap="square">
-            <a:noAutofit/>
-          </a:bodyPr>
-          <a:lstStyle/>
-          <a:p>
-            <a:pPr algn="l"/>
-            <a:r>
-              <a:rPr sz="750" b="1" i="0">
+            <a:off x="9116568" y="2852928"/>
+            <a:ext cx="2478024" cy="182880"/>
+          </a:xfrm>
+          <a:prstGeom prst="rect">
+            <a:avLst/>
+          </a:prstGeom>
+          <a:noFill/>
+        </p:spPr>
+        <p:txBody>
+          <a:bodyPr wrap="square">
+            <a:noAutofit/>
+          </a:bodyPr>
+          <a:lstStyle/>
+          <a:p>
+            <a:pPr algn="l"/>
+            <a:r>
+              <a:rPr sz="700" b="1" i="0">
                 <a:solidFill>
                   <a:srgbClr val="C8102E"/>
                 </a:solidFill>
@@ -25341,8 +25341,8 @@
         </p:nvSpPr>
         <p:spPr>
           <a:xfrm>
-            <a:off x="4288536" y="4343399"/>
-            <a:ext cx="3291840" cy="713232"/>
+            <a:off x="9116568" y="3035808"/>
+            <a:ext cx="2441448" cy="603504"/>
           </a:xfrm>
           <a:prstGeom prst="rect">
             <a:avLst/>
@@ -25357,11 +25357,11 @@
           <a:p>
             <a:pPr>
               <a:spcAft>
-                <a:spcPts val="300"/>
+                <a:spcPts val="200"/>
               </a:spcAft>
             </a:pPr>
             <a:r>
-              <a:rPr sz="800">
+              <a:rPr sz="700">
                 <a:solidFill>
                   <a:srgbClr val="78716C"/>
                 </a:solidFill>
@@ -25380,8 +25380,8 @@
         </p:nvSpPr>
         <p:spPr>
           <a:xfrm>
-            <a:off x="7863840" y="3840479"/>
-            <a:ext cx="3566160" cy="1261872"/>
+            <a:off x="384048" y="3840479"/>
+            <a:ext cx="2697480" cy="1261872"/>
           </a:xfrm>
           <a:prstGeom prst="rect">
             <a:avLst/>
@@ -25425,7 +25425,7 @@
         </p:nvSpPr>
         <p:spPr>
           <a:xfrm>
-            <a:off x="7863840" y="3840479"/>
+            <a:off x="384048" y="3840479"/>
             <a:ext cx="50292" cy="1261872"/>
           </a:xfrm>
           <a:prstGeom prst="rect">
@@ -25468,23 +25468,23 @@
         </p:nvSpPr>
         <p:spPr>
           <a:xfrm>
-            <a:off x="8028431" y="3931919"/>
-            <a:ext cx="3310128" cy="256032"/>
-          </a:xfrm>
-          <a:prstGeom prst="rect">
-            <a:avLst/>
-          </a:prstGeom>
-          <a:noFill/>
-        </p:spPr>
-        <p:txBody>
-          <a:bodyPr wrap="square">
-            <a:noAutofit/>
-          </a:bodyPr>
-          <a:lstStyle/>
-          <a:p>
-            <a:pPr algn="l"/>
-            <a:r>
-              <a:rPr sz="950" b="1" i="0">
+            <a:off x="530352" y="3931919"/>
+            <a:ext cx="2478024" cy="365760"/>
+          </a:xfrm>
+          <a:prstGeom prst="rect">
+            <a:avLst/>
+          </a:prstGeom>
+          <a:noFill/>
+        </p:spPr>
+        <p:txBody>
+          <a:bodyPr wrap="square">
+            <a:noAutofit/>
+          </a:bodyPr>
+          <a:lstStyle/>
+          <a:p>
+            <a:pPr algn="l"/>
+            <a:r>
+              <a:rPr sz="900" b="1" i="0">
                 <a:solidFill>
                   <a:srgbClr val="1C1917"/>
                 </a:solidFill>
@@ -25503,23 +25503,23 @@
         </p:nvSpPr>
         <p:spPr>
           <a:xfrm>
-            <a:off x="8028431" y="4169663"/>
-            <a:ext cx="1097280" cy="182880"/>
-          </a:xfrm>
-          <a:prstGeom prst="rect">
-            <a:avLst/>
-          </a:prstGeom>
-          <a:noFill/>
-        </p:spPr>
-        <p:txBody>
-          <a:bodyPr wrap="square">
-            <a:noAutofit/>
-          </a:bodyPr>
-          <a:lstStyle/>
-          <a:p>
-            <a:pPr algn="l"/>
-            <a:r>
-              <a:rPr sz="750" b="1" i="0">
+            <a:off x="530352" y="4261103"/>
+            <a:ext cx="2478024" cy="182880"/>
+          </a:xfrm>
+          <a:prstGeom prst="rect">
+            <a:avLst/>
+          </a:prstGeom>
+          <a:noFill/>
+        </p:spPr>
+        <p:txBody>
+          <a:bodyPr wrap="square">
+            <a:noAutofit/>
+          </a:bodyPr>
+          <a:lstStyle/>
+          <a:p>
+            <a:pPr algn="l"/>
+            <a:r>
+              <a:rPr sz="700" b="1" i="0">
                 <a:solidFill>
                   <a:srgbClr val="C8102E"/>
                 </a:solidFill>
@@ -25538,8 +25538,8 @@
         </p:nvSpPr>
         <p:spPr>
           <a:xfrm>
-            <a:off x="8028431" y="4343399"/>
-            <a:ext cx="3291840" cy="713232"/>
+            <a:off x="530352" y="4443983"/>
+            <a:ext cx="2441448" cy="603504"/>
           </a:xfrm>
           <a:prstGeom prst="rect">
             <a:avLst/>
@@ -25554,11 +25554,11 @@
           <a:p>
             <a:pPr>
               <a:spcAft>
-                <a:spcPts val="300"/>
+                <a:spcPts val="200"/>
               </a:spcAft>
             </a:pPr>
             <a:r>
-              <a:rPr sz="800">
+              <a:rPr sz="700">
                 <a:solidFill>
                   <a:srgbClr val="78716C"/>
                 </a:solidFill>
@@ -25577,8 +25577,8 @@
         </p:nvSpPr>
         <p:spPr>
           <a:xfrm>
-            <a:off x="384048" y="5248655"/>
-            <a:ext cx="3566160" cy="1261872"/>
+            <a:off x="3246120" y="3840479"/>
+            <a:ext cx="2697480" cy="1261872"/>
           </a:xfrm>
           <a:prstGeom prst="rect">
             <a:avLst/>
@@ -25622,7 +25622,7 @@
         </p:nvSpPr>
         <p:spPr>
           <a:xfrm>
-            <a:off x="384048" y="5248655"/>
+            <a:off x="3246120" y="3840479"/>
             <a:ext cx="50292" cy="1261872"/>
           </a:xfrm>
           <a:prstGeom prst="rect">
@@ -25665,23 +25665,23 @@
         </p:nvSpPr>
         <p:spPr>
           <a:xfrm>
-            <a:off x="548640" y="5340095"/>
-            <a:ext cx="3310128" cy="256032"/>
-          </a:xfrm>
-          <a:prstGeom prst="rect">
-            <a:avLst/>
-          </a:prstGeom>
-          <a:noFill/>
-        </p:spPr>
-        <p:txBody>
-          <a:bodyPr wrap="square">
-            <a:noAutofit/>
-          </a:bodyPr>
-          <a:lstStyle/>
-          <a:p>
-            <a:pPr algn="l"/>
-            <a:r>
-              <a:rPr sz="950" b="1" i="0">
+            <a:off x="3392424" y="3931919"/>
+            <a:ext cx="2478024" cy="365760"/>
+          </a:xfrm>
+          <a:prstGeom prst="rect">
+            <a:avLst/>
+          </a:prstGeom>
+          <a:noFill/>
+        </p:spPr>
+        <p:txBody>
+          <a:bodyPr wrap="square">
+            <a:noAutofit/>
+          </a:bodyPr>
+          <a:lstStyle/>
+          <a:p>
+            <a:pPr algn="l"/>
+            <a:r>
+              <a:rPr sz="900" b="1" i="0">
                 <a:solidFill>
                   <a:srgbClr val="1C1917"/>
                 </a:solidFill>
@@ -25700,23 +25700,23 @@
         </p:nvSpPr>
         <p:spPr>
           <a:xfrm>
-            <a:off x="548640" y="5577840"/>
-            <a:ext cx="1097280" cy="182880"/>
-          </a:xfrm>
-          <a:prstGeom prst="rect">
-            <a:avLst/>
-          </a:prstGeom>
-          <a:noFill/>
-        </p:spPr>
-        <p:txBody>
-          <a:bodyPr wrap="square">
-            <a:noAutofit/>
-          </a:bodyPr>
-          <a:lstStyle/>
-          <a:p>
-            <a:pPr algn="l"/>
-            <a:r>
-              <a:rPr sz="750" b="1" i="0">
+            <a:off x="3392424" y="4261103"/>
+            <a:ext cx="2478024" cy="182880"/>
+          </a:xfrm>
+          <a:prstGeom prst="rect">
+            <a:avLst/>
+          </a:prstGeom>
+          <a:noFill/>
+        </p:spPr>
+        <p:txBody>
+          <a:bodyPr wrap="square">
+            <a:noAutofit/>
+          </a:bodyPr>
+          <a:lstStyle/>
+          <a:p>
+            <a:pPr algn="l"/>
+            <a:r>
+              <a:rPr sz="700" b="1" i="0">
                 <a:solidFill>
                   <a:srgbClr val="C8102E"/>
                 </a:solidFill>
@@ -25735,8 +25735,8 @@
         </p:nvSpPr>
         <p:spPr>
           <a:xfrm>
-            <a:off x="548640" y="5751575"/>
-            <a:ext cx="3291840" cy="713232"/>
+            <a:off x="3392424" y="4443983"/>
+            <a:ext cx="2441448" cy="603504"/>
           </a:xfrm>
           <a:prstGeom prst="rect">
             <a:avLst/>
@@ -25751,11 +25751,11 @@
           <a:p>
             <a:pPr>
               <a:spcAft>
-                <a:spcPts val="300"/>
+                <a:spcPts val="200"/>
               </a:spcAft>
             </a:pPr>
             <a:r>
-              <a:rPr sz="800">
+              <a:rPr sz="700">
                 <a:solidFill>
                   <a:srgbClr val="78716C"/>
                 </a:solidFill>
@@ -25774,8 +25774,8 @@
         </p:nvSpPr>
         <p:spPr>
           <a:xfrm>
-            <a:off x="4123944" y="5248655"/>
-            <a:ext cx="3566160" cy="1261872"/>
+            <a:off x="6108192" y="3840479"/>
+            <a:ext cx="2697480" cy="1261872"/>
           </a:xfrm>
           <a:prstGeom prst="rect">
             <a:avLst/>
@@ -25819,7 +25819,7 @@
         </p:nvSpPr>
         <p:spPr>
           <a:xfrm>
-            <a:off x="4123944" y="5248655"/>
+            <a:off x="6108192" y="3840479"/>
             <a:ext cx="50292" cy="1261872"/>
           </a:xfrm>
           <a:prstGeom prst="rect">
@@ -25862,23 +25862,23 @@
         </p:nvSpPr>
         <p:spPr>
           <a:xfrm>
-            <a:off x="4288536" y="5340095"/>
-            <a:ext cx="3310128" cy="256032"/>
-          </a:xfrm>
-          <a:prstGeom prst="rect">
-            <a:avLst/>
-          </a:prstGeom>
-          <a:noFill/>
-        </p:spPr>
-        <p:txBody>
-          <a:bodyPr wrap="square">
-            <a:noAutofit/>
-          </a:bodyPr>
-          <a:lstStyle/>
-          <a:p>
-            <a:pPr algn="l"/>
-            <a:r>
-              <a:rPr sz="950" b="1" i="0">
+            <a:off x="6254496" y="3931919"/>
+            <a:ext cx="2478024" cy="365760"/>
+          </a:xfrm>
+          <a:prstGeom prst="rect">
+            <a:avLst/>
+          </a:prstGeom>
+          <a:noFill/>
+        </p:spPr>
+        <p:txBody>
+          <a:bodyPr wrap="square">
+            <a:noAutofit/>
+          </a:bodyPr>
+          <a:lstStyle/>
+          <a:p>
+            <a:pPr algn="l"/>
+            <a:r>
+              <a:rPr sz="900" b="1" i="0">
                 <a:solidFill>
                   <a:srgbClr val="1C1917"/>
                 </a:solidFill>
@@ -25897,23 +25897,23 @@
         </p:nvSpPr>
         <p:spPr>
           <a:xfrm>
-            <a:off x="4288536" y="5577840"/>
-            <a:ext cx="1097280" cy="182880"/>
-          </a:xfrm>
-          <a:prstGeom prst="rect">
-            <a:avLst/>
-          </a:prstGeom>
-          <a:noFill/>
-        </p:spPr>
-        <p:txBody>
-          <a:bodyPr wrap="square">
-            <a:noAutofit/>
-          </a:bodyPr>
-          <a:lstStyle/>
-          <a:p>
-            <a:pPr algn="l"/>
-            <a:r>
-              <a:rPr sz="750" b="1" i="0">
+            <a:off x="6254496" y="4261103"/>
+            <a:ext cx="2478024" cy="182880"/>
+          </a:xfrm>
+          <a:prstGeom prst="rect">
+            <a:avLst/>
+          </a:prstGeom>
+          <a:noFill/>
+        </p:spPr>
+        <p:txBody>
+          <a:bodyPr wrap="square">
+            <a:noAutofit/>
+          </a:bodyPr>
+          <a:lstStyle/>
+          <a:p>
+            <a:pPr algn="l"/>
+            <a:r>
+              <a:rPr sz="700" b="1" i="0">
                 <a:solidFill>
                   <a:srgbClr val="C8102E"/>
                 </a:solidFill>
@@ -25932,8 +25932,8 @@
         </p:nvSpPr>
         <p:spPr>
           <a:xfrm>
-            <a:off x="4288536" y="5751575"/>
-            <a:ext cx="3291840" cy="713232"/>
+            <a:off x="6254496" y="4443983"/>
+            <a:ext cx="2441448" cy="603504"/>
           </a:xfrm>
           <a:prstGeom prst="rect">
             <a:avLst/>
@@ -25948,17 +25948,17 @@
           <a:p>
             <a:pPr>
               <a:spcAft>
-                <a:spcPts val="300"/>
+                <a:spcPts val="200"/>
               </a:spcAft>
             </a:pPr>
             <a:r>
-              <a:rPr sz="800">
+              <a:rPr sz="700">
                 <a:solidFill>
                   <a:srgbClr val="78716C"/>
                 </a:solidFill>
                 <a:latin typeface="Calibri"/>
               </a:rPr>
-              <a:t>Amount + currency + IBAN + beneficiary → live rate + FCA fee disclosure (Consumer Rights Act 2015) → biometric confirm. 5 currencies: EUR/USD/CHF/AUD/CAD. MLR 2017 screening flag ≥£50k. SWIFT ref to audit trail.</a:t>
+              <a:t>Amount + currency + IBAN + beneficiary → live rate + FCA fee disclosure → biometric confirm. 5 currencies (EUR/USD/CHF/AUD/CAD). MLR 2017 screening flag ≥£50k. SWIFT ref to audit trail.</a:t>
             </a:r>
           </a:p>
         </p:txBody>
@@ -25971,8 +25971,8 @@
         </p:nvSpPr>
         <p:spPr>
           <a:xfrm>
-            <a:off x="7863840" y="5248655"/>
-            <a:ext cx="3566160" cy="1261872"/>
+            <a:off x="8970264" y="3840479"/>
+            <a:ext cx="2697480" cy="1261872"/>
           </a:xfrm>
           <a:prstGeom prst="rect">
             <a:avLst/>
@@ -26016,7 +26016,7 @@
         </p:nvSpPr>
         <p:spPr>
           <a:xfrm>
-            <a:off x="7863840" y="5248655"/>
+            <a:off x="8970264" y="3840479"/>
             <a:ext cx="50292" cy="1261872"/>
           </a:xfrm>
           <a:prstGeom prst="rect">
@@ -26059,29 +26059,29 @@
         </p:nvSpPr>
         <p:spPr>
           <a:xfrm>
-            <a:off x="8028431" y="5340095"/>
-            <a:ext cx="3310128" cy="256032"/>
-          </a:xfrm>
-          <a:prstGeom prst="rect">
-            <a:avLst/>
-          </a:prstGeom>
-          <a:noFill/>
-        </p:spPr>
-        <p:txBody>
-          <a:bodyPr wrap="square">
-            <a:noAutofit/>
-          </a:bodyPr>
-          <a:lstStyle/>
-          <a:p>
-            <a:pPr algn="l"/>
-            <a:r>
-              <a:rPr sz="950" b="1" i="0">
+            <a:off x="9116568" y="3931919"/>
+            <a:ext cx="2478024" cy="365760"/>
+          </a:xfrm>
+          <a:prstGeom prst="rect">
+            <a:avLst/>
+          </a:prstGeom>
+          <a:noFill/>
+        </p:spPr>
+        <p:txBody>
+          <a:bodyPr wrap="square">
+            <a:noAutofit/>
+          </a:bodyPr>
+          <a:lstStyle/>
+          <a:p>
+            <a:pPr algn="l"/>
+            <a:r>
+              <a:rPr sz="900" b="1" i="0">
                 <a:solidFill>
                   <a:srgbClr val="1C1917"/>
                 </a:solidFill>
                 <a:latin typeface="Calibri"/>
               </a:rPr>
-              <a:t>Complaint Handling</a:t>
+              <a:t>Standing Orders &amp; Direct Debits</a:t>
             </a:r>
           </a:p>
         </p:txBody>
@@ -26094,29 +26094,29 @@
         </p:nvSpPr>
         <p:spPr>
           <a:xfrm>
-            <a:off x="8028431" y="5577840"/>
-            <a:ext cx="1097280" cy="182880"/>
-          </a:xfrm>
-          <a:prstGeom prst="rect">
-            <a:avLst/>
-          </a:prstGeom>
-          <a:noFill/>
-        </p:spPr>
-        <p:txBody>
-          <a:bodyPr wrap="square">
-            <a:noAutofit/>
-          </a:bodyPr>
-          <a:lstStyle/>
-          <a:p>
-            <a:pPr algn="l"/>
-            <a:r>
-              <a:rPr sz="750" b="1" i="0">
+            <a:off x="9116568" y="4261103"/>
+            <a:ext cx="2478024" cy="182880"/>
+          </a:xfrm>
+          <a:prstGeom prst="rect">
+            <a:avLst/>
+          </a:prstGeom>
+          <a:noFill/>
+        </p:spPr>
+        <p:txBody>
+          <a:bodyPr wrap="square">
+            <a:noAutofit/>
+          </a:bodyPr>
+          <a:lstStyle/>
+          <a:p>
+            <a:pPr algn="l"/>
+            <a:r>
+              <a:rPr sz="700" b="1" i="0">
                 <a:solidFill>
                   <a:srgbClr val="C8102E"/>
                 </a:solidFill>
                 <a:latin typeface="Calibri"/>
               </a:rPr>
-              <a:t>4 steps</a:t>
+              <a:t>up to 3 steps</a:t>
             </a:r>
           </a:p>
         </p:txBody>
@@ -26129,8 +26129,8 @@
         </p:nvSpPr>
         <p:spPr>
           <a:xfrm>
-            <a:off x="8028431" y="5751575"/>
-            <a:ext cx="3291840" cy="713232"/>
+            <a:off x="9116568" y="4443983"/>
+            <a:ext cx="2441448" cy="603504"/>
           </a:xfrm>
           <a:prstGeom prst="rect">
             <a:avLst/>
@@ -26145,17 +26145,17 @@
           <a:p>
             <a:pPr>
               <a:spcAft>
-                <a:spcPts val="300"/>
+                <a:spcPts val="200"/>
               </a:spcAft>
             </a:pPr>
             <a:r>
-              <a:rPr sz="800">
+              <a:rPr sz="700">
                 <a:solidFill>
                   <a:srgbClr val="78716C"/>
                 </a:solidFill>
                 <a:latin typeface="Calibri"/>
               </a:rPr>
-              <a:t>Intake → escalation triage → denial → case outcome. FCA DISP-compliant. Eligible complainant check (DISP 2.7), escalation flag selection, denial reason, optional goodwill gesture. Triggers from Home screen Log complaint tile.</a:t>
+              <a:t>Overview of active DDs (Guarantee-protected) and standing orders → set up a standing order (payee + CoP, amount, frequency, start date) or cancel a Direct Debit under the Direct Debit Guarantee.</a:t>
             </a:r>
           </a:p>
         </p:txBody>
@@ -26163,6 +26163,203 @@
       <p:sp>
         <p:nvSpPr>
           <p:cNvPr id="67" name="Rectangle 66"/>
+          <p:cNvSpPr/>
+          <p:nvPr/>
+        </p:nvSpPr>
+        <p:spPr>
+          <a:xfrm>
+            <a:off x="384048" y="5248655"/>
+            <a:ext cx="2697480" cy="1261872"/>
+          </a:xfrm>
+          <a:prstGeom prst="rect">
+            <a:avLst/>
+          </a:prstGeom>
+          <a:solidFill>
+            <a:srgbClr val="FFFFFF"/>
+          </a:solidFill>
+          <a:ln w="9525">
+            <a:solidFill>
+              <a:srgbClr val="E7E5E4"/>
+            </a:solidFill>
+          </a:ln>
+        </p:spPr>
+        <p:style>
+          <a:lnRef idx="1">
+            <a:schemeClr val="accent1"/>
+          </a:lnRef>
+          <a:fillRef idx="3">
+            <a:schemeClr val="accent1"/>
+          </a:fillRef>
+          <a:effectRef idx="2">
+            <a:schemeClr val="accent1"/>
+          </a:effectRef>
+          <a:fontRef idx="minor">
+            <a:schemeClr val="lt1"/>
+          </a:fontRef>
+        </p:style>
+        <p:txBody>
+          <a:bodyPr rtlCol="0" anchor="ctr"/>
+          <a:lstStyle/>
+          <a:p>
+            <a:pPr algn="ctr"/>
+          </a:p>
+        </p:txBody>
+      </p:sp>
+      <p:sp>
+        <p:nvSpPr>
+          <p:cNvPr id="68" name="Rectangle 67"/>
+          <p:cNvSpPr/>
+          <p:nvPr/>
+        </p:nvSpPr>
+        <p:spPr>
+          <a:xfrm>
+            <a:off x="384048" y="5248655"/>
+            <a:ext cx="50292" cy="1261872"/>
+          </a:xfrm>
+          <a:prstGeom prst="rect">
+            <a:avLst/>
+          </a:prstGeom>
+          <a:solidFill>
+            <a:srgbClr val="C8102E"/>
+          </a:solidFill>
+          <a:ln>
+            <a:noFill/>
+          </a:ln>
+        </p:spPr>
+        <p:style>
+          <a:lnRef idx="1">
+            <a:schemeClr val="accent1"/>
+          </a:lnRef>
+          <a:fillRef idx="3">
+            <a:schemeClr val="accent1"/>
+          </a:fillRef>
+          <a:effectRef idx="2">
+            <a:schemeClr val="accent1"/>
+          </a:effectRef>
+          <a:fontRef idx="minor">
+            <a:schemeClr val="lt1"/>
+          </a:fontRef>
+        </p:style>
+        <p:txBody>
+          <a:bodyPr rtlCol="0" anchor="ctr"/>
+          <a:lstStyle/>
+          <a:p>
+            <a:pPr algn="ctr"/>
+          </a:p>
+        </p:txBody>
+      </p:sp>
+      <p:sp>
+        <p:nvSpPr>
+          <p:cNvPr id="69" name="TextBox 68"/>
+          <p:cNvSpPr txBox="1"/>
+          <p:nvPr/>
+        </p:nvSpPr>
+        <p:spPr>
+          <a:xfrm>
+            <a:off x="530352" y="5340095"/>
+            <a:ext cx="2478024" cy="365760"/>
+          </a:xfrm>
+          <a:prstGeom prst="rect">
+            <a:avLst/>
+          </a:prstGeom>
+          <a:noFill/>
+        </p:spPr>
+        <p:txBody>
+          <a:bodyPr wrap="square">
+            <a:noAutofit/>
+          </a:bodyPr>
+          <a:lstStyle/>
+          <a:p>
+            <a:pPr algn="l"/>
+            <a:r>
+              <a:rPr sz="900" b="1" i="0">
+                <a:solidFill>
+                  <a:srgbClr val="1C1917"/>
+                </a:solidFill>
+                <a:latin typeface="Calibri"/>
+              </a:rPr>
+              <a:t>Complaint Handling</a:t>
+            </a:r>
+          </a:p>
+        </p:txBody>
+      </p:sp>
+      <p:sp>
+        <p:nvSpPr>
+          <p:cNvPr id="70" name="TextBox 69"/>
+          <p:cNvSpPr txBox="1"/>
+          <p:nvPr/>
+        </p:nvSpPr>
+        <p:spPr>
+          <a:xfrm>
+            <a:off x="530352" y="5669279"/>
+            <a:ext cx="2478024" cy="182880"/>
+          </a:xfrm>
+          <a:prstGeom prst="rect">
+            <a:avLst/>
+          </a:prstGeom>
+          <a:noFill/>
+        </p:spPr>
+        <p:txBody>
+          <a:bodyPr wrap="square">
+            <a:noAutofit/>
+          </a:bodyPr>
+          <a:lstStyle/>
+          <a:p>
+            <a:pPr algn="l"/>
+            <a:r>
+              <a:rPr sz="700" b="1" i="0">
+                <a:solidFill>
+                  <a:srgbClr val="C8102E"/>
+                </a:solidFill>
+                <a:latin typeface="Calibri"/>
+              </a:rPr>
+              <a:t>4 steps</a:t>
+            </a:r>
+          </a:p>
+        </p:txBody>
+      </p:sp>
+      <p:sp>
+        <p:nvSpPr>
+          <p:cNvPr id="71" name="TextBox 70"/>
+          <p:cNvSpPr txBox="1"/>
+          <p:nvPr/>
+        </p:nvSpPr>
+        <p:spPr>
+          <a:xfrm>
+            <a:off x="530352" y="5852159"/>
+            <a:ext cx="2441448" cy="603504"/>
+          </a:xfrm>
+          <a:prstGeom prst="rect">
+            <a:avLst/>
+          </a:prstGeom>
+          <a:noFill/>
+        </p:spPr>
+        <p:txBody>
+          <a:bodyPr wrap="square">
+            <a:noAutofit/>
+          </a:bodyPr>
+          <a:lstStyle/>
+          <a:p>
+            <a:pPr>
+              <a:spcAft>
+                <a:spcPts val="200"/>
+              </a:spcAft>
+            </a:pPr>
+            <a:r>
+              <a:rPr sz="700">
+                <a:solidFill>
+                  <a:srgbClr val="78716C"/>
+                </a:solidFill>
+                <a:latin typeface="Calibri"/>
+              </a:rPr>
+              <a:t>Intake → escalation triage → denial → case outcome. FCA DISP-compliant. Eligible-complainant check (DISP 2.7), escalation flags, denial reason, optional goodwill. From the Log complaint tile.</a:t>
+            </a:r>
+          </a:p>
+        </p:txBody>
+      </p:sp>
+      <p:sp>
+        <p:nvSpPr>
+          <p:cNvPr id="72" name="Rectangle 71"/>
           <p:cNvSpPr/>
           <p:nvPr/>
         </p:nvSpPr>
@@ -26205,7 +26402,7 @@
       </p:sp>
       <p:sp>
         <p:nvSpPr>
-          <p:cNvPr id="68" name="TextBox 67"/>
+          <p:cNvPr id="73" name="TextBox 72"/>
           <p:cNvSpPr txBox="1"/>
           <p:nvPr/>
         </p:nvSpPr>
@@ -26240,7 +26437,7 @@
       </p:sp>
       <p:sp>
         <p:nvSpPr>
-          <p:cNvPr id="69" name="TextBox 68"/>
+          <p:cNvPr id="74" name="TextBox 73"/>
           <p:cNvSpPr txBox="1"/>
           <p:nvPr/>
         </p:nvSpPr>
@@ -26275,7 +26472,7 @@
       </p:sp>
       <p:sp>
         <p:nvSpPr>
-          <p:cNvPr id="70" name="TextBox 69"/>
+          <p:cNvPr id="75" name="TextBox 74"/>
           <p:cNvSpPr txBox="1"/>
           <p:nvPr/>
         </p:nvSpPr>

</xml_diff>